<commit_message>
chore(outputs): add beta PPTX final (rail KYC + connaissance client), guide-orateur and sources docs
</commit_message>
<xml_diff>
--- a/outputs/manual-20260602-veripass-executive-stage-beta/presentations/veripass-executive-stage-beta/output/veripass-rail-kyc-souverain-beta-interne-bicec.pptx
+++ b/outputs/manual-20260602-veripass-executive-stage-beta/presentations/veripass-executive-stage-beta/output/veripass-rail-kyc-souverain-beta-interne-bicec.pptx
@@ -2,24 +2,24 @@
 <file path=ppt/presentation.xml><?xml version="1.0" encoding="utf-8"?>
 <p:presentation xmlns:p="http://schemas.openxmlformats.org/presentationml/2006/main">
   <p:sldMasterIdLst>
-    <p:sldMasterId xmlns:r="http://schemas.openxmlformats.org/officeDocument/2006/relationships" id="2147483648" r:id="R2ef0c407efb24a97"/>
+    <p:sldMasterId xmlns:r="http://schemas.openxmlformats.org/officeDocument/2006/relationships" id="2147483648" r:id="R0adfe561fc2a46e0"/>
   </p:sldMasterIdLst>
   <p:notesMasterIdLst>
-    <p:notesMasterId xmlns:r="http://schemas.openxmlformats.org/officeDocument/2006/relationships" r:id="R380d18e31e8041e0"/>
+    <p:notesMasterId xmlns:r="http://schemas.openxmlformats.org/officeDocument/2006/relationships" r:id="R9271456aa75e4ad5"/>
   </p:notesMasterIdLst>
   <p:sldIdLst>
-    <p:sldId xmlns:r="http://schemas.openxmlformats.org/officeDocument/2006/relationships" id="256" r:id="R25e3d1d825ff49ad"/>
-    <p:sldId xmlns:r="http://schemas.openxmlformats.org/officeDocument/2006/relationships" id="257" r:id="Rf5eedbb2c04445a3"/>
-    <p:sldId xmlns:r="http://schemas.openxmlformats.org/officeDocument/2006/relationships" id="258" r:id="R710de2b83e88455a"/>
-    <p:sldId xmlns:r="http://schemas.openxmlformats.org/officeDocument/2006/relationships" id="259" r:id="R4a4cb4a8ec8148b1"/>
-    <p:sldId xmlns:r="http://schemas.openxmlformats.org/officeDocument/2006/relationships" id="260" r:id="Rcaa844ed7b194417"/>
-    <p:sldId xmlns:r="http://schemas.openxmlformats.org/officeDocument/2006/relationships" id="261" r:id="R3768d0af6de045c7"/>
-    <p:sldId xmlns:r="http://schemas.openxmlformats.org/officeDocument/2006/relationships" id="262" r:id="R376c65a42a804cd6"/>
-    <p:sldId xmlns:r="http://schemas.openxmlformats.org/officeDocument/2006/relationships" id="263" r:id="Rdae0ff43127b4e4d"/>
-    <p:sldId xmlns:r="http://schemas.openxmlformats.org/officeDocument/2006/relationships" id="264" r:id="Rfb14c88b407c486e"/>
-    <p:sldId xmlns:r="http://schemas.openxmlformats.org/officeDocument/2006/relationships" id="265" r:id="R65beda62a4164e3b"/>
-    <p:sldId xmlns:r="http://schemas.openxmlformats.org/officeDocument/2006/relationships" id="266" r:id="R6a53df02f4254678"/>
-    <p:sldId xmlns:r="http://schemas.openxmlformats.org/officeDocument/2006/relationships" id="267" r:id="R076728a6b43040e2"/>
+    <p:sldId xmlns:r="http://schemas.openxmlformats.org/officeDocument/2006/relationships" id="256" r:id="Rc18b86211a67462e"/>
+    <p:sldId xmlns:r="http://schemas.openxmlformats.org/officeDocument/2006/relationships" id="257" r:id="Rce2c3ccb05374d01"/>
+    <p:sldId xmlns:r="http://schemas.openxmlformats.org/officeDocument/2006/relationships" id="258" r:id="R412b3acdb6c04284"/>
+    <p:sldId xmlns:r="http://schemas.openxmlformats.org/officeDocument/2006/relationships" id="259" r:id="Ra499b2d589ba49fb"/>
+    <p:sldId xmlns:r="http://schemas.openxmlformats.org/officeDocument/2006/relationships" id="260" r:id="Ra2c2af4149c84087"/>
+    <p:sldId xmlns:r="http://schemas.openxmlformats.org/officeDocument/2006/relationships" id="261" r:id="Rbe99f8b1e0d64153"/>
+    <p:sldId xmlns:r="http://schemas.openxmlformats.org/officeDocument/2006/relationships" id="262" r:id="R2625a394777e4b80"/>
+    <p:sldId xmlns:r="http://schemas.openxmlformats.org/officeDocument/2006/relationships" id="263" r:id="R6f4b51f1e382485b"/>
+    <p:sldId xmlns:r="http://schemas.openxmlformats.org/officeDocument/2006/relationships" id="264" r:id="Rff15d29f688848de"/>
+    <p:sldId xmlns:r="http://schemas.openxmlformats.org/officeDocument/2006/relationships" id="265" r:id="R0e001f90a51a435d"/>
+    <p:sldId xmlns:r="http://schemas.openxmlformats.org/officeDocument/2006/relationships" id="266" r:id="R6ed13713e4e04388"/>
+    <p:sldId xmlns:r="http://schemas.openxmlformats.org/officeDocument/2006/relationships" id="267" r:id="Rd4d5598d2517449a"/>
   </p:sldIdLst>
   <p:sldSz cx="12192000" cy="6858000"/>
   <p:notesSz cx="6858000" cy="9144000"/>
@@ -1292,7 +1292,7 @@
   </p:cSld>
   <p:clrMap bg1="lt1" tx1="dk1" bg2="lt2" tx2="dk2" accent1="accent1" accent2="accent2" accent3="accent3" accent4="accent4" accent5="accent5" accent6="accent6" hlink="hlink" folHlink="folHlink"/>
   <p:sldLayoutIdLst>
-    <p:sldLayoutId xmlns:r="http://schemas.openxmlformats.org/officeDocument/2006/relationships" id="2147483649" r:id="Re374e2ab1fd74d7f"/>
+    <p:sldLayoutId xmlns:r="http://schemas.openxmlformats.org/officeDocument/2006/relationships" id="2147483649" r:id="R4e411cadf33d4a36"/>
   </p:sldLayoutIdLst>
   <p:txStyles>
     <p:titleStyle>
@@ -1790,7 +1790,7 @@
           <p:cNvPr id="1" name="">
             <a:extLst xmlns:a="http://schemas.openxmlformats.org/drawingml/2006/main">
               <a:ext uri="{FF2B5EF4-FFF2-40B4-BE49-F238E27FC236}">
-                <a16:creationId xmlns:a16="http://schemas.microsoft.com/office/drawing/2014/main" id="{05C2E840-807D-4E72-B31D-C752EC34E12C}"/>
+                <a16:creationId xmlns:a16="http://schemas.microsoft.com/office/drawing/2014/main" id="{5A90A4F7-0872-47D6-AD3A-5B982635B0EC}"/>
               </a:ext>
             </a:extLst>
           </p:cNvPr>
@@ -1825,7 +1825,7 @@
           <p:cNvPr id="2" name="">
             <a:extLst xmlns:a="http://schemas.openxmlformats.org/drawingml/2006/main">
               <a:ext uri="{FF2B5EF4-FFF2-40B4-BE49-F238E27FC236}">
-                <a16:creationId xmlns:a16="http://schemas.microsoft.com/office/drawing/2014/main" id="{3845FDA2-01CE-4683-9696-A81A8102E47C}"/>
+                <a16:creationId xmlns:a16="http://schemas.microsoft.com/office/drawing/2014/main" id="{8D1C4867-30FF-45D5-886F-9D033A5C131E}"/>
               </a:ext>
             </a:extLst>
           </p:cNvPr>
@@ -1860,7 +1860,7 @@
           <p:cNvPr id="3" name="">
             <a:extLst xmlns:a="http://schemas.openxmlformats.org/drawingml/2006/main">
               <a:ext uri="{FF2B5EF4-FFF2-40B4-BE49-F238E27FC236}">
-                <a16:creationId xmlns:a16="http://schemas.microsoft.com/office/drawing/2014/main" id="{E3AED94B-DAB2-4B28-A0B0-FAA23CF2ECF7}"/>
+                <a16:creationId xmlns:a16="http://schemas.microsoft.com/office/drawing/2014/main" id="{DF7EA277-4E23-4027-98F7-47B574604176}"/>
               </a:ext>
             </a:extLst>
           </p:cNvPr>
@@ -1895,7 +1895,7 @@
           <p:cNvPr id="4" name="">
             <a:extLst xmlns:a="http://schemas.openxmlformats.org/drawingml/2006/main">
               <a:ext uri="{FF2B5EF4-FFF2-40B4-BE49-F238E27FC236}">
-                <a16:creationId xmlns:a16="http://schemas.microsoft.com/office/drawing/2014/main" id="{3D9883CE-0153-4CB4-B44E-777B1BCC0C02}"/>
+                <a16:creationId xmlns:a16="http://schemas.microsoft.com/office/drawing/2014/main" id="{D827AC31-FC10-448C-8A1E-185FACA333B8}"/>
               </a:ext>
             </a:extLst>
           </p:cNvPr>
@@ -1934,7 +1934,7 @@
           <p:nvPr/>
         </p:nvPicPr>
         <p:blipFill>
-          <a:blip xmlns:r="http://schemas.openxmlformats.org/officeDocument/2006/relationships" xmlns:a="http://schemas.openxmlformats.org/drawingml/2006/main" r:embed="Rea90048ac94f4eb9"/>
+          <a:blip xmlns:r="http://schemas.openxmlformats.org/officeDocument/2006/relationships" xmlns:a="http://schemas.openxmlformats.org/drawingml/2006/main" r:embed="R57b809177f374b2e"/>
           <a:stretch xmlns:a="http://schemas.openxmlformats.org/drawingml/2006/main"/>
         </p:blipFill>
         <p:spPr>
@@ -1952,7 +1952,7 @@
           <p:cNvPr id="6" name="">
             <a:extLst xmlns:a="http://schemas.openxmlformats.org/drawingml/2006/main">
               <a:ext uri="{FF2B5EF4-FFF2-40B4-BE49-F238E27FC236}">
-                <a16:creationId xmlns:a16="http://schemas.microsoft.com/office/drawing/2014/main" id="{25C76D43-4290-43DB-AFDD-8909447968AE}"/>
+                <a16:creationId xmlns:a16="http://schemas.microsoft.com/office/drawing/2014/main" id="{DB95848E-62CE-4C28-8066-379ACF3ED9DE}"/>
               </a:ext>
             </a:extLst>
           </p:cNvPr>
@@ -2016,7 +2016,7 @@
           <p:cNvPr id="7" name="">
             <a:extLst xmlns:a="http://schemas.openxmlformats.org/drawingml/2006/main">
               <a:ext uri="{FF2B5EF4-FFF2-40B4-BE49-F238E27FC236}">
-                <a16:creationId xmlns:a16="http://schemas.microsoft.com/office/drawing/2014/main" id="{7340E9A7-8593-4479-8EC0-269151F59F43}"/>
+                <a16:creationId xmlns:a16="http://schemas.microsoft.com/office/drawing/2014/main" id="{6727ED34-A70F-4394-B020-0AE5AF11D35D}"/>
               </a:ext>
             </a:extLst>
           </p:cNvPr>
@@ -2080,7 +2080,7 @@
           <p:cNvPr id="8" name="">
             <a:extLst xmlns:a="http://schemas.openxmlformats.org/drawingml/2006/main">
               <a:ext uri="{FF2B5EF4-FFF2-40B4-BE49-F238E27FC236}">
-                <a16:creationId xmlns:a16="http://schemas.microsoft.com/office/drawing/2014/main" id="{0CC48589-B4B9-4D76-9014-EFF179849950}"/>
+                <a16:creationId xmlns:a16="http://schemas.microsoft.com/office/drawing/2014/main" id="{F4765AD5-6C22-4E82-A627-AAD34DB5F0EA}"/>
               </a:ext>
             </a:extLst>
           </p:cNvPr>
@@ -2144,7 +2144,7 @@
           <p:cNvPr id="9" name="">
             <a:extLst xmlns:a="http://schemas.openxmlformats.org/drawingml/2006/main">
               <a:ext uri="{FF2B5EF4-FFF2-40B4-BE49-F238E27FC236}">
-                <a16:creationId xmlns:a16="http://schemas.microsoft.com/office/drawing/2014/main" id="{FB87F267-F2DB-410A-A26C-8081F1084A4E}"/>
+                <a16:creationId xmlns:a16="http://schemas.microsoft.com/office/drawing/2014/main" id="{2225B99F-0C52-4B16-AED2-18CEE597EE05}"/>
               </a:ext>
             </a:extLst>
           </p:cNvPr>
@@ -2198,7 +2198,7 @@
                 <a:ea typeface="Aptos Display"/>
                 <a:cs typeface="Aptos Display"/>
               </a:rPr>
-              <a:t>Le rail KYC que BICEC peut tester maintenant.</a:t>
+              <a:t>Le socle de connaissance client que BICEC peut tester maintenant.</a:t>
             </a:r>
           </a:p>
         </p:txBody>
@@ -2208,7 +2208,7 @@
           <p:cNvPr id="10" name="">
             <a:extLst xmlns:a="http://schemas.openxmlformats.org/drawingml/2006/main">
               <a:ext uri="{FF2B5EF4-FFF2-40B4-BE49-F238E27FC236}">
-                <a16:creationId xmlns:a16="http://schemas.microsoft.com/office/drawing/2014/main" id="{0DAC2B31-F4D3-4384-AE63-E937531850CF}"/>
+                <a16:creationId xmlns:a16="http://schemas.microsoft.com/office/drawing/2014/main" id="{F89D1BED-CC17-4771-9D93-99CF2CE261A4}"/>
               </a:ext>
             </a:extLst>
           </p:cNvPr>
@@ -2262,7 +2262,7 @@
                 <a:ea typeface="Aptos"/>
                 <a:cs typeface="Aptos"/>
               </a:rPr>
-              <a:t>Un MVP fonctionnel pour transformer l'identite client en dossier bancaire controle, auditable et mesurable.</a:t>
+              <a:t>Une version fonctionnelle pour transformer l'identite client en dossier bancaire controle, auditable et mesurable.</a:t>
             </a:r>
           </a:p>
         </p:txBody>
@@ -2272,7 +2272,7 @@
           <p:cNvPr id="11" name="">
             <a:extLst xmlns:a="http://schemas.openxmlformats.org/drawingml/2006/main">
               <a:ext uri="{FF2B5EF4-FFF2-40B4-BE49-F238E27FC236}">
-                <a16:creationId xmlns:a16="http://schemas.microsoft.com/office/drawing/2014/main" id="{3C5AE909-3D66-42E1-9743-CF4C0B2C600B}"/>
+                <a16:creationId xmlns:a16="http://schemas.microsoft.com/office/drawing/2014/main" id="{CA6A749E-CFF3-4F5A-9335-43594D755217}"/>
               </a:ext>
             </a:extLst>
           </p:cNvPr>
@@ -2307,7 +2307,7 @@
           <p:cNvPr id="12" name="">
             <a:extLst xmlns:a="http://schemas.openxmlformats.org/drawingml/2006/main">
               <a:ext uri="{FF2B5EF4-FFF2-40B4-BE49-F238E27FC236}">
-                <a16:creationId xmlns:a16="http://schemas.microsoft.com/office/drawing/2014/main" id="{858FB456-4DAD-431F-8876-207B0B5F05E7}"/>
+                <a16:creationId xmlns:a16="http://schemas.microsoft.com/office/drawing/2014/main" id="{37DA75C5-0493-445C-935C-21D756BF3FCE}"/>
               </a:ext>
             </a:extLst>
           </p:cNvPr>
@@ -2371,7 +2371,7 @@
           <p:cNvPr id="13" name="">
             <a:extLst xmlns:a="http://schemas.openxmlformats.org/drawingml/2006/main">
               <a:ext uri="{FF2B5EF4-FFF2-40B4-BE49-F238E27FC236}">
-                <a16:creationId xmlns:a16="http://schemas.microsoft.com/office/drawing/2014/main" id="{6C5E1BEB-87FE-4678-A585-A6AD24945CD6}"/>
+                <a16:creationId xmlns:a16="http://schemas.microsoft.com/office/drawing/2014/main" id="{436C7F03-63C4-48F3-869F-654AE9B421D5}"/>
               </a:ext>
             </a:extLst>
           </p:cNvPr>
@@ -2435,7 +2435,7 @@
           <p:cNvPr id="14" name="">
             <a:extLst xmlns:a="http://schemas.openxmlformats.org/drawingml/2006/main">
               <a:ext uri="{FF2B5EF4-FFF2-40B4-BE49-F238E27FC236}">
-                <a16:creationId xmlns:a16="http://schemas.microsoft.com/office/drawing/2014/main" id="{E30B6EE8-D900-48F0-A360-D9D1BD2349A6}"/>
+                <a16:creationId xmlns:a16="http://schemas.microsoft.com/office/drawing/2014/main" id="{9257C9E1-279C-4F16-8D62-CFA8BAF815BD}"/>
               </a:ext>
             </a:extLst>
           </p:cNvPr>
@@ -2468,7 +2468,7 @@
           <p:cNvPr id="15" name="">
             <a:extLst xmlns:a="http://schemas.openxmlformats.org/drawingml/2006/main">
               <a:ext uri="{FF2B5EF4-FFF2-40B4-BE49-F238E27FC236}">
-                <a16:creationId xmlns:a16="http://schemas.microsoft.com/office/drawing/2014/main" id="{3D5685AC-9A0D-4101-A5DA-B9B13E79111B}"/>
+                <a16:creationId xmlns:a16="http://schemas.microsoft.com/office/drawing/2014/main" id="{77ED818F-8C99-4EB7-8C5E-45D3646872D3}"/>
               </a:ext>
             </a:extLst>
           </p:cNvPr>
@@ -2505,7 +2505,7 @@
           <p:nvPr/>
         </p:nvPicPr>
         <p:blipFill>
-          <a:blip xmlns:r="http://schemas.openxmlformats.org/officeDocument/2006/relationships" xmlns:a="http://schemas.openxmlformats.org/drawingml/2006/main" r:embed="Rb196b601c9d54d9a"/>
+          <a:blip xmlns:r="http://schemas.openxmlformats.org/officeDocument/2006/relationships" xmlns:a="http://schemas.openxmlformats.org/drawingml/2006/main" r:embed="R595a11dbf9d84d19"/>
           <a:stretch xmlns:a="http://schemas.openxmlformats.org/drawingml/2006/main"/>
         </p:blipFill>
         <p:spPr>
@@ -2523,7 +2523,7 @@
           <p:cNvPr id="17" name="">
             <a:extLst xmlns:a="http://schemas.openxmlformats.org/drawingml/2006/main">
               <a:ext uri="{FF2B5EF4-FFF2-40B4-BE49-F238E27FC236}">
-                <a16:creationId xmlns:a16="http://schemas.microsoft.com/office/drawing/2014/main" id="{029DCD76-9854-40F9-9286-78EB99D8EA60}"/>
+                <a16:creationId xmlns:a16="http://schemas.microsoft.com/office/drawing/2014/main" id="{EF065BC3-203F-43BB-AAB0-126E135267DF}"/>
               </a:ext>
             </a:extLst>
           </p:cNvPr>
@@ -2560,7 +2560,7 @@
           <p:nvPr/>
         </p:nvPicPr>
         <p:blipFill>
-          <a:blip xmlns:r="http://schemas.openxmlformats.org/officeDocument/2006/relationships" xmlns:a="http://schemas.openxmlformats.org/drawingml/2006/main" r:embed="R7bd6565fed74483f"/>
+          <a:blip xmlns:r="http://schemas.openxmlformats.org/officeDocument/2006/relationships" xmlns:a="http://schemas.openxmlformats.org/drawingml/2006/main" r:embed="Rcbe2922c5c064c65"/>
           <a:srcRect xmlns:a="http://schemas.openxmlformats.org/drawingml/2006/main" l="0" t="8798" r="0" b="8798"/>
           <a:stretch xmlns:a="http://schemas.openxmlformats.org/drawingml/2006/main">
             <a:fillRect l="0" t="0" r="0" b="0"/>
@@ -2581,7 +2581,7 @@
           <p:cNvPr id="19" name="">
             <a:extLst xmlns:a="http://schemas.openxmlformats.org/drawingml/2006/main">
               <a:ext uri="{FF2B5EF4-FFF2-40B4-BE49-F238E27FC236}">
-                <a16:creationId xmlns:a16="http://schemas.microsoft.com/office/drawing/2014/main" id="{108BFCE3-90A0-468D-9ACA-57ACA4FA358C}"/>
+                <a16:creationId xmlns:a16="http://schemas.microsoft.com/office/drawing/2014/main" id="{0E833753-F91D-4A4C-B16F-E941CBB8BB43}"/>
               </a:ext>
             </a:extLst>
           </p:cNvPr>
@@ -2616,7 +2616,7 @@
           <p:cNvPr id="20" name="">
             <a:extLst xmlns:a="http://schemas.openxmlformats.org/drawingml/2006/main">
               <a:ext uri="{FF2B5EF4-FFF2-40B4-BE49-F238E27FC236}">
-                <a16:creationId xmlns:a16="http://schemas.microsoft.com/office/drawing/2014/main" id="{15CEF8DC-75D0-44A8-B418-F6EA3B6A1132}"/>
+                <a16:creationId xmlns:a16="http://schemas.microsoft.com/office/drawing/2014/main" id="{A14202FC-743A-47A4-913D-BC67EB0F15C9}"/>
               </a:ext>
             </a:extLst>
           </p:cNvPr>
@@ -2670,7 +2670,7 @@
                 <a:ea typeface="Aptos"/>
                 <a:cs typeface="Aptos"/>
               </a:rPr>
-              <a:t>Preuve visible: le MVP se lance, se teste et se montre.</a:t>
+              <a:t>Preuve visible: elle se lance, se teste et se montre.</a:t>
             </a:r>
           </a:p>
         </p:txBody>
@@ -2680,7 +2680,7 @@
           <p:cNvPr id="21" name="">
             <a:extLst xmlns:a="http://schemas.openxmlformats.org/drawingml/2006/main">
               <a:ext uri="{FF2B5EF4-FFF2-40B4-BE49-F238E27FC236}">
-                <a16:creationId xmlns:a16="http://schemas.microsoft.com/office/drawing/2014/main" id="{F3457951-D213-4E59-ACDF-6A48AFF32CFA}"/>
+                <a16:creationId xmlns:a16="http://schemas.microsoft.com/office/drawing/2014/main" id="{923365C0-A7CF-4656-B7DF-9AEC647BA944}"/>
               </a:ext>
             </a:extLst>
           </p:cNvPr>
@@ -2715,7 +2715,7 @@
           <p:cNvPr id="22" name="">
             <a:extLst xmlns:a="http://schemas.openxmlformats.org/drawingml/2006/main">
               <a:ext uri="{FF2B5EF4-FFF2-40B4-BE49-F238E27FC236}">
-                <a16:creationId xmlns:a16="http://schemas.microsoft.com/office/drawing/2014/main" id="{018B222D-6DAD-42B5-8659-3F83E5F02F8A}"/>
+                <a16:creationId xmlns:a16="http://schemas.microsoft.com/office/drawing/2014/main" id="{58A51F19-4088-40A4-8407-DDB9B16AE069}"/>
               </a:ext>
             </a:extLst>
           </p:cNvPr>
@@ -2769,7 +2769,7 @@
                 <a:ea typeface="Aptos"/>
                 <a:cs typeface="Aptos"/>
               </a:rPr>
-              <a:t>VeriPass - support executif</a:t>
+              <a:t>VeriPass - support de direction</a:t>
             </a:r>
           </a:p>
         </p:txBody>
@@ -2779,7 +2779,7 @@
           <p:cNvPr id="23" name="">
             <a:extLst xmlns:a="http://schemas.openxmlformats.org/drawingml/2006/main">
               <a:ext uri="{FF2B5EF4-FFF2-40B4-BE49-F238E27FC236}">
-                <a16:creationId xmlns:a16="http://schemas.microsoft.com/office/drawing/2014/main" id="{6B3B3718-7148-4F4A-9882-42936DDD052E}"/>
+                <a16:creationId xmlns:a16="http://schemas.microsoft.com/office/drawing/2014/main" id="{ACB069AA-34B5-4D4C-A907-5E6489CD3C9E}"/>
               </a:ext>
             </a:extLst>
           </p:cNvPr>
@@ -2841,7 +2841,7 @@
     </p:spTree>
     <p:extLst>
       <p:ext uri="{BB962C8B-B14F-4D97-AF65-F5344CB8AC3E}">
-        <p14:creationId xmlns:p14="http://schemas.microsoft.com/office/powerpoint/2010/main" val="517127497"/>
+        <p14:creationId xmlns:p14="http://schemas.microsoft.com/office/powerpoint/2010/main" val="1739763406"/>
       </p:ext>
     </p:extLst>
   </p:cSld>
@@ -2865,7 +2865,7 @@
           <p:cNvPr id="1" name="">
             <a:extLst xmlns:a="http://schemas.openxmlformats.org/drawingml/2006/main">
               <a:ext uri="{FF2B5EF4-FFF2-40B4-BE49-F238E27FC236}">
-                <a16:creationId xmlns:a16="http://schemas.microsoft.com/office/drawing/2014/main" id="{DB931EC5-D9E8-4988-ACD4-CC599543DFE9}"/>
+                <a16:creationId xmlns:a16="http://schemas.microsoft.com/office/drawing/2014/main" id="{F0D6921F-60AB-4808-B222-B06EE6B32786}"/>
               </a:ext>
             </a:extLst>
           </p:cNvPr>
@@ -2900,7 +2900,7 @@
           <p:cNvPr id="2" name="">
             <a:extLst xmlns:a="http://schemas.openxmlformats.org/drawingml/2006/main">
               <a:ext uri="{FF2B5EF4-FFF2-40B4-BE49-F238E27FC236}">
-                <a16:creationId xmlns:a16="http://schemas.microsoft.com/office/drawing/2014/main" id="{495195A5-C024-4C3A-9EBA-3D0D86CB279B}"/>
+                <a16:creationId xmlns:a16="http://schemas.microsoft.com/office/drawing/2014/main" id="{79EE0706-50B9-4072-9D69-84B49B246FCD}"/>
               </a:ext>
             </a:extLst>
           </p:cNvPr>
@@ -2935,7 +2935,7 @@
           <p:cNvPr id="3" name="">
             <a:extLst xmlns:a="http://schemas.openxmlformats.org/drawingml/2006/main">
               <a:ext uri="{FF2B5EF4-FFF2-40B4-BE49-F238E27FC236}">
-                <a16:creationId xmlns:a16="http://schemas.microsoft.com/office/drawing/2014/main" id="{7C514F7A-A06D-44BC-A75A-8BF07EA60192}"/>
+                <a16:creationId xmlns:a16="http://schemas.microsoft.com/office/drawing/2014/main" id="{3A7CF3A1-15E5-4B05-8185-FC4138E810EB}"/>
               </a:ext>
             </a:extLst>
           </p:cNvPr>
@@ -2999,7 +2999,7 @@
           <p:cNvPr id="4" name="">
             <a:extLst xmlns:a="http://schemas.openxmlformats.org/drawingml/2006/main">
               <a:ext uri="{FF2B5EF4-FFF2-40B4-BE49-F238E27FC236}">
-                <a16:creationId xmlns:a16="http://schemas.microsoft.com/office/drawing/2014/main" id="{CF0F46E8-D439-4F8E-AF61-DB9091231C1B}"/>
+                <a16:creationId xmlns:a16="http://schemas.microsoft.com/office/drawing/2014/main" id="{0C6A620B-F951-455B-85CC-2885EA31027D}"/>
               </a:ext>
             </a:extLst>
           </p:cNvPr>
@@ -3011,7 +3011,7 @@
         <p:spPr>
           <a:xfrm xmlns:a="http://schemas.openxmlformats.org/drawingml/2006/main">
             <a:off x="609600" y="838200"/>
-            <a:ext cx="7429500" cy="1028700"/>
+            <a:ext cx="7810500" cy="1028700"/>
           </a:xfrm>
           <a:prstGeom xmlns:a="http://schemas.openxmlformats.org/drawingml/2006/main" prst="rect">
             <a:avLst/>
@@ -3035,7 +3035,7 @@
           <a:lstStyle xmlns:a="http://schemas.openxmlformats.org/drawingml/2006/main"/>
           <a:p xmlns:a="http://schemas.openxmlformats.org/drawingml/2006/main">
             <a:pPr algn="l">
-              <a:defRPr sz="3450" b="1">
+              <a:defRPr sz="3225" b="1">
                 <a:solidFill>
                   <a:srgbClr val="FFFFFF"/>
                 </a:solidFill>
@@ -3045,7 +3045,7 @@
               </a:defRPr>
             </a:pPr>
             <a:r>
-              <a:rPr sz="3450" b="1">
+              <a:rPr sz="3225" b="1">
                 <a:solidFill>
                   <a:srgbClr val="FFFFFF"/>
                 </a:solidFill>
@@ -3053,7 +3053,7 @@
                 <a:ea typeface="Aptos Display"/>
                 <a:cs typeface="Aptos Display"/>
               </a:rPr>
-              <a:t>Transformer le MVP en dispositif bancaire eprouve.</a:t>
+              <a:t>Transformer la version fonctionnelle en dispositif bancaire eprouve.</a:t>
             </a:r>
           </a:p>
         </p:txBody>
@@ -3063,7 +3063,7 @@
           <p:cNvPr id="5" name="">
             <a:extLst xmlns:a="http://schemas.openxmlformats.org/drawingml/2006/main">
               <a:ext uri="{FF2B5EF4-FFF2-40B4-BE49-F238E27FC236}">
-                <a16:creationId xmlns:a16="http://schemas.microsoft.com/office/drawing/2014/main" id="{40DAC0BD-AFE5-4E8E-94E0-F70F92EC805E}"/>
+                <a16:creationId xmlns:a16="http://schemas.microsoft.com/office/drawing/2014/main" id="{8C77E8DD-983F-4237-9B3E-0F5E3EEDE0A2}"/>
               </a:ext>
             </a:extLst>
           </p:cNvPr>
@@ -3117,7 +3117,7 @@
                 <a:ea typeface="Aptos"/>
                 <a:cs typeface="Aptos"/>
               </a:rPr>
-              <a:t>La suite ne doit pas etre une liste de features. Elle doit etre une validation croisee: metier, conformite, SI, operations et donnees.</a:t>
+              <a:t>La suite ne doit pas etre une liste de fonctionnalites. Elle doit etre une validation croisee: metier, conformite, SI, operations et donnees.</a:t>
             </a:r>
           </a:p>
         </p:txBody>
@@ -3127,7 +3127,7 @@
           <p:cNvPr id="6" name="">
             <a:extLst xmlns:a="http://schemas.openxmlformats.org/drawingml/2006/main">
               <a:ext uri="{FF2B5EF4-FFF2-40B4-BE49-F238E27FC236}">
-                <a16:creationId xmlns:a16="http://schemas.microsoft.com/office/drawing/2014/main" id="{E79CEB48-F7A0-4A90-8413-A39693A726F2}"/>
+                <a16:creationId xmlns:a16="http://schemas.microsoft.com/office/drawing/2014/main" id="{F96AFFD8-858B-4AAC-83AF-27E6EEB6601F}"/>
               </a:ext>
             </a:extLst>
           </p:cNvPr>
@@ -3160,7 +3160,7 @@
           <p:cNvPr id="7" name="">
             <a:extLst xmlns:a="http://schemas.openxmlformats.org/drawingml/2006/main">
               <a:ext uri="{FF2B5EF4-FFF2-40B4-BE49-F238E27FC236}">
-                <a16:creationId xmlns:a16="http://schemas.microsoft.com/office/drawing/2014/main" id="{2724443F-51E2-4617-BC97-6DE13780BF95}"/>
+                <a16:creationId xmlns:a16="http://schemas.microsoft.com/office/drawing/2014/main" id="{B4743032-F7A0-4911-8FDE-234FC79E6F37}"/>
               </a:ext>
             </a:extLst>
           </p:cNvPr>
@@ -3195,7 +3195,7 @@
           <p:cNvPr id="8" name="">
             <a:extLst xmlns:a="http://schemas.openxmlformats.org/drawingml/2006/main">
               <a:ext uri="{FF2B5EF4-FFF2-40B4-BE49-F238E27FC236}">
-                <a16:creationId xmlns:a16="http://schemas.microsoft.com/office/drawing/2014/main" id="{F8CC0197-14BA-4700-837A-F236F3115A26}"/>
+                <a16:creationId xmlns:a16="http://schemas.microsoft.com/office/drawing/2014/main" id="{9A242442-F7A5-4CA0-A4DF-30A366226F9E}"/>
               </a:ext>
             </a:extLst>
           </p:cNvPr>
@@ -3230,7 +3230,7 @@
           <p:cNvPr id="9" name="">
             <a:extLst xmlns:a="http://schemas.openxmlformats.org/drawingml/2006/main">
               <a:ext uri="{FF2B5EF4-FFF2-40B4-BE49-F238E27FC236}">
-                <a16:creationId xmlns:a16="http://schemas.microsoft.com/office/drawing/2014/main" id="{46BD4EE3-2B4A-40AE-B2B1-EA63BCFB199E}"/>
+                <a16:creationId xmlns:a16="http://schemas.microsoft.com/office/drawing/2014/main" id="{9EB210EC-AD13-47EB-9EE2-09908CA5444A}"/>
               </a:ext>
             </a:extLst>
           </p:cNvPr>
@@ -3294,7 +3294,7 @@
           <p:cNvPr id="10" name="">
             <a:extLst xmlns:a="http://schemas.openxmlformats.org/drawingml/2006/main">
               <a:ext uri="{FF2B5EF4-FFF2-40B4-BE49-F238E27FC236}">
-                <a16:creationId xmlns:a16="http://schemas.microsoft.com/office/drawing/2014/main" id="{67414D71-E29D-4F54-A753-A3926A93BC3F}"/>
+                <a16:creationId xmlns:a16="http://schemas.microsoft.com/office/drawing/2014/main" id="{10B742F2-F172-45FB-92A3-23E427F51C79}"/>
               </a:ext>
             </a:extLst>
           </p:cNvPr>
@@ -3358,7 +3358,7 @@
           <p:cNvPr id="11" name="">
             <a:extLst xmlns:a="http://schemas.openxmlformats.org/drawingml/2006/main">
               <a:ext uri="{FF2B5EF4-FFF2-40B4-BE49-F238E27FC236}">
-                <a16:creationId xmlns:a16="http://schemas.microsoft.com/office/drawing/2014/main" id="{237544BF-6A20-48A4-9A0E-4E42FD48E376}"/>
+                <a16:creationId xmlns:a16="http://schemas.microsoft.com/office/drawing/2014/main" id="{E39D3CE7-475E-4064-993B-7D435628B4ED}"/>
               </a:ext>
             </a:extLst>
           </p:cNvPr>
@@ -3422,7 +3422,7 @@
           <p:cNvPr id="12" name="">
             <a:extLst xmlns:a="http://schemas.openxmlformats.org/drawingml/2006/main">
               <a:ext uri="{FF2B5EF4-FFF2-40B4-BE49-F238E27FC236}">
-                <a16:creationId xmlns:a16="http://schemas.microsoft.com/office/drawing/2014/main" id="{67B2DA59-19EF-44F3-B276-90F06762FDEA}"/>
+                <a16:creationId xmlns:a16="http://schemas.microsoft.com/office/drawing/2014/main" id="{FFF78ADD-FEBD-4BFA-9144-BE1AC265188A}"/>
               </a:ext>
             </a:extLst>
           </p:cNvPr>
@@ -3455,7 +3455,7 @@
           <p:cNvPr id="13" name="">
             <a:extLst xmlns:a="http://schemas.openxmlformats.org/drawingml/2006/main">
               <a:ext uri="{FF2B5EF4-FFF2-40B4-BE49-F238E27FC236}">
-                <a16:creationId xmlns:a16="http://schemas.microsoft.com/office/drawing/2014/main" id="{C1D3E77F-AC9A-4932-9E19-153CA649B718}"/>
+                <a16:creationId xmlns:a16="http://schemas.microsoft.com/office/drawing/2014/main" id="{B81762D8-55E9-4C6A-9495-0DD95DE608D2}"/>
               </a:ext>
             </a:extLst>
           </p:cNvPr>
@@ -3490,7 +3490,7 @@
           <p:cNvPr id="14" name="">
             <a:extLst xmlns:a="http://schemas.openxmlformats.org/drawingml/2006/main">
               <a:ext uri="{FF2B5EF4-FFF2-40B4-BE49-F238E27FC236}">
-                <a16:creationId xmlns:a16="http://schemas.microsoft.com/office/drawing/2014/main" id="{B0239194-5EB0-43F7-A147-E54B30DAE0C9}"/>
+                <a16:creationId xmlns:a16="http://schemas.microsoft.com/office/drawing/2014/main" id="{B8C0E5BC-1380-4D9B-AFBA-B37C06ECA7DF}"/>
               </a:ext>
             </a:extLst>
           </p:cNvPr>
@@ -3525,7 +3525,7 @@
           <p:cNvPr id="15" name="">
             <a:extLst xmlns:a="http://schemas.openxmlformats.org/drawingml/2006/main">
               <a:ext uri="{FF2B5EF4-FFF2-40B4-BE49-F238E27FC236}">
-                <a16:creationId xmlns:a16="http://schemas.microsoft.com/office/drawing/2014/main" id="{103008A7-28D4-4FF5-AC7F-977665A6EFE4}"/>
+                <a16:creationId xmlns:a16="http://schemas.microsoft.com/office/drawing/2014/main" id="{5E60A446-0EEA-4F9E-B1B8-57F929FBB9C9}"/>
               </a:ext>
             </a:extLst>
           </p:cNvPr>
@@ -3589,7 +3589,7 @@
           <p:cNvPr id="16" name="">
             <a:extLst xmlns:a="http://schemas.openxmlformats.org/drawingml/2006/main">
               <a:ext uri="{FF2B5EF4-FFF2-40B4-BE49-F238E27FC236}">
-                <a16:creationId xmlns:a16="http://schemas.microsoft.com/office/drawing/2014/main" id="{28C3F4B1-62FA-41ED-A9AC-78073E29733B}"/>
+                <a16:creationId xmlns:a16="http://schemas.microsoft.com/office/drawing/2014/main" id="{DE7F62A0-E19F-40AB-9F56-BED552103171}"/>
               </a:ext>
             </a:extLst>
           </p:cNvPr>
@@ -3653,7 +3653,7 @@
           <p:cNvPr id="17" name="">
             <a:extLst xmlns:a="http://schemas.openxmlformats.org/drawingml/2006/main">
               <a:ext uri="{FF2B5EF4-FFF2-40B4-BE49-F238E27FC236}">
-                <a16:creationId xmlns:a16="http://schemas.microsoft.com/office/drawing/2014/main" id="{DE84A399-6413-4A96-A2B1-DC40E2CF146B}"/>
+                <a16:creationId xmlns:a16="http://schemas.microsoft.com/office/drawing/2014/main" id="{8C788727-7058-4251-B065-2D85D2AC5649}"/>
               </a:ext>
             </a:extLst>
           </p:cNvPr>
@@ -3707,7 +3707,7 @@
                 <a:ea typeface="Aptos"/>
                 <a:cs typeface="Aptos"/>
               </a:rPr>
-              <a:t>AML/CFT, conservation, preuves, decisions</a:t>
+              <a:t>LCB-FT, conservation, preuves, decisions</a:t>
             </a:r>
           </a:p>
         </p:txBody>
@@ -3717,7 +3717,7 @@
           <p:cNvPr id="18" name="">
             <a:extLst xmlns:a="http://schemas.openxmlformats.org/drawingml/2006/main">
               <a:ext uri="{FF2B5EF4-FFF2-40B4-BE49-F238E27FC236}">
-                <a16:creationId xmlns:a16="http://schemas.microsoft.com/office/drawing/2014/main" id="{F05DB717-81D4-46DE-8E9B-4CBC318DEBF5}"/>
+                <a16:creationId xmlns:a16="http://schemas.microsoft.com/office/drawing/2014/main" id="{2470CA76-9340-4ED5-B17B-AABC422B3578}"/>
               </a:ext>
             </a:extLst>
           </p:cNvPr>
@@ -3750,7 +3750,7 @@
           <p:cNvPr id="19" name="">
             <a:extLst xmlns:a="http://schemas.openxmlformats.org/drawingml/2006/main">
               <a:ext uri="{FF2B5EF4-FFF2-40B4-BE49-F238E27FC236}">
-                <a16:creationId xmlns:a16="http://schemas.microsoft.com/office/drawing/2014/main" id="{EB67B64B-F073-43E0-B457-807AE59FA17E}"/>
+                <a16:creationId xmlns:a16="http://schemas.microsoft.com/office/drawing/2014/main" id="{B01CFDE1-32B0-41A7-923E-9DAB1180DEA3}"/>
               </a:ext>
             </a:extLst>
           </p:cNvPr>
@@ -3785,7 +3785,7 @@
           <p:cNvPr id="20" name="">
             <a:extLst xmlns:a="http://schemas.openxmlformats.org/drawingml/2006/main">
               <a:ext uri="{FF2B5EF4-FFF2-40B4-BE49-F238E27FC236}">
-                <a16:creationId xmlns:a16="http://schemas.microsoft.com/office/drawing/2014/main" id="{B5996A65-0E7A-4446-BE28-81C536C5F97D}"/>
+                <a16:creationId xmlns:a16="http://schemas.microsoft.com/office/drawing/2014/main" id="{156E52E1-EC65-42F7-B3ED-310B04EB8051}"/>
               </a:ext>
             </a:extLst>
           </p:cNvPr>
@@ -3820,7 +3820,7 @@
           <p:cNvPr id="21" name="">
             <a:extLst xmlns:a="http://schemas.openxmlformats.org/drawingml/2006/main">
               <a:ext uri="{FF2B5EF4-FFF2-40B4-BE49-F238E27FC236}">
-                <a16:creationId xmlns:a16="http://schemas.microsoft.com/office/drawing/2014/main" id="{6EDCE6D5-D667-4806-9B4E-E7118B74582B}"/>
+                <a16:creationId xmlns:a16="http://schemas.microsoft.com/office/drawing/2014/main" id="{B7069F1A-42CE-44FE-AB19-35AA158AC49A}"/>
               </a:ext>
             </a:extLst>
           </p:cNvPr>
@@ -3884,7 +3884,7 @@
           <p:cNvPr id="22" name="">
             <a:extLst xmlns:a="http://schemas.openxmlformats.org/drawingml/2006/main">
               <a:ext uri="{FF2B5EF4-FFF2-40B4-BE49-F238E27FC236}">
-                <a16:creationId xmlns:a16="http://schemas.microsoft.com/office/drawing/2014/main" id="{0C443A07-4C58-46D1-B4E0-54E7BE7D6FF9}"/>
+                <a16:creationId xmlns:a16="http://schemas.microsoft.com/office/drawing/2014/main" id="{A9EBAD3C-8FE4-4349-8BFE-2D3FAA5B60B0}"/>
               </a:ext>
             </a:extLst>
           </p:cNvPr>
@@ -3948,7 +3948,7 @@
           <p:cNvPr id="23" name="">
             <a:extLst xmlns:a="http://schemas.openxmlformats.org/drawingml/2006/main">
               <a:ext uri="{FF2B5EF4-FFF2-40B4-BE49-F238E27FC236}">
-                <a16:creationId xmlns:a16="http://schemas.microsoft.com/office/drawing/2014/main" id="{9573A476-559F-437D-A86D-12C6D32C115B}"/>
+                <a16:creationId xmlns:a16="http://schemas.microsoft.com/office/drawing/2014/main" id="{42A0FD43-8F8E-40C0-BF68-CB60931E180C}"/>
               </a:ext>
             </a:extLst>
           </p:cNvPr>
@@ -4012,7 +4012,7 @@
           <p:cNvPr id="24" name="">
             <a:extLst xmlns:a="http://schemas.openxmlformats.org/drawingml/2006/main">
               <a:ext uri="{FF2B5EF4-FFF2-40B4-BE49-F238E27FC236}">
-                <a16:creationId xmlns:a16="http://schemas.microsoft.com/office/drawing/2014/main" id="{45393B13-C877-4153-9B28-A0A50BDF8D2E}"/>
+                <a16:creationId xmlns:a16="http://schemas.microsoft.com/office/drawing/2014/main" id="{0DE27A38-E34E-4ADD-A024-23DD5542D11D}"/>
               </a:ext>
             </a:extLst>
           </p:cNvPr>
@@ -4045,7 +4045,7 @@
           <p:cNvPr id="25" name="">
             <a:extLst xmlns:a="http://schemas.openxmlformats.org/drawingml/2006/main">
               <a:ext uri="{FF2B5EF4-FFF2-40B4-BE49-F238E27FC236}">
-                <a16:creationId xmlns:a16="http://schemas.microsoft.com/office/drawing/2014/main" id="{C75FB639-DDE0-48EF-9C08-30FF7DE03D32}"/>
+                <a16:creationId xmlns:a16="http://schemas.microsoft.com/office/drawing/2014/main" id="{49CA99A7-8C21-4A7D-B5F3-1B3A4FC43BD9}"/>
               </a:ext>
             </a:extLst>
           </p:cNvPr>
@@ -4080,7 +4080,7 @@
           <p:cNvPr id="26" name="">
             <a:extLst xmlns:a="http://schemas.openxmlformats.org/drawingml/2006/main">
               <a:ext uri="{FF2B5EF4-FFF2-40B4-BE49-F238E27FC236}">
-                <a16:creationId xmlns:a16="http://schemas.microsoft.com/office/drawing/2014/main" id="{A1868A4F-F0AB-48FB-92E0-12AFAEE1B0E9}"/>
+                <a16:creationId xmlns:a16="http://schemas.microsoft.com/office/drawing/2014/main" id="{308FFD2D-C07C-4089-BC1A-6ED353B4EC9F}"/>
               </a:ext>
             </a:extLst>
           </p:cNvPr>
@@ -4115,7 +4115,7 @@
           <p:cNvPr id="27" name="">
             <a:extLst xmlns:a="http://schemas.openxmlformats.org/drawingml/2006/main">
               <a:ext uri="{FF2B5EF4-FFF2-40B4-BE49-F238E27FC236}">
-                <a16:creationId xmlns:a16="http://schemas.microsoft.com/office/drawing/2014/main" id="{D73A27DB-3FB5-4BE5-8BE6-E41E85B8166F}"/>
+                <a16:creationId xmlns:a16="http://schemas.microsoft.com/office/drawing/2014/main" id="{226552A1-736F-4086-A188-D67215F7D2D6}"/>
               </a:ext>
             </a:extLst>
           </p:cNvPr>
@@ -4179,7 +4179,7 @@
           <p:cNvPr id="28" name="">
             <a:extLst xmlns:a="http://schemas.openxmlformats.org/drawingml/2006/main">
               <a:ext uri="{FF2B5EF4-FFF2-40B4-BE49-F238E27FC236}">
-                <a16:creationId xmlns:a16="http://schemas.microsoft.com/office/drawing/2014/main" id="{B094DC72-CEB1-4939-A160-0DF3EFD15ED3}"/>
+                <a16:creationId xmlns:a16="http://schemas.microsoft.com/office/drawing/2014/main" id="{FE860A6A-5621-46FD-BE87-3762825BA6A7}"/>
               </a:ext>
             </a:extLst>
           </p:cNvPr>
@@ -4243,7 +4243,7 @@
           <p:cNvPr id="29" name="">
             <a:extLst xmlns:a="http://schemas.openxmlformats.org/drawingml/2006/main">
               <a:ext uri="{FF2B5EF4-FFF2-40B4-BE49-F238E27FC236}">
-                <a16:creationId xmlns:a16="http://schemas.microsoft.com/office/drawing/2014/main" id="{CB69B249-CC8C-41B3-ABD7-EC7833A1021E}"/>
+                <a16:creationId xmlns:a16="http://schemas.microsoft.com/office/drawing/2014/main" id="{252999C0-28F1-4806-B93B-B45ABFD9A7B2}"/>
               </a:ext>
             </a:extLst>
           </p:cNvPr>
@@ -4297,7 +4297,7 @@
                 <a:ea typeface="Aptos"/>
                 <a:cs typeface="Aptos"/>
               </a:rPr>
-              <a:t>files, SLA, roles, support, procedures</a:t>
+              <a:t>files, delais cibles, roles, appui, procedures</a:t>
             </a:r>
           </a:p>
         </p:txBody>
@@ -4307,7 +4307,7 @@
           <p:cNvPr id="30" name="">
             <a:extLst xmlns:a="http://schemas.openxmlformats.org/drawingml/2006/main">
               <a:ext uri="{FF2B5EF4-FFF2-40B4-BE49-F238E27FC236}">
-                <a16:creationId xmlns:a16="http://schemas.microsoft.com/office/drawing/2014/main" id="{B2FB16D4-A53B-41DB-88CF-9D01F643B52A}"/>
+                <a16:creationId xmlns:a16="http://schemas.microsoft.com/office/drawing/2014/main" id="{58E2E2CE-F598-4126-BD7A-E32745979E07}"/>
               </a:ext>
             </a:extLst>
           </p:cNvPr>
@@ -4340,7 +4340,7 @@
           <p:cNvPr id="31" name="">
             <a:extLst xmlns:a="http://schemas.openxmlformats.org/drawingml/2006/main">
               <a:ext uri="{FF2B5EF4-FFF2-40B4-BE49-F238E27FC236}">
-                <a16:creationId xmlns:a16="http://schemas.microsoft.com/office/drawing/2014/main" id="{0D2E567E-79CF-4D77-8953-D41266118537}"/>
+                <a16:creationId xmlns:a16="http://schemas.microsoft.com/office/drawing/2014/main" id="{B3A2578E-C85F-4E75-B453-242D4199701F}"/>
               </a:ext>
             </a:extLst>
           </p:cNvPr>
@@ -4375,7 +4375,7 @@
           <p:cNvPr id="32" name="">
             <a:extLst xmlns:a="http://schemas.openxmlformats.org/drawingml/2006/main">
               <a:ext uri="{FF2B5EF4-FFF2-40B4-BE49-F238E27FC236}">
-                <a16:creationId xmlns:a16="http://schemas.microsoft.com/office/drawing/2014/main" id="{0730F0F7-FA25-4486-8370-98080820AB4C}"/>
+                <a16:creationId xmlns:a16="http://schemas.microsoft.com/office/drawing/2014/main" id="{9277D887-CF52-4AEC-9F57-20DD009E7B1B}"/>
               </a:ext>
             </a:extLst>
           </p:cNvPr>
@@ -4410,7 +4410,7 @@
           <p:cNvPr id="33" name="">
             <a:extLst xmlns:a="http://schemas.openxmlformats.org/drawingml/2006/main">
               <a:ext uri="{FF2B5EF4-FFF2-40B4-BE49-F238E27FC236}">
-                <a16:creationId xmlns:a16="http://schemas.microsoft.com/office/drawing/2014/main" id="{2E7F4585-9EB5-4B50-AAF6-648448E5B91E}"/>
+                <a16:creationId xmlns:a16="http://schemas.microsoft.com/office/drawing/2014/main" id="{9486585A-D962-4510-AFEA-691920823728}"/>
               </a:ext>
             </a:extLst>
           </p:cNvPr>
@@ -4474,7 +4474,7 @@
           <p:cNvPr id="34" name="">
             <a:extLst xmlns:a="http://schemas.openxmlformats.org/drawingml/2006/main">
               <a:ext uri="{FF2B5EF4-FFF2-40B4-BE49-F238E27FC236}">
-                <a16:creationId xmlns:a16="http://schemas.microsoft.com/office/drawing/2014/main" id="{87D7FB39-B930-4646-8EA1-031FD54F223D}"/>
+                <a16:creationId xmlns:a16="http://schemas.microsoft.com/office/drawing/2014/main" id="{4A99B52A-59B2-4816-B230-98D708655118}"/>
               </a:ext>
             </a:extLst>
           </p:cNvPr>
@@ -4528,7 +4528,7 @@
                 <a:ea typeface="Aptos Display"/>
                 <a:cs typeface="Aptos Display"/>
               </a:rPr>
-              <a:t>Data / ROI</a:t>
+              <a:t>Donnees / valeur</a:t>
             </a:r>
           </a:p>
         </p:txBody>
@@ -4538,7 +4538,7 @@
           <p:cNvPr id="35" name="">
             <a:extLst xmlns:a="http://schemas.openxmlformats.org/drawingml/2006/main">
               <a:ext uri="{FF2B5EF4-FFF2-40B4-BE49-F238E27FC236}">
-                <a16:creationId xmlns:a16="http://schemas.microsoft.com/office/drawing/2014/main" id="{04E6B46F-CC8E-416D-B91D-C95122E8D425}"/>
+                <a16:creationId xmlns:a16="http://schemas.microsoft.com/office/drawing/2014/main" id="{1CCEACF1-8D85-446A-B82D-AC906BE4D81A}"/>
               </a:ext>
             </a:extLst>
           </p:cNvPr>
@@ -4592,7 +4592,7 @@
                 <a:ea typeface="Aptos"/>
                 <a:cs typeface="Aptos"/>
               </a:rPr>
-              <a:t>baseline, KPI pilote, cout par dossier</a:t>
+              <a:t>etat initial, indicateurs pilote, cout par dossier</a:t>
             </a:r>
           </a:p>
         </p:txBody>
@@ -4602,7 +4602,7 @@
           <p:cNvPr id="36" name="">
             <a:extLst xmlns:a="http://schemas.openxmlformats.org/drawingml/2006/main">
               <a:ext uri="{FF2B5EF4-FFF2-40B4-BE49-F238E27FC236}">
-                <a16:creationId xmlns:a16="http://schemas.microsoft.com/office/drawing/2014/main" id="{43B1A05E-D86F-4846-96E0-F03C7B4FB3B3}"/>
+                <a16:creationId xmlns:a16="http://schemas.microsoft.com/office/drawing/2014/main" id="{7ED16E26-102D-46D5-A8C8-B311F5727EE2}"/>
               </a:ext>
             </a:extLst>
           </p:cNvPr>
@@ -4635,7 +4635,7 @@
           <p:cNvPr id="37" name="">
             <a:extLst xmlns:a="http://schemas.openxmlformats.org/drawingml/2006/main">
               <a:ext uri="{FF2B5EF4-FFF2-40B4-BE49-F238E27FC236}">
-                <a16:creationId xmlns:a16="http://schemas.microsoft.com/office/drawing/2014/main" id="{E67A7750-D63A-4282-9FA6-B5EFB58D2320}"/>
+                <a16:creationId xmlns:a16="http://schemas.microsoft.com/office/drawing/2014/main" id="{C641DBEA-A7F8-4007-AC1A-4F4ADFCF5CAE}"/>
               </a:ext>
             </a:extLst>
           </p:cNvPr>
@@ -4699,19 +4699,19 @@
           <p:cNvPr id="38" name="">
             <a:extLst xmlns:a="http://schemas.openxmlformats.org/drawingml/2006/main">
               <a:ext uri="{FF2B5EF4-FFF2-40B4-BE49-F238E27FC236}">
-                <a16:creationId xmlns:a16="http://schemas.microsoft.com/office/drawing/2014/main" id="{EB474A10-BBDE-4E13-AAC8-0872D854A20F}"/>
-              </a:ext>
-            </a:extLst>
-          </p:cNvPr>
-          <p:cNvSpPr>
-            <a:spLocks xmlns:a="http://schemas.openxmlformats.org/drawingml/2006/main" noGrp="1"/>
-          </p:cNvSpPr>
-          <p:nvPr/>
-        </p:nvSpPr>
-        <p:spPr>
-          <a:xfrm xmlns:a="http://schemas.openxmlformats.org/drawingml/2006/main">
-            <a:off x="7886700" y="5162550"/>
-            <a:ext cx="1714500" cy="171450"/>
+                <a16:creationId xmlns:a16="http://schemas.microsoft.com/office/drawing/2014/main" id="{6F7B4D8E-E678-42EF-B8F5-BC21299637D3}"/>
+              </a:ext>
+            </a:extLst>
+          </p:cNvPr>
+          <p:cNvSpPr>
+            <a:spLocks xmlns:a="http://schemas.openxmlformats.org/drawingml/2006/main" noGrp="1"/>
+          </p:cNvSpPr>
+          <p:nvPr/>
+        </p:nvSpPr>
+        <p:spPr>
+          <a:xfrm xmlns:a="http://schemas.openxmlformats.org/drawingml/2006/main">
+            <a:off x="7829550" y="5143500"/>
+            <a:ext cx="1847850" cy="266700"/>
           </a:xfrm>
           <a:prstGeom xmlns:a="http://schemas.openxmlformats.org/drawingml/2006/main" prst="rect">
             <a:avLst/>
@@ -4735,7 +4735,7 @@
           <a:lstStyle xmlns:a="http://schemas.openxmlformats.org/drawingml/2006/main"/>
           <a:p xmlns:a="http://schemas.openxmlformats.org/drawingml/2006/main">
             <a:pPr algn="ctr">
-              <a:defRPr sz="1050" b="1">
+              <a:defRPr sz="938" b="1">
                 <a:solidFill>
                   <a:srgbClr val="FFFFFF"/>
                 </a:solidFill>
@@ -4745,7 +4745,7 @@
               </a:defRPr>
             </a:pPr>
             <a:r>
-              <a:rPr sz="1050" b="1">
+              <a:rPr sz="938" b="1">
                 <a:solidFill>
                   <a:srgbClr val="FFFFFF"/>
                 </a:solidFill>
@@ -4753,7 +4753,7 @@
                 <a:ea typeface="Aptos"/>
                 <a:cs typeface="Aptos"/>
               </a:rPr>
-              <a:t>go / no-go / rebuild / buy</a:t>
+              <a:t>continuer / arreter / refondre / acheter</a:t>
             </a:r>
           </a:p>
         </p:txBody>
@@ -4763,7 +4763,7 @@
           <p:cNvPr id="39" name="">
             <a:extLst xmlns:a="http://schemas.openxmlformats.org/drawingml/2006/main">
               <a:ext uri="{FF2B5EF4-FFF2-40B4-BE49-F238E27FC236}">
-                <a16:creationId xmlns:a16="http://schemas.microsoft.com/office/drawing/2014/main" id="{6463D377-6F7E-4691-9472-5A18DAA61603}"/>
+                <a16:creationId xmlns:a16="http://schemas.microsoft.com/office/drawing/2014/main" id="{6835DA88-E9C4-4EEB-9DBE-BE38B29E03B0}"/>
               </a:ext>
             </a:extLst>
           </p:cNvPr>
@@ -4798,7 +4798,7 @@
           <p:cNvPr id="40" name="">
             <a:extLst xmlns:a="http://schemas.openxmlformats.org/drawingml/2006/main">
               <a:ext uri="{FF2B5EF4-FFF2-40B4-BE49-F238E27FC236}">
-                <a16:creationId xmlns:a16="http://schemas.microsoft.com/office/drawing/2014/main" id="{769C653D-6732-4BCD-A4F0-392598E85FE7}"/>
+                <a16:creationId xmlns:a16="http://schemas.microsoft.com/office/drawing/2014/main" id="{40D6DB30-E30A-4825-BEE7-5012EC143BAB}"/>
               </a:ext>
             </a:extLst>
           </p:cNvPr>
@@ -4852,7 +4852,7 @@
                 <a:ea typeface="Aptos"/>
                 <a:cs typeface="Aptos"/>
               </a:rPr>
-              <a:t>VeriPass - rail KYC souverain</a:t>
+              <a:t>VeriPass - connaissance client souveraine</a:t>
             </a:r>
           </a:p>
         </p:txBody>
@@ -4862,7 +4862,7 @@
           <p:cNvPr id="41" name="">
             <a:extLst xmlns:a="http://schemas.openxmlformats.org/drawingml/2006/main">
               <a:ext uri="{FF2B5EF4-FFF2-40B4-BE49-F238E27FC236}">
-                <a16:creationId xmlns:a16="http://schemas.microsoft.com/office/drawing/2014/main" id="{A5016927-D08D-4B7E-A674-88D7B7AA7999}"/>
+                <a16:creationId xmlns:a16="http://schemas.microsoft.com/office/drawing/2014/main" id="{E8CAA72C-8B02-44F0-BA3A-443704BA6FB5}"/>
               </a:ext>
             </a:extLst>
           </p:cNvPr>
@@ -4924,7 +4924,7 @@
     </p:spTree>
     <p:extLst>
       <p:ext uri="{BB962C8B-B14F-4D97-AF65-F5344CB8AC3E}">
-        <p14:creationId xmlns:p14="http://schemas.microsoft.com/office/powerpoint/2010/main" val="555634115"/>
+        <p14:creationId xmlns:p14="http://schemas.microsoft.com/office/powerpoint/2010/main" val="1904667117"/>
       </p:ext>
     </p:extLst>
   </p:cSld>
@@ -4948,7 +4948,7 @@
           <p:cNvPr id="1" name="">
             <a:extLst xmlns:a="http://schemas.openxmlformats.org/drawingml/2006/main">
               <a:ext uri="{FF2B5EF4-FFF2-40B4-BE49-F238E27FC236}">
-                <a16:creationId xmlns:a16="http://schemas.microsoft.com/office/drawing/2014/main" id="{D6E94F08-EF61-4C18-AF66-288F4B733D9A}"/>
+                <a16:creationId xmlns:a16="http://schemas.microsoft.com/office/drawing/2014/main" id="{A5773B28-3879-46DB-A878-04D9666806C3}"/>
               </a:ext>
             </a:extLst>
           </p:cNvPr>
@@ -4983,7 +4983,7 @@
           <p:cNvPr id="2" name="">
             <a:extLst xmlns:a="http://schemas.openxmlformats.org/drawingml/2006/main">
               <a:ext uri="{FF2B5EF4-FFF2-40B4-BE49-F238E27FC236}">
-                <a16:creationId xmlns:a16="http://schemas.microsoft.com/office/drawing/2014/main" id="{CE3CC403-9F57-4BE5-89AA-8D9E8B5850AE}"/>
+                <a16:creationId xmlns:a16="http://schemas.microsoft.com/office/drawing/2014/main" id="{D1187C89-EAA6-413B-BC9E-3DDFBC2209D9}"/>
               </a:ext>
             </a:extLst>
           </p:cNvPr>
@@ -5018,7 +5018,7 @@
           <p:cNvPr id="3" name="">
             <a:extLst xmlns:a="http://schemas.openxmlformats.org/drawingml/2006/main">
               <a:ext uri="{FF2B5EF4-FFF2-40B4-BE49-F238E27FC236}">
-                <a16:creationId xmlns:a16="http://schemas.microsoft.com/office/drawing/2014/main" id="{8989362D-F6FB-45AC-A18E-7986270CA761}"/>
+                <a16:creationId xmlns:a16="http://schemas.microsoft.com/office/drawing/2014/main" id="{00B5828C-3862-4821-9DD8-5CC30726D4D7}"/>
               </a:ext>
             </a:extLst>
           </p:cNvPr>
@@ -5072,7 +5072,7 @@
                 <a:ea typeface="Aptos"/>
                 <a:cs typeface="Aptos"/>
               </a:rPr>
-              <a:t>BUSINESS CASE</a:t>
+              <a:t>DOSSIER ECONOMIQUE</a:t>
             </a:r>
           </a:p>
         </p:txBody>
@@ -5082,7 +5082,7 @@
           <p:cNvPr id="4" name="">
             <a:extLst xmlns:a="http://schemas.openxmlformats.org/drawingml/2006/main">
               <a:ext uri="{FF2B5EF4-FFF2-40B4-BE49-F238E27FC236}">
-                <a16:creationId xmlns:a16="http://schemas.microsoft.com/office/drawing/2014/main" id="{35B4C816-8866-48D7-A2AF-C047F2A93E56}"/>
+                <a16:creationId xmlns:a16="http://schemas.microsoft.com/office/drawing/2014/main" id="{BB608C6E-CBE0-49CE-B6DD-E60980406803}"/>
               </a:ext>
             </a:extLst>
           </p:cNvPr>
@@ -5094,7 +5094,7 @@
         <p:spPr>
           <a:xfrm xmlns:a="http://schemas.openxmlformats.org/drawingml/2006/main">
             <a:off x="609600" y="838200"/>
-            <a:ext cx="7239000" cy="914400"/>
+            <a:ext cx="6667500" cy="914400"/>
           </a:xfrm>
           <a:prstGeom xmlns:a="http://schemas.openxmlformats.org/drawingml/2006/main" prst="rect">
             <a:avLst/>
@@ -5136,7 +5136,7 @@
                 <a:ea typeface="Aptos Display"/>
                 <a:cs typeface="Aptos Display"/>
               </a:rPr>
-              <a:t>Ne pas maquiller le ROI. Le mesurer.</a:t>
+              <a:t>Ne pas maquiller les gains. Les mesurer.</a:t>
             </a:r>
           </a:p>
         </p:txBody>
@@ -5146,7 +5146,7 @@
           <p:cNvPr id="5" name="">
             <a:extLst xmlns:a="http://schemas.openxmlformats.org/drawingml/2006/main">
               <a:ext uri="{FF2B5EF4-FFF2-40B4-BE49-F238E27FC236}">
-                <a16:creationId xmlns:a16="http://schemas.microsoft.com/office/drawing/2014/main" id="{FDE985D4-CA11-4E6A-8ADB-74CF806425CF}"/>
+                <a16:creationId xmlns:a16="http://schemas.microsoft.com/office/drawing/2014/main" id="{9D30E3A5-FC68-480B-B69B-AAD68B40DA74}"/>
               </a:ext>
             </a:extLst>
           </p:cNvPr>
@@ -5200,7 +5200,7 @@
                 <a:ea typeface="Aptos"/>
                 <a:cs typeface="Aptos"/>
               </a:rPr>
-              <a:t>Le bon business case ne vient pas d'un chiffre invente. Il vient d'un pilote qui mesure les variables BICEC.</a:t>
+              <a:t>Le retour sur investissement ne vient pas d'un chiffre invente. Il vient d'un pilote qui mesure les variables BICEC.</a:t>
             </a:r>
           </a:p>
         </p:txBody>
@@ -5210,7 +5210,7 @@
           <p:cNvPr id="6" name="">
             <a:extLst xmlns:a="http://schemas.openxmlformats.org/drawingml/2006/main">
               <a:ext uri="{FF2B5EF4-FFF2-40B4-BE49-F238E27FC236}">
-                <a16:creationId xmlns:a16="http://schemas.microsoft.com/office/drawing/2014/main" id="{79CC7713-F4EE-4A12-A75A-F5BE808A341B}"/>
+                <a16:creationId xmlns:a16="http://schemas.microsoft.com/office/drawing/2014/main" id="{CC69BA15-F443-4472-B3CE-031FE4AD2314}"/>
               </a:ext>
             </a:extLst>
           </p:cNvPr>
@@ -5243,7 +5243,7 @@
           <p:cNvPr id="7" name="">
             <a:extLst xmlns:a="http://schemas.openxmlformats.org/drawingml/2006/main">
               <a:ext uri="{FF2B5EF4-FFF2-40B4-BE49-F238E27FC236}">
-                <a16:creationId xmlns:a16="http://schemas.microsoft.com/office/drawing/2014/main" id="{EF439656-9DDD-40FE-BBAC-7FF3B28EEBAD}"/>
+                <a16:creationId xmlns:a16="http://schemas.microsoft.com/office/drawing/2014/main" id="{C28BE4B4-F8E2-4177-BA50-57BBCC25FBC6}"/>
               </a:ext>
             </a:extLst>
           </p:cNvPr>
@@ -5278,7 +5278,7 @@
           <p:cNvPr id="8" name="">
             <a:extLst xmlns:a="http://schemas.openxmlformats.org/drawingml/2006/main">
               <a:ext uri="{FF2B5EF4-FFF2-40B4-BE49-F238E27FC236}">
-                <a16:creationId xmlns:a16="http://schemas.microsoft.com/office/drawing/2014/main" id="{6BAB7114-39ED-4C03-BE63-3717C37933C1}"/>
+                <a16:creationId xmlns:a16="http://schemas.microsoft.com/office/drawing/2014/main" id="{3715EB1D-EB0D-4F5B-9263-ADAA227EE50F}"/>
               </a:ext>
             </a:extLst>
           </p:cNvPr>
@@ -5332,7 +5332,7 @@
                 <a:ea typeface="Aptos Display"/>
                 <a:cs typeface="Aptos Display"/>
               </a:rPr>
-              <a:t>Rework</a:t>
+              <a:t>Reprises</a:t>
             </a:r>
           </a:p>
         </p:txBody>
@@ -5342,7 +5342,7 @@
           <p:cNvPr id="9" name="">
             <a:extLst xmlns:a="http://schemas.openxmlformats.org/drawingml/2006/main">
               <a:ext uri="{FF2B5EF4-FFF2-40B4-BE49-F238E27FC236}">
-                <a16:creationId xmlns:a16="http://schemas.microsoft.com/office/drawing/2014/main" id="{53EDE38B-89C3-46BD-AFAC-346720235871}"/>
+                <a16:creationId xmlns:a16="http://schemas.microsoft.com/office/drawing/2014/main" id="{05FBAFAC-278C-4465-8454-692931AB1EB1}"/>
               </a:ext>
             </a:extLst>
           </p:cNvPr>
@@ -5377,7 +5377,7 @@
           <p:cNvPr id="10" name="">
             <a:extLst xmlns:a="http://schemas.openxmlformats.org/drawingml/2006/main">
               <a:ext uri="{FF2B5EF4-FFF2-40B4-BE49-F238E27FC236}">
-                <a16:creationId xmlns:a16="http://schemas.microsoft.com/office/drawing/2014/main" id="{5AB287B0-EFFB-4B27-945E-98D1C5FAD893}"/>
+                <a16:creationId xmlns:a16="http://schemas.microsoft.com/office/drawing/2014/main" id="{861D227E-19DF-4DF2-B54B-8568207BECA5}"/>
               </a:ext>
             </a:extLst>
           </p:cNvPr>
@@ -5441,7 +5441,7 @@
           <p:cNvPr id="11" name="">
             <a:extLst xmlns:a="http://schemas.openxmlformats.org/drawingml/2006/main">
               <a:ext uri="{FF2B5EF4-FFF2-40B4-BE49-F238E27FC236}">
-                <a16:creationId xmlns:a16="http://schemas.microsoft.com/office/drawing/2014/main" id="{FB24AB85-E7B4-4FC3-A4E4-5B62B0D5F521}"/>
+                <a16:creationId xmlns:a16="http://schemas.microsoft.com/office/drawing/2014/main" id="{B0326984-B45C-4303-A5E1-E185CFE907FD}"/>
               </a:ext>
             </a:extLst>
           </p:cNvPr>
@@ -5474,7 +5474,7 @@
           <p:cNvPr id="12" name="">
             <a:extLst xmlns:a="http://schemas.openxmlformats.org/drawingml/2006/main">
               <a:ext uri="{FF2B5EF4-FFF2-40B4-BE49-F238E27FC236}">
-                <a16:creationId xmlns:a16="http://schemas.microsoft.com/office/drawing/2014/main" id="{60B0464E-201B-4114-A768-F7B2B683F9AF}"/>
+                <a16:creationId xmlns:a16="http://schemas.microsoft.com/office/drawing/2014/main" id="{D8FC1164-60B3-4D2F-8367-EC55E032A8E8}"/>
               </a:ext>
             </a:extLst>
           </p:cNvPr>
@@ -5509,7 +5509,7 @@
           <p:cNvPr id="13" name="">
             <a:extLst xmlns:a="http://schemas.openxmlformats.org/drawingml/2006/main">
               <a:ext uri="{FF2B5EF4-FFF2-40B4-BE49-F238E27FC236}">
-                <a16:creationId xmlns:a16="http://schemas.microsoft.com/office/drawing/2014/main" id="{1A3C25B0-0540-4E60-8D34-8E57A5E10EA8}"/>
+                <a16:creationId xmlns:a16="http://schemas.microsoft.com/office/drawing/2014/main" id="{C9E5E7F0-DFA7-4437-A3A8-6D1B13AA6E89}"/>
               </a:ext>
             </a:extLst>
           </p:cNvPr>
@@ -5563,7 +5563,7 @@
                 <a:ea typeface="Aptos Display"/>
                 <a:cs typeface="Aptos Display"/>
               </a:rPr>
-              <a:t>Conversion</a:t>
+              <a:t>Transformation</a:t>
             </a:r>
           </a:p>
         </p:txBody>
@@ -5573,7 +5573,7 @@
           <p:cNvPr id="14" name="">
             <a:extLst xmlns:a="http://schemas.openxmlformats.org/drawingml/2006/main">
               <a:ext uri="{FF2B5EF4-FFF2-40B4-BE49-F238E27FC236}">
-                <a16:creationId xmlns:a16="http://schemas.microsoft.com/office/drawing/2014/main" id="{F7A70CD7-4467-4751-BA2F-C6B9CF9CF32F}"/>
+                <a16:creationId xmlns:a16="http://schemas.microsoft.com/office/drawing/2014/main" id="{AA69B2A7-33A3-418C-AD21-151D3C22D64E}"/>
               </a:ext>
             </a:extLst>
           </p:cNvPr>
@@ -5608,7 +5608,7 @@
           <p:cNvPr id="15" name="">
             <a:extLst xmlns:a="http://schemas.openxmlformats.org/drawingml/2006/main">
               <a:ext uri="{FF2B5EF4-FFF2-40B4-BE49-F238E27FC236}">
-                <a16:creationId xmlns:a16="http://schemas.microsoft.com/office/drawing/2014/main" id="{4F802E9D-1781-419B-B658-E6FFA062477A}"/>
+                <a16:creationId xmlns:a16="http://schemas.microsoft.com/office/drawing/2014/main" id="{0671EA1C-306C-463E-B1DD-65B6F02B2B56}"/>
               </a:ext>
             </a:extLst>
           </p:cNvPr>
@@ -5662,7 +5662,7 @@
                 <a:ea typeface="Aptos"/>
                 <a:cs typeface="Aptos"/>
               </a:rPr>
-              <a:t>prospects additionnels convertis x valeur moyenne client actif</a:t>
+              <a:t>clients potentiels convertis x valeur moyenne client actif</a:t>
             </a:r>
           </a:p>
         </p:txBody>
@@ -5672,7 +5672,7 @@
           <p:cNvPr id="16" name="">
             <a:extLst xmlns:a="http://schemas.openxmlformats.org/drawingml/2006/main">
               <a:ext uri="{FF2B5EF4-FFF2-40B4-BE49-F238E27FC236}">
-                <a16:creationId xmlns:a16="http://schemas.microsoft.com/office/drawing/2014/main" id="{876873F2-7858-4B6B-94C3-BEF5D74CCDB9}"/>
+                <a16:creationId xmlns:a16="http://schemas.microsoft.com/office/drawing/2014/main" id="{B5CA4E1D-B88E-4DF3-B252-2D8B04E1F538}"/>
               </a:ext>
             </a:extLst>
           </p:cNvPr>
@@ -5705,7 +5705,7 @@
           <p:cNvPr id="17" name="">
             <a:extLst xmlns:a="http://schemas.openxmlformats.org/drawingml/2006/main">
               <a:ext uri="{FF2B5EF4-FFF2-40B4-BE49-F238E27FC236}">
-                <a16:creationId xmlns:a16="http://schemas.microsoft.com/office/drawing/2014/main" id="{40A11486-43C8-411A-983A-BFB9346D7B0C}"/>
+                <a16:creationId xmlns:a16="http://schemas.microsoft.com/office/drawing/2014/main" id="{4527325F-0A94-495F-845C-706804F89BA7}"/>
               </a:ext>
             </a:extLst>
           </p:cNvPr>
@@ -5740,7 +5740,7 @@
           <p:cNvPr id="18" name="">
             <a:extLst xmlns:a="http://schemas.openxmlformats.org/drawingml/2006/main">
               <a:ext uri="{FF2B5EF4-FFF2-40B4-BE49-F238E27FC236}">
-                <a16:creationId xmlns:a16="http://schemas.microsoft.com/office/drawing/2014/main" id="{F1CF857D-8C29-402A-95AB-F0FC14FD74D4}"/>
+                <a16:creationId xmlns:a16="http://schemas.microsoft.com/office/drawing/2014/main" id="{1845EEEE-87E2-48DF-8DD0-3C734F75A4D3}"/>
               </a:ext>
             </a:extLst>
           </p:cNvPr>
@@ -5804,7 +5804,7 @@
           <p:cNvPr id="19" name="">
             <a:extLst xmlns:a="http://schemas.openxmlformats.org/drawingml/2006/main">
               <a:ext uri="{FF2B5EF4-FFF2-40B4-BE49-F238E27FC236}">
-                <a16:creationId xmlns:a16="http://schemas.microsoft.com/office/drawing/2014/main" id="{7C8E4B14-1A56-4C75-AE39-9CCC2DD6933F}"/>
+                <a16:creationId xmlns:a16="http://schemas.microsoft.com/office/drawing/2014/main" id="{86E2FA87-6391-4CC0-80D5-FA31F6A864E0}"/>
               </a:ext>
             </a:extLst>
           </p:cNvPr>
@@ -5839,7 +5839,7 @@
           <p:cNvPr id="20" name="">
             <a:extLst xmlns:a="http://schemas.openxmlformats.org/drawingml/2006/main">
               <a:ext uri="{FF2B5EF4-FFF2-40B4-BE49-F238E27FC236}">
-                <a16:creationId xmlns:a16="http://schemas.microsoft.com/office/drawing/2014/main" id="{99DAC597-362F-4409-BA8F-567432CEFFA5}"/>
+                <a16:creationId xmlns:a16="http://schemas.microsoft.com/office/drawing/2014/main" id="{BD6BE8B0-B57A-4CA6-A011-241BE4A51E35}"/>
               </a:ext>
             </a:extLst>
           </p:cNvPr>
@@ -5903,7 +5903,7 @@
           <p:cNvPr id="21" name="">
             <a:extLst xmlns:a="http://schemas.openxmlformats.org/drawingml/2006/main">
               <a:ext uri="{FF2B5EF4-FFF2-40B4-BE49-F238E27FC236}">
-                <a16:creationId xmlns:a16="http://schemas.microsoft.com/office/drawing/2014/main" id="{A1B1EB37-58D0-4449-BEE7-4B85BCA1BEFF}"/>
+                <a16:creationId xmlns:a16="http://schemas.microsoft.com/office/drawing/2014/main" id="{3E38D268-0D20-4624-850B-23AF9F049DB5}"/>
               </a:ext>
             </a:extLst>
           </p:cNvPr>
@@ -5938,7 +5938,7 @@
           <p:cNvPr id="22" name="">
             <a:extLst xmlns:a="http://schemas.openxmlformats.org/drawingml/2006/main">
               <a:ext uri="{FF2B5EF4-FFF2-40B4-BE49-F238E27FC236}">
-                <a16:creationId xmlns:a16="http://schemas.microsoft.com/office/drawing/2014/main" id="{5DD53033-829D-4F0F-9091-31EF625789AF}"/>
+                <a16:creationId xmlns:a16="http://schemas.microsoft.com/office/drawing/2014/main" id="{D982E5B2-4D1F-4B6C-9177-54172DB2BDB1}"/>
               </a:ext>
             </a:extLst>
           </p:cNvPr>
@@ -6002,7 +6002,7 @@
           <p:cNvPr id="23" name="">
             <a:extLst xmlns:a="http://schemas.openxmlformats.org/drawingml/2006/main">
               <a:ext uri="{FF2B5EF4-FFF2-40B4-BE49-F238E27FC236}">
-                <a16:creationId xmlns:a16="http://schemas.microsoft.com/office/drawing/2014/main" id="{BBF3380E-72BF-47BF-A2B0-C795E57A4190}"/>
+                <a16:creationId xmlns:a16="http://schemas.microsoft.com/office/drawing/2014/main" id="{8168CCC2-DCF6-4C79-B0A4-6A2C97D91FEA}"/>
               </a:ext>
             </a:extLst>
           </p:cNvPr>
@@ -6056,7 +6056,7 @@
                 <a:ea typeface="Aptos"/>
                 <a:cs typeface="Aptos"/>
               </a:rPr>
-              <a:t>Je ne veux pas maquiller le business case. Le pilote sert justement a mesurer ces variables avec les chiffres BICEC.</a:t>
+              <a:t>Je ne veux pas maquiller le dossier economique. Le pilote sert justement a mesurer ces variables avec les chiffres BICEC.</a:t>
             </a:r>
           </a:p>
         </p:txBody>
@@ -6066,7 +6066,7 @@
           <p:cNvPr id="24" name="">
             <a:extLst xmlns:a="http://schemas.openxmlformats.org/drawingml/2006/main">
               <a:ext uri="{FF2B5EF4-FFF2-40B4-BE49-F238E27FC236}">
-                <a16:creationId xmlns:a16="http://schemas.microsoft.com/office/drawing/2014/main" id="{A9D81B04-CFFF-451F-AC19-21EE81FF88D5}"/>
+                <a16:creationId xmlns:a16="http://schemas.microsoft.com/office/drawing/2014/main" id="{46C3A9FE-B94F-455F-9A12-FC1F85B23077}"/>
               </a:ext>
             </a:extLst>
           </p:cNvPr>
@@ -6120,7 +6120,7 @@
                 <a:ea typeface="Aptos"/>
                 <a:cs typeface="Aptos"/>
               </a:rPr>
-              <a:t>Benchmarks prudents: Fenergo 2025 signale que 70% des institutions interrogees ont perdu des clients a cause d'un onboarding lent; a ne pas traiter comme chiffre BICEC.</a:t>
+              <a:t>Repere prudent: Fenergo 2025 signale que 70% des institutions interrogees ont perdu des clients a cause d'une entree en relation lente; a ne pas traiter comme chiffre BICEC.</a:t>
             </a:r>
           </a:p>
         </p:txBody>
@@ -6130,7 +6130,7 @@
           <p:cNvPr id="25" name="">
             <a:extLst xmlns:a="http://schemas.openxmlformats.org/drawingml/2006/main">
               <a:ext uri="{FF2B5EF4-FFF2-40B4-BE49-F238E27FC236}">
-                <a16:creationId xmlns:a16="http://schemas.microsoft.com/office/drawing/2014/main" id="{3B10EB99-4A15-4A6A-AA5E-AF3425D323EA}"/>
+                <a16:creationId xmlns:a16="http://schemas.microsoft.com/office/drawing/2014/main" id="{A348CA76-B7CE-4B76-A63C-12C7395F39B0}"/>
               </a:ext>
             </a:extLst>
           </p:cNvPr>
@@ -6165,7 +6165,7 @@
           <p:cNvPr id="26" name="">
             <a:extLst xmlns:a="http://schemas.openxmlformats.org/drawingml/2006/main">
               <a:ext uri="{FF2B5EF4-FFF2-40B4-BE49-F238E27FC236}">
-                <a16:creationId xmlns:a16="http://schemas.microsoft.com/office/drawing/2014/main" id="{345FE1A8-7954-41AD-AD0F-30B33CE157C9}"/>
+                <a16:creationId xmlns:a16="http://schemas.microsoft.com/office/drawing/2014/main" id="{78C77854-F623-4C9B-A4FE-D476F42FF33F}"/>
               </a:ext>
             </a:extLst>
           </p:cNvPr>
@@ -6219,7 +6219,7 @@
                 <a:ea typeface="Aptos"/>
                 <a:cs typeface="Aptos"/>
               </a:rPr>
-              <a:t>VeriPass - rail KYC souverain</a:t>
+              <a:t>VeriPass - connaissance client souveraine</a:t>
             </a:r>
           </a:p>
         </p:txBody>
@@ -6229,7 +6229,7 @@
           <p:cNvPr id="27" name="">
             <a:extLst xmlns:a="http://schemas.openxmlformats.org/drawingml/2006/main">
               <a:ext uri="{FF2B5EF4-FFF2-40B4-BE49-F238E27FC236}">
-                <a16:creationId xmlns:a16="http://schemas.microsoft.com/office/drawing/2014/main" id="{36B1A9F7-BC78-4D8A-ACF8-4158012F5C80}"/>
+                <a16:creationId xmlns:a16="http://schemas.microsoft.com/office/drawing/2014/main" id="{4A43F40D-709D-48D4-886E-394C6FF1BF78}"/>
               </a:ext>
             </a:extLst>
           </p:cNvPr>
@@ -6291,7 +6291,7 @@
     </p:spTree>
     <p:extLst>
       <p:ext uri="{BB962C8B-B14F-4D97-AF65-F5344CB8AC3E}">
-        <p14:creationId xmlns:p14="http://schemas.microsoft.com/office/powerpoint/2010/main" val="1334746005"/>
+        <p14:creationId xmlns:p14="http://schemas.microsoft.com/office/powerpoint/2010/main" val="1480529191"/>
       </p:ext>
     </p:extLst>
   </p:cSld>
@@ -6315,7 +6315,7 @@
           <p:cNvPr id="1" name="">
             <a:extLst xmlns:a="http://schemas.openxmlformats.org/drawingml/2006/main">
               <a:ext uri="{FF2B5EF4-FFF2-40B4-BE49-F238E27FC236}">
-                <a16:creationId xmlns:a16="http://schemas.microsoft.com/office/drawing/2014/main" id="{57375283-314F-465B-87FE-8CC86346632B}"/>
+                <a16:creationId xmlns:a16="http://schemas.microsoft.com/office/drawing/2014/main" id="{556D19C0-FCE2-4A9B-9F04-244021546FC3}"/>
               </a:ext>
             </a:extLst>
           </p:cNvPr>
@@ -6350,7 +6350,7 @@
           <p:cNvPr id="2" name="">
             <a:extLst xmlns:a="http://schemas.openxmlformats.org/drawingml/2006/main">
               <a:ext uri="{FF2B5EF4-FFF2-40B4-BE49-F238E27FC236}">
-                <a16:creationId xmlns:a16="http://schemas.microsoft.com/office/drawing/2014/main" id="{9763FDA1-818C-4D39-8861-1FB5584C9DD2}"/>
+                <a16:creationId xmlns:a16="http://schemas.microsoft.com/office/drawing/2014/main" id="{6AF482DB-7374-44BB-8614-E46D6889DB1E}"/>
               </a:ext>
             </a:extLst>
           </p:cNvPr>
@@ -6385,7 +6385,7 @@
           <p:cNvPr id="3" name="">
             <a:extLst xmlns:a="http://schemas.openxmlformats.org/drawingml/2006/main">
               <a:ext uri="{FF2B5EF4-FFF2-40B4-BE49-F238E27FC236}">
-                <a16:creationId xmlns:a16="http://schemas.microsoft.com/office/drawing/2014/main" id="{2146998D-8445-4213-94E2-A0B6C4C69FC1}"/>
+                <a16:creationId xmlns:a16="http://schemas.microsoft.com/office/drawing/2014/main" id="{FCB4A7E0-5278-4132-ABB4-C56A09F85DAC}"/>
               </a:ext>
             </a:extLst>
           </p:cNvPr>
@@ -6420,7 +6420,7 @@
           <p:cNvPr id="4" name="">
             <a:extLst xmlns:a="http://schemas.openxmlformats.org/drawingml/2006/main">
               <a:ext uri="{FF2B5EF4-FFF2-40B4-BE49-F238E27FC236}">
-                <a16:creationId xmlns:a16="http://schemas.microsoft.com/office/drawing/2014/main" id="{53BDB2F6-5B70-4287-BE9D-4A26D1E149B0}"/>
+                <a16:creationId xmlns:a16="http://schemas.microsoft.com/office/drawing/2014/main" id="{D860F9EC-3A27-4124-A5D0-2538CD8620F8}"/>
               </a:ext>
             </a:extLst>
           </p:cNvPr>
@@ -6459,7 +6459,7 @@
           <p:nvPr/>
         </p:nvPicPr>
         <p:blipFill>
-          <a:blip xmlns:r="http://schemas.openxmlformats.org/officeDocument/2006/relationships" xmlns:a="http://schemas.openxmlformats.org/drawingml/2006/main" r:embed="R3c0d06d5b9c44b8c"/>
+          <a:blip xmlns:r="http://schemas.openxmlformats.org/officeDocument/2006/relationships" xmlns:a="http://schemas.openxmlformats.org/drawingml/2006/main" r:embed="R47aaee10252f4735"/>
           <a:stretch xmlns:a="http://schemas.openxmlformats.org/drawingml/2006/main"/>
         </p:blipFill>
         <p:spPr>
@@ -6477,7 +6477,7 @@
           <p:cNvPr id="6" name="">
             <a:extLst xmlns:a="http://schemas.openxmlformats.org/drawingml/2006/main">
               <a:ext uri="{FF2B5EF4-FFF2-40B4-BE49-F238E27FC236}">
-                <a16:creationId xmlns:a16="http://schemas.microsoft.com/office/drawing/2014/main" id="{A4C6EAAF-33CC-477F-B81D-B817E4D40524}"/>
+                <a16:creationId xmlns:a16="http://schemas.microsoft.com/office/drawing/2014/main" id="{458B4DD3-8671-485A-A5E4-E7C4C34E8B7C}"/>
               </a:ext>
             </a:extLst>
           </p:cNvPr>
@@ -6541,7 +6541,7 @@
           <p:cNvPr id="7" name="">
             <a:extLst xmlns:a="http://schemas.openxmlformats.org/drawingml/2006/main">
               <a:ext uri="{FF2B5EF4-FFF2-40B4-BE49-F238E27FC236}">
-                <a16:creationId xmlns:a16="http://schemas.microsoft.com/office/drawing/2014/main" id="{6EF38476-F41B-4495-847D-4415A958BD49}"/>
+                <a16:creationId xmlns:a16="http://schemas.microsoft.com/office/drawing/2014/main" id="{B3EF932A-6421-491B-A472-E76EE3C6DBBC}"/>
               </a:ext>
             </a:extLst>
           </p:cNvPr>
@@ -6576,7 +6576,7 @@
           <p:cNvPr id="8" name="">
             <a:extLst xmlns:a="http://schemas.openxmlformats.org/drawingml/2006/main">
               <a:ext uri="{FF2B5EF4-FFF2-40B4-BE49-F238E27FC236}">
-                <a16:creationId xmlns:a16="http://schemas.microsoft.com/office/drawing/2014/main" id="{11158C1D-CF46-45EA-8E1D-FC4EF8886668}"/>
+                <a16:creationId xmlns:a16="http://schemas.microsoft.com/office/drawing/2014/main" id="{B709C709-5545-4317-9A6C-B4179F15D2CE}"/>
               </a:ext>
             </a:extLst>
           </p:cNvPr>
@@ -6640,7 +6640,7 @@
           <p:cNvPr id="9" name="">
             <a:extLst xmlns:a="http://schemas.openxmlformats.org/drawingml/2006/main">
               <a:ext uri="{FF2B5EF4-FFF2-40B4-BE49-F238E27FC236}">
-                <a16:creationId xmlns:a16="http://schemas.microsoft.com/office/drawing/2014/main" id="{858FF7C5-8583-4913-949B-0DCF6D6D3447}"/>
+                <a16:creationId xmlns:a16="http://schemas.microsoft.com/office/drawing/2014/main" id="{7F6E4B3C-5152-45F6-AA85-C68C00DECC7E}"/>
               </a:ext>
             </a:extLst>
           </p:cNvPr>
@@ -6704,7 +6704,7 @@
           <p:cNvPr id="10" name="">
             <a:extLst xmlns:a="http://schemas.openxmlformats.org/drawingml/2006/main">
               <a:ext uri="{FF2B5EF4-FFF2-40B4-BE49-F238E27FC236}">
-                <a16:creationId xmlns:a16="http://schemas.microsoft.com/office/drawing/2014/main" id="{5C48C66E-5D00-4914-BB18-65E8AC5FBEB2}"/>
+                <a16:creationId xmlns:a16="http://schemas.microsoft.com/office/drawing/2014/main" id="{207EF981-61CB-4E4E-9517-E540B2C3D7DE}"/>
               </a:ext>
             </a:extLst>
           </p:cNvPr>
@@ -6758,7 +6758,7 @@
                 <a:ea typeface="Aptos"/>
                 <a:cs typeface="Aptos"/>
               </a:rPr>
-              <a:t>La demande n'est pas un deploiement national. La demande est une beta interne sponsorisee, mesuree et encadree.</a:t>
+              <a:t>La demande n'est pas un deploiement national. La demande est une phase d'essai interne portee, mesuree et encadree.</a:t>
             </a:r>
           </a:p>
         </p:txBody>
@@ -6768,7 +6768,7 @@
           <p:cNvPr id="11" name="">
             <a:extLst xmlns:a="http://schemas.openxmlformats.org/drawingml/2006/main">
               <a:ext uri="{FF2B5EF4-FFF2-40B4-BE49-F238E27FC236}">
-                <a16:creationId xmlns:a16="http://schemas.microsoft.com/office/drawing/2014/main" id="{96B7ACCB-3B19-49F3-A6C6-A618F6F9137C}"/>
+                <a16:creationId xmlns:a16="http://schemas.microsoft.com/office/drawing/2014/main" id="{DCE960F2-CD71-4B16-AD99-7057ECDAB49C}"/>
               </a:ext>
             </a:extLst>
           </p:cNvPr>
@@ -6801,7 +6801,7 @@
           <p:cNvPr id="12" name="">
             <a:extLst xmlns:a="http://schemas.openxmlformats.org/drawingml/2006/main">
               <a:ext uri="{FF2B5EF4-FFF2-40B4-BE49-F238E27FC236}">
-                <a16:creationId xmlns:a16="http://schemas.microsoft.com/office/drawing/2014/main" id="{2AEBE28F-5107-4A30-BB32-2CDC0379B80C}"/>
+                <a16:creationId xmlns:a16="http://schemas.microsoft.com/office/drawing/2014/main" id="{E57674D9-0133-4DCD-8819-19B0990358FB}"/>
               </a:ext>
             </a:extLst>
           </p:cNvPr>
@@ -6836,7 +6836,7 @@
           <p:cNvPr id="13" name="">
             <a:extLst xmlns:a="http://schemas.openxmlformats.org/drawingml/2006/main">
               <a:ext uri="{FF2B5EF4-FFF2-40B4-BE49-F238E27FC236}">
-                <a16:creationId xmlns:a16="http://schemas.microsoft.com/office/drawing/2014/main" id="{1A71B2DB-BF52-448D-9C2E-F68299FB0123}"/>
+                <a16:creationId xmlns:a16="http://schemas.microsoft.com/office/drawing/2014/main" id="{767C025C-5F99-4751-8FB6-6F9B49AC7FB0}"/>
               </a:ext>
             </a:extLst>
           </p:cNvPr>
@@ -6900,7 +6900,7 @@
           <p:cNvPr id="14" name="">
             <a:extLst xmlns:a="http://schemas.openxmlformats.org/drawingml/2006/main">
               <a:ext uri="{FF2B5EF4-FFF2-40B4-BE49-F238E27FC236}">
-                <a16:creationId xmlns:a16="http://schemas.microsoft.com/office/drawing/2014/main" id="{ABFD510B-E800-4A11-BE94-7FDCBD422F63}"/>
+                <a16:creationId xmlns:a16="http://schemas.microsoft.com/office/drawing/2014/main" id="{C0932EF3-0FA0-4C31-AA76-D6B008BC453B}"/>
               </a:ext>
             </a:extLst>
           </p:cNvPr>
@@ -6954,7 +6954,7 @@
                 <a:ea typeface="Aptos Display"/>
                 <a:cs typeface="Aptos Display"/>
               </a:rPr>
-              <a:t>Nommer un sponsor</a:t>
+              <a:t>Nommer un porteur</a:t>
             </a:r>
           </a:p>
         </p:txBody>
@@ -6964,7 +6964,7 @@
           <p:cNvPr id="15" name="">
             <a:extLst xmlns:a="http://schemas.openxmlformats.org/drawingml/2006/main">
               <a:ext uri="{FF2B5EF4-FFF2-40B4-BE49-F238E27FC236}">
-                <a16:creationId xmlns:a16="http://schemas.microsoft.com/office/drawing/2014/main" id="{35B91B56-C2A5-477E-9CF8-F4D606B368BB}"/>
+                <a16:creationId xmlns:a16="http://schemas.microsoft.com/office/drawing/2014/main" id="{E2F41C08-EE6F-4DFF-862D-65CC31C08D3A}"/>
               </a:ext>
             </a:extLst>
           </p:cNvPr>
@@ -7028,7 +7028,7 @@
           <p:cNvPr id="16" name="">
             <a:extLst xmlns:a="http://schemas.openxmlformats.org/drawingml/2006/main">
               <a:ext uri="{FF2B5EF4-FFF2-40B4-BE49-F238E27FC236}">
-                <a16:creationId xmlns:a16="http://schemas.microsoft.com/office/drawing/2014/main" id="{E0215987-FC4B-46E2-9046-9AA9B9C13809}"/>
+                <a16:creationId xmlns:a16="http://schemas.microsoft.com/office/drawing/2014/main" id="{1B70A1AB-90C8-48F7-A3D7-859FF8310625}"/>
               </a:ext>
             </a:extLst>
           </p:cNvPr>
@@ -7061,7 +7061,7 @@
           <p:cNvPr id="17" name="">
             <a:extLst xmlns:a="http://schemas.openxmlformats.org/drawingml/2006/main">
               <a:ext uri="{FF2B5EF4-FFF2-40B4-BE49-F238E27FC236}">
-                <a16:creationId xmlns:a16="http://schemas.microsoft.com/office/drawing/2014/main" id="{B384CADE-C640-478E-B0E0-550B49D572B4}"/>
+                <a16:creationId xmlns:a16="http://schemas.microsoft.com/office/drawing/2014/main" id="{B7D4FD88-3C34-4CCA-AABF-7243391F42C9}"/>
               </a:ext>
             </a:extLst>
           </p:cNvPr>
@@ -7096,7 +7096,7 @@
           <p:cNvPr id="18" name="">
             <a:extLst xmlns:a="http://schemas.openxmlformats.org/drawingml/2006/main">
               <a:ext uri="{FF2B5EF4-FFF2-40B4-BE49-F238E27FC236}">
-                <a16:creationId xmlns:a16="http://schemas.microsoft.com/office/drawing/2014/main" id="{A99D8827-8C42-48E9-88C6-5AFA308CB11A}"/>
+                <a16:creationId xmlns:a16="http://schemas.microsoft.com/office/drawing/2014/main" id="{0552E6DF-071E-44DF-9D94-887FD28056C3}"/>
               </a:ext>
             </a:extLst>
           </p:cNvPr>
@@ -7160,7 +7160,7 @@
           <p:cNvPr id="19" name="">
             <a:extLst xmlns:a="http://schemas.openxmlformats.org/drawingml/2006/main">
               <a:ext uri="{FF2B5EF4-FFF2-40B4-BE49-F238E27FC236}">
-                <a16:creationId xmlns:a16="http://schemas.microsoft.com/office/drawing/2014/main" id="{77EC2A9D-D199-4B14-BCED-9B62F32059D0}"/>
+                <a16:creationId xmlns:a16="http://schemas.microsoft.com/office/drawing/2014/main" id="{FE20F4F0-A870-4275-863C-6E100F7A04EC}"/>
               </a:ext>
             </a:extLst>
           </p:cNvPr>
@@ -7214,7 +7214,7 @@
                 <a:ea typeface="Aptos Display"/>
                 <a:cs typeface="Aptos Display"/>
               </a:rPr>
-              <a:t>Autoriser la beta</a:t>
+              <a:t>Autoriser l'essai</a:t>
             </a:r>
           </a:p>
         </p:txBody>
@@ -7224,7 +7224,7 @@
           <p:cNvPr id="20" name="">
             <a:extLst xmlns:a="http://schemas.openxmlformats.org/drawingml/2006/main">
               <a:ext uri="{FF2B5EF4-FFF2-40B4-BE49-F238E27FC236}">
-                <a16:creationId xmlns:a16="http://schemas.microsoft.com/office/drawing/2014/main" id="{5E0F759A-DD53-4D53-B46A-848C19643C8D}"/>
+                <a16:creationId xmlns:a16="http://schemas.microsoft.com/office/drawing/2014/main" id="{0F55BC0C-FAB2-4775-9A3F-FEC70508B39B}"/>
               </a:ext>
             </a:extLst>
           </p:cNvPr>
@@ -7278,7 +7278,7 @@
                 <a:ea typeface="Aptos"/>
                 <a:cs typeface="Aptos"/>
               </a:rPr>
-              <a:t>acces encadre au MVP</a:t>
+              <a:t>acces encadre a la version</a:t>
             </a:r>
           </a:p>
         </p:txBody>
@@ -7288,7 +7288,7 @@
           <p:cNvPr id="21" name="">
             <a:extLst xmlns:a="http://schemas.openxmlformats.org/drawingml/2006/main">
               <a:ext uri="{FF2B5EF4-FFF2-40B4-BE49-F238E27FC236}">
-                <a16:creationId xmlns:a16="http://schemas.microsoft.com/office/drawing/2014/main" id="{382BE279-95CC-490A-9C22-B50788C3222D}"/>
+                <a16:creationId xmlns:a16="http://schemas.microsoft.com/office/drawing/2014/main" id="{DC4BDD66-CB54-42EE-AD59-515995C02DD7}"/>
               </a:ext>
             </a:extLst>
           </p:cNvPr>
@@ -7321,7 +7321,7 @@
           <p:cNvPr id="22" name="">
             <a:extLst xmlns:a="http://schemas.openxmlformats.org/drawingml/2006/main">
               <a:ext uri="{FF2B5EF4-FFF2-40B4-BE49-F238E27FC236}">
-                <a16:creationId xmlns:a16="http://schemas.microsoft.com/office/drawing/2014/main" id="{872E3381-CB97-41F1-8874-EDB88A0076CE}"/>
+                <a16:creationId xmlns:a16="http://schemas.microsoft.com/office/drawing/2014/main" id="{B4111A37-6BF9-4D29-A143-1CCD04C1A4BC}"/>
               </a:ext>
             </a:extLst>
           </p:cNvPr>
@@ -7356,7 +7356,7 @@
           <p:cNvPr id="23" name="">
             <a:extLst xmlns:a="http://schemas.openxmlformats.org/drawingml/2006/main">
               <a:ext uri="{FF2B5EF4-FFF2-40B4-BE49-F238E27FC236}">
-                <a16:creationId xmlns:a16="http://schemas.microsoft.com/office/drawing/2014/main" id="{AA8CD0DB-4964-433C-B00B-29A810309550}"/>
+                <a16:creationId xmlns:a16="http://schemas.microsoft.com/office/drawing/2014/main" id="{23F701A7-7E47-4B86-949F-0DBFF2C1FBEC}"/>
               </a:ext>
             </a:extLst>
           </p:cNvPr>
@@ -7420,7 +7420,7 @@
           <p:cNvPr id="24" name="">
             <a:extLst xmlns:a="http://schemas.openxmlformats.org/drawingml/2006/main">
               <a:ext uri="{FF2B5EF4-FFF2-40B4-BE49-F238E27FC236}">
-                <a16:creationId xmlns:a16="http://schemas.microsoft.com/office/drawing/2014/main" id="{66EFE5C0-4262-4CC3-B606-A40FB12AAA97}"/>
+                <a16:creationId xmlns:a16="http://schemas.microsoft.com/office/drawing/2014/main" id="{5E810977-7794-4B8D-A062-CF50FABC83C3}"/>
               </a:ext>
             </a:extLst>
           </p:cNvPr>
@@ -7474,7 +7474,7 @@
                 <a:ea typeface="Aptos Display"/>
                 <a:cs typeface="Aptos Display"/>
               </a:rPr>
-              <a:t>Collecter la baseline</a:t>
+              <a:t>Mesurer l'etat initial</a:t>
             </a:r>
           </a:p>
         </p:txBody>
@@ -7484,7 +7484,7 @@
           <p:cNvPr id="25" name="">
             <a:extLst xmlns:a="http://schemas.openxmlformats.org/drawingml/2006/main">
               <a:ext uri="{FF2B5EF4-FFF2-40B4-BE49-F238E27FC236}">
-                <a16:creationId xmlns:a16="http://schemas.microsoft.com/office/drawing/2014/main" id="{752A7E93-9CB4-4C37-A81F-08F52C96E046}"/>
+                <a16:creationId xmlns:a16="http://schemas.microsoft.com/office/drawing/2014/main" id="{26CCAF4E-2C5B-4666-878B-758707AEA63A}"/>
               </a:ext>
             </a:extLst>
           </p:cNvPr>
@@ -7538,7 +7538,7 @@
                 <a:ea typeface="Aptos"/>
                 <a:cs typeface="Aptos"/>
               </a:rPr>
-              <a:t>delais, rework, abandon, cout</a:t>
+              <a:t>delais, reprises, abandon, cout</a:t>
             </a:r>
           </a:p>
         </p:txBody>
@@ -7548,7 +7548,7 @@
           <p:cNvPr id="26" name="">
             <a:extLst xmlns:a="http://schemas.openxmlformats.org/drawingml/2006/main">
               <a:ext uri="{FF2B5EF4-FFF2-40B4-BE49-F238E27FC236}">
-                <a16:creationId xmlns:a16="http://schemas.microsoft.com/office/drawing/2014/main" id="{ABD0397E-5BE5-47E7-994F-96892BC01352}"/>
+                <a16:creationId xmlns:a16="http://schemas.microsoft.com/office/drawing/2014/main" id="{06CB0838-370F-4EE1-8098-3B741E67BE4E}"/>
               </a:ext>
             </a:extLst>
           </p:cNvPr>
@@ -7581,7 +7581,7 @@
           <p:cNvPr id="27" name="">
             <a:extLst xmlns:a="http://schemas.openxmlformats.org/drawingml/2006/main">
               <a:ext uri="{FF2B5EF4-FFF2-40B4-BE49-F238E27FC236}">
-                <a16:creationId xmlns:a16="http://schemas.microsoft.com/office/drawing/2014/main" id="{9E697F5C-BCEC-4097-A7C4-223859E2FA17}"/>
+                <a16:creationId xmlns:a16="http://schemas.microsoft.com/office/drawing/2014/main" id="{FFFEEE00-5780-48B6-81F5-29D2E71200A7}"/>
               </a:ext>
             </a:extLst>
           </p:cNvPr>
@@ -7616,7 +7616,7 @@
           <p:cNvPr id="28" name="">
             <a:extLst xmlns:a="http://schemas.openxmlformats.org/drawingml/2006/main">
               <a:ext uri="{FF2B5EF4-FFF2-40B4-BE49-F238E27FC236}">
-                <a16:creationId xmlns:a16="http://schemas.microsoft.com/office/drawing/2014/main" id="{C85252A9-815A-482A-B1B1-6D327F02E88A}"/>
+                <a16:creationId xmlns:a16="http://schemas.microsoft.com/office/drawing/2014/main" id="{80588858-D08A-40C0-94EF-9FD5A68E47DC}"/>
               </a:ext>
             </a:extLst>
           </p:cNvPr>
@@ -7680,7 +7680,7 @@
           <p:cNvPr id="29" name="">
             <a:extLst xmlns:a="http://schemas.openxmlformats.org/drawingml/2006/main">
               <a:ext uri="{FF2B5EF4-FFF2-40B4-BE49-F238E27FC236}">
-                <a16:creationId xmlns:a16="http://schemas.microsoft.com/office/drawing/2014/main" id="{B741CEC8-B027-4466-B59F-0EF4F1BBF5FE}"/>
+                <a16:creationId xmlns:a16="http://schemas.microsoft.com/office/drawing/2014/main" id="{CA2AD651-2935-4E50-8C8B-F99B7C2424EA}"/>
               </a:ext>
             </a:extLst>
           </p:cNvPr>
@@ -7744,7 +7744,7 @@
           <p:cNvPr id="30" name="">
             <a:extLst xmlns:a="http://schemas.openxmlformats.org/drawingml/2006/main">
               <a:ext uri="{FF2B5EF4-FFF2-40B4-BE49-F238E27FC236}">
-                <a16:creationId xmlns:a16="http://schemas.microsoft.com/office/drawing/2014/main" id="{DE716E6F-E8B3-430C-9B4E-D279F3E59DD9}"/>
+                <a16:creationId xmlns:a16="http://schemas.microsoft.com/office/drawing/2014/main" id="{FD0069E4-94C6-4745-AD57-286A027B7AFD}"/>
               </a:ext>
             </a:extLst>
           </p:cNvPr>
@@ -7798,7 +7798,7 @@
                 <a:ea typeface="Aptos"/>
                 <a:cs typeface="Aptos"/>
               </a:rPr>
-              <a:t>go / no-go / phase 2</a:t>
+              <a:t>continuer / arreter / phase 2</a:t>
             </a:r>
           </a:p>
         </p:txBody>
@@ -7808,7 +7808,7 @@
           <p:cNvPr id="31" name="">
             <a:extLst xmlns:a="http://schemas.openxmlformats.org/drawingml/2006/main">
               <a:ext uri="{FF2B5EF4-FFF2-40B4-BE49-F238E27FC236}">
-                <a16:creationId xmlns:a16="http://schemas.microsoft.com/office/drawing/2014/main" id="{4596D6D1-2C3A-4379-8F38-14796DDE7B87}"/>
+                <a16:creationId xmlns:a16="http://schemas.microsoft.com/office/drawing/2014/main" id="{3DB50520-664A-42D1-A11D-9CC9D72A95B6}"/>
               </a:ext>
             </a:extLst>
           </p:cNvPr>
@@ -7843,7 +7843,7 @@
           <p:cNvPr id="32" name="">
             <a:extLst xmlns:a="http://schemas.openxmlformats.org/drawingml/2006/main">
               <a:ext uri="{FF2B5EF4-FFF2-40B4-BE49-F238E27FC236}">
-                <a16:creationId xmlns:a16="http://schemas.microsoft.com/office/drawing/2014/main" id="{B915F1E1-A9AF-4B8D-9E12-E0CF3B32F066}"/>
+                <a16:creationId xmlns:a16="http://schemas.microsoft.com/office/drawing/2014/main" id="{3F251EBE-5B9F-486C-9F22-3257E7BC8B28}"/>
               </a:ext>
             </a:extLst>
           </p:cNvPr>
@@ -7907,7 +7907,7 @@
           <p:cNvPr id="33" name="">
             <a:extLst xmlns:a="http://schemas.openxmlformats.org/drawingml/2006/main">
               <a:ext uri="{FF2B5EF4-FFF2-40B4-BE49-F238E27FC236}">
-                <a16:creationId xmlns:a16="http://schemas.microsoft.com/office/drawing/2014/main" id="{4293F07D-9E62-4E84-9A33-4DA243CC1439}"/>
+                <a16:creationId xmlns:a16="http://schemas.microsoft.com/office/drawing/2014/main" id="{15FB9EA9-BD79-492A-807C-4916DB8A54DC}"/>
               </a:ext>
             </a:extLst>
           </p:cNvPr>
@@ -7971,7 +7971,7 @@
           <p:cNvPr id="34" name="">
             <a:extLst xmlns:a="http://schemas.openxmlformats.org/drawingml/2006/main">
               <a:ext uri="{FF2B5EF4-FFF2-40B4-BE49-F238E27FC236}">
-                <a16:creationId xmlns:a16="http://schemas.microsoft.com/office/drawing/2014/main" id="{2B957A0C-354E-4236-A826-2E50EF1F40B8}"/>
+                <a16:creationId xmlns:a16="http://schemas.microsoft.com/office/drawing/2014/main" id="{40217D9F-DEC1-4A3A-BEE4-F14D9A37038A}"/>
               </a:ext>
             </a:extLst>
           </p:cNvPr>
@@ -8035,7 +8035,7 @@
           <p:cNvPr id="35" name="">
             <a:extLst xmlns:a="http://schemas.openxmlformats.org/drawingml/2006/main">
               <a:ext uri="{FF2B5EF4-FFF2-40B4-BE49-F238E27FC236}">
-                <a16:creationId xmlns:a16="http://schemas.microsoft.com/office/drawing/2014/main" id="{DCF6AEF7-736F-4CFA-8DE0-14E0E2F33619}"/>
+                <a16:creationId xmlns:a16="http://schemas.microsoft.com/office/drawing/2014/main" id="{22ABB82A-ADF8-4A47-8277-63F58545266E}"/>
               </a:ext>
             </a:extLst>
           </p:cNvPr>
@@ -8070,7 +8070,7 @@
           <p:cNvPr id="36" name="">
             <a:extLst xmlns:a="http://schemas.openxmlformats.org/drawingml/2006/main">
               <a:ext uri="{FF2B5EF4-FFF2-40B4-BE49-F238E27FC236}">
-                <a16:creationId xmlns:a16="http://schemas.microsoft.com/office/drawing/2014/main" id="{2FF1572F-B8DF-43B2-AA2C-61AA403CD7EE}"/>
+                <a16:creationId xmlns:a16="http://schemas.microsoft.com/office/drawing/2014/main" id="{E727434E-61CC-43D3-A353-934A5519EF45}"/>
               </a:ext>
             </a:extLst>
           </p:cNvPr>
@@ -8134,7 +8134,7 @@
           <p:cNvPr id="37" name="">
             <a:extLst xmlns:a="http://schemas.openxmlformats.org/drawingml/2006/main">
               <a:ext uri="{FF2B5EF4-FFF2-40B4-BE49-F238E27FC236}">
-                <a16:creationId xmlns:a16="http://schemas.microsoft.com/office/drawing/2014/main" id="{B15B97FE-EB79-4EC6-88EF-DF65796073B9}"/>
+                <a16:creationId xmlns:a16="http://schemas.microsoft.com/office/drawing/2014/main" id="{FCF57804-E994-4786-AD57-9AB91043D73F}"/>
               </a:ext>
             </a:extLst>
           </p:cNvPr>
@@ -8196,7 +8196,7 @@
     </p:spTree>
     <p:extLst>
       <p:ext uri="{BB962C8B-B14F-4D97-AF65-F5344CB8AC3E}">
-        <p14:creationId xmlns:p14="http://schemas.microsoft.com/office/powerpoint/2010/main" val="405668845"/>
+        <p14:creationId xmlns:p14="http://schemas.microsoft.com/office/powerpoint/2010/main" val="1577494510"/>
       </p:ext>
     </p:extLst>
   </p:cSld>
@@ -8220,7 +8220,7 @@
           <p:cNvPr id="1" name="">
             <a:extLst xmlns:a="http://schemas.openxmlformats.org/drawingml/2006/main">
               <a:ext uri="{FF2B5EF4-FFF2-40B4-BE49-F238E27FC236}">
-                <a16:creationId xmlns:a16="http://schemas.microsoft.com/office/drawing/2014/main" id="{73354AB5-6624-41BA-90C5-DC4FBA38900F}"/>
+                <a16:creationId xmlns:a16="http://schemas.microsoft.com/office/drawing/2014/main" id="{1C8642C7-4850-4371-B43D-B749B0C01008}"/>
               </a:ext>
             </a:extLst>
           </p:cNvPr>
@@ -8255,7 +8255,7 @@
           <p:cNvPr id="2" name="">
             <a:extLst xmlns:a="http://schemas.openxmlformats.org/drawingml/2006/main">
               <a:ext uri="{FF2B5EF4-FFF2-40B4-BE49-F238E27FC236}">
-                <a16:creationId xmlns:a16="http://schemas.microsoft.com/office/drawing/2014/main" id="{E11F44BA-7D8C-42BC-8B34-8A26ABC91075}"/>
+                <a16:creationId xmlns:a16="http://schemas.microsoft.com/office/drawing/2014/main" id="{D7C3444F-B9DB-4F4E-806E-FC3064753DB4}"/>
               </a:ext>
             </a:extLst>
           </p:cNvPr>
@@ -8290,7 +8290,7 @@
           <p:cNvPr id="3" name="">
             <a:extLst xmlns:a="http://schemas.openxmlformats.org/drawingml/2006/main">
               <a:ext uri="{FF2B5EF4-FFF2-40B4-BE49-F238E27FC236}">
-                <a16:creationId xmlns:a16="http://schemas.microsoft.com/office/drawing/2014/main" id="{89751979-AFF6-4E8B-B7C7-B1216A42908A}"/>
+                <a16:creationId xmlns:a16="http://schemas.microsoft.com/office/drawing/2014/main" id="{A24ED096-6212-4ACB-B76D-F268BACBE822}"/>
               </a:ext>
             </a:extLst>
           </p:cNvPr>
@@ -8354,7 +8354,7 @@
           <p:cNvPr id="4" name="">
             <a:extLst xmlns:a="http://schemas.openxmlformats.org/drawingml/2006/main">
               <a:ext uri="{FF2B5EF4-FFF2-40B4-BE49-F238E27FC236}">
-                <a16:creationId xmlns:a16="http://schemas.microsoft.com/office/drawing/2014/main" id="{0E4B2C75-E58C-4405-8794-AC1F8BD768BA}"/>
+                <a16:creationId xmlns:a16="http://schemas.microsoft.com/office/drawing/2014/main" id="{31D5F2A1-FEE4-45A4-86EA-6526103CB3D7}"/>
               </a:ext>
             </a:extLst>
           </p:cNvPr>
@@ -8418,7 +8418,7 @@
           <p:cNvPr id="5" name="">
             <a:extLst xmlns:a="http://schemas.openxmlformats.org/drawingml/2006/main">
               <a:ext uri="{FF2B5EF4-FFF2-40B4-BE49-F238E27FC236}">
-                <a16:creationId xmlns:a16="http://schemas.microsoft.com/office/drawing/2014/main" id="{7E2AC77B-D35E-4EFB-909A-911070C246EC}"/>
+                <a16:creationId xmlns:a16="http://schemas.microsoft.com/office/drawing/2014/main" id="{ED7D95CC-49BD-4295-9E52-B031BB5277DA}"/>
               </a:ext>
             </a:extLst>
           </p:cNvPr>
@@ -8482,7 +8482,7 @@
           <p:cNvPr id="6" name="">
             <a:extLst xmlns:a="http://schemas.openxmlformats.org/drawingml/2006/main">
               <a:ext uri="{FF2B5EF4-FFF2-40B4-BE49-F238E27FC236}">
-                <a16:creationId xmlns:a16="http://schemas.microsoft.com/office/drawing/2014/main" id="{7AD52620-1444-4FC9-9ED2-9BC12ECFA1EA}"/>
+                <a16:creationId xmlns:a16="http://schemas.microsoft.com/office/drawing/2014/main" id="{C293B0DF-A0DE-4A52-BCA9-DCC09F87B6BF}"/>
               </a:ext>
             </a:extLst>
           </p:cNvPr>
@@ -8517,7 +8517,7 @@
           <p:cNvPr id="7" name="">
             <a:extLst xmlns:a="http://schemas.openxmlformats.org/drawingml/2006/main">
               <a:ext uri="{FF2B5EF4-FFF2-40B4-BE49-F238E27FC236}">
-                <a16:creationId xmlns:a16="http://schemas.microsoft.com/office/drawing/2014/main" id="{27F66AF8-F0C9-461D-9583-5C7FF43D9B0A}"/>
+                <a16:creationId xmlns:a16="http://schemas.microsoft.com/office/drawing/2014/main" id="{DAADFEA6-6E52-4252-B7A3-B3889E1E09D1}"/>
               </a:ext>
             </a:extLst>
           </p:cNvPr>
@@ -8581,7 +8581,7 @@
           <p:cNvPr id="8" name="">
             <a:extLst xmlns:a="http://schemas.openxmlformats.org/drawingml/2006/main">
               <a:ext uri="{FF2B5EF4-FFF2-40B4-BE49-F238E27FC236}">
-                <a16:creationId xmlns:a16="http://schemas.microsoft.com/office/drawing/2014/main" id="{30DCD04F-D5AF-4ADC-9E9D-7386B797D58F}"/>
+                <a16:creationId xmlns:a16="http://schemas.microsoft.com/office/drawing/2014/main" id="{2C453B43-8457-4E9C-ADE8-67CDA91DA87B}"/>
               </a:ext>
             </a:extLst>
           </p:cNvPr>
@@ -8645,7 +8645,7 @@
           <p:cNvPr id="9" name="">
             <a:extLst xmlns:a="http://schemas.openxmlformats.org/drawingml/2006/main">
               <a:ext uri="{FF2B5EF4-FFF2-40B4-BE49-F238E27FC236}">
-                <a16:creationId xmlns:a16="http://schemas.microsoft.com/office/drawing/2014/main" id="{8A010BC8-9C25-451D-9F46-F792F0D04328}"/>
+                <a16:creationId xmlns:a16="http://schemas.microsoft.com/office/drawing/2014/main" id="{1915311C-2489-4378-ACD9-D12261295895}"/>
               </a:ext>
             </a:extLst>
           </p:cNvPr>
@@ -8680,7 +8680,7 @@
           <p:cNvPr id="10" name="">
             <a:extLst xmlns:a="http://schemas.openxmlformats.org/drawingml/2006/main">
               <a:ext uri="{FF2B5EF4-FFF2-40B4-BE49-F238E27FC236}">
-                <a16:creationId xmlns:a16="http://schemas.microsoft.com/office/drawing/2014/main" id="{A1A82B47-BCE6-438B-9642-B9AA100C2567}"/>
+                <a16:creationId xmlns:a16="http://schemas.microsoft.com/office/drawing/2014/main" id="{0B53408F-3E9B-4D90-973B-B063AC2762C5}"/>
               </a:ext>
             </a:extLst>
           </p:cNvPr>
@@ -8744,7 +8744,7 @@
           <p:cNvPr id="11" name="">
             <a:extLst xmlns:a="http://schemas.openxmlformats.org/drawingml/2006/main">
               <a:ext uri="{FF2B5EF4-FFF2-40B4-BE49-F238E27FC236}">
-                <a16:creationId xmlns:a16="http://schemas.microsoft.com/office/drawing/2014/main" id="{F2A5DE7D-C3AE-4296-8A0A-64B4104127C1}"/>
+                <a16:creationId xmlns:a16="http://schemas.microsoft.com/office/drawing/2014/main" id="{D4AC9EFE-B3A3-4A79-9651-B85D5C2F2DD3}"/>
               </a:ext>
             </a:extLst>
           </p:cNvPr>
@@ -8808,7 +8808,7 @@
           <p:cNvPr id="12" name="">
             <a:extLst xmlns:a="http://schemas.openxmlformats.org/drawingml/2006/main">
               <a:ext uri="{FF2B5EF4-FFF2-40B4-BE49-F238E27FC236}">
-                <a16:creationId xmlns:a16="http://schemas.microsoft.com/office/drawing/2014/main" id="{89B1172A-9696-47A2-BA75-C24A006E926A}"/>
+                <a16:creationId xmlns:a16="http://schemas.microsoft.com/office/drawing/2014/main" id="{18C223AE-9D06-4A05-8A4C-60DE89B48E4B}"/>
               </a:ext>
             </a:extLst>
           </p:cNvPr>
@@ -8843,7 +8843,7 @@
           <p:cNvPr id="13" name="">
             <a:extLst xmlns:a="http://schemas.openxmlformats.org/drawingml/2006/main">
               <a:ext uri="{FF2B5EF4-FFF2-40B4-BE49-F238E27FC236}">
-                <a16:creationId xmlns:a16="http://schemas.microsoft.com/office/drawing/2014/main" id="{D26EAB94-E2A7-4523-BE8A-3AF3A309A63C}"/>
+                <a16:creationId xmlns:a16="http://schemas.microsoft.com/office/drawing/2014/main" id="{17AC3201-0A9C-40D3-AAF8-DF4DE0A2D616}"/>
               </a:ext>
             </a:extLst>
           </p:cNvPr>
@@ -8907,7 +8907,7 @@
           <p:cNvPr id="14" name="">
             <a:extLst xmlns:a="http://schemas.openxmlformats.org/drawingml/2006/main">
               <a:ext uri="{FF2B5EF4-FFF2-40B4-BE49-F238E27FC236}">
-                <a16:creationId xmlns:a16="http://schemas.microsoft.com/office/drawing/2014/main" id="{0AF16922-41A2-4B3B-8E18-04C83EABC5FD}"/>
+                <a16:creationId xmlns:a16="http://schemas.microsoft.com/office/drawing/2014/main" id="{F70307AA-0600-4707-B0E1-49D5F632F52D}"/>
               </a:ext>
             </a:extLst>
           </p:cNvPr>
@@ -8961,7 +8961,7 @@
                 <a:ea typeface="Aptos"/>
                 <a:cs typeface="Aptos"/>
               </a:rPr>
-              <a:t>ont transite par les wallets mobile money dans le monde en 2025 selon la GSMA</a:t>
+              <a:t>ont transite par les portefeuilles de paiement mobile dans le monde en 2025 selon la GSMA</a:t>
             </a:r>
           </a:p>
         </p:txBody>
@@ -8971,7 +8971,7 @@
           <p:cNvPr id="15" name="">
             <a:extLst xmlns:a="http://schemas.openxmlformats.org/drawingml/2006/main">
               <a:ext uri="{FF2B5EF4-FFF2-40B4-BE49-F238E27FC236}">
-                <a16:creationId xmlns:a16="http://schemas.microsoft.com/office/drawing/2014/main" id="{D1E64220-D830-4FBD-8A92-B78C9BA5F2ED}"/>
+                <a16:creationId xmlns:a16="http://schemas.microsoft.com/office/drawing/2014/main" id="{094D5141-257F-4EB1-B4FA-62986189A434}"/>
               </a:ext>
             </a:extLst>
           </p:cNvPr>
@@ -9006,7 +9006,7 @@
           <p:cNvPr id="16" name="">
             <a:extLst xmlns:a="http://schemas.openxmlformats.org/drawingml/2006/main">
               <a:ext uri="{FF2B5EF4-FFF2-40B4-BE49-F238E27FC236}">
-                <a16:creationId xmlns:a16="http://schemas.microsoft.com/office/drawing/2014/main" id="{B0672769-76D2-4EFB-8C19-FE136A5B7098}"/>
+                <a16:creationId xmlns:a16="http://schemas.microsoft.com/office/drawing/2014/main" id="{E79DEB13-F609-49D1-8B12-C170DD6AE3E3}"/>
               </a:ext>
             </a:extLst>
           </p:cNvPr>
@@ -9070,7 +9070,7 @@
           <p:cNvPr id="17" name="">
             <a:extLst xmlns:a="http://schemas.openxmlformats.org/drawingml/2006/main">
               <a:ext uri="{FF2B5EF4-FFF2-40B4-BE49-F238E27FC236}">
-                <a16:creationId xmlns:a16="http://schemas.microsoft.com/office/drawing/2014/main" id="{C00DB9DE-1472-441D-997B-C88BE18605BE}"/>
+                <a16:creationId xmlns:a16="http://schemas.microsoft.com/office/drawing/2014/main" id="{0357EC43-4501-4472-AB05-CEBCD2485A13}"/>
               </a:ext>
             </a:extLst>
           </p:cNvPr>
@@ -9134,7 +9134,7 @@
           <p:cNvPr id="18" name="">
             <a:extLst xmlns:a="http://schemas.openxmlformats.org/drawingml/2006/main">
               <a:ext uri="{FF2B5EF4-FFF2-40B4-BE49-F238E27FC236}">
-                <a16:creationId xmlns:a16="http://schemas.microsoft.com/office/drawing/2014/main" id="{6BB83531-3F7F-42CE-95BF-7FF65643C94B}"/>
+                <a16:creationId xmlns:a16="http://schemas.microsoft.com/office/drawing/2014/main" id="{5E44ACB3-B2DF-4BC0-B859-3B110F61A5C1}"/>
               </a:ext>
             </a:extLst>
           </p:cNvPr>
@@ -9169,7 +9169,7 @@
           <p:cNvPr id="19" name="">
             <a:extLst xmlns:a="http://schemas.openxmlformats.org/drawingml/2006/main">
               <a:ext uri="{FF2B5EF4-FFF2-40B4-BE49-F238E27FC236}">
-                <a16:creationId xmlns:a16="http://schemas.microsoft.com/office/drawing/2014/main" id="{ED1D1061-1EC7-4FBB-932A-3999844E69F7}"/>
+                <a16:creationId xmlns:a16="http://schemas.microsoft.com/office/drawing/2014/main" id="{39D1A930-1936-4C50-8603-CF7B45112777}"/>
               </a:ext>
             </a:extLst>
           </p:cNvPr>
@@ -9223,7 +9223,7 @@
                 <a:ea typeface="Aptos"/>
                 <a:cs typeface="Aptos"/>
               </a:rPr>
-              <a:t>VeriPass - rail KYC souverain</a:t>
+              <a:t>VeriPass - connaissance client souveraine</a:t>
             </a:r>
           </a:p>
         </p:txBody>
@@ -9233,7 +9233,7 @@
           <p:cNvPr id="20" name="">
             <a:extLst xmlns:a="http://schemas.openxmlformats.org/drawingml/2006/main">
               <a:ext uri="{FF2B5EF4-FFF2-40B4-BE49-F238E27FC236}">
-                <a16:creationId xmlns:a16="http://schemas.microsoft.com/office/drawing/2014/main" id="{6721EE28-AAAE-4720-97D4-BD41CF4FECAB}"/>
+                <a16:creationId xmlns:a16="http://schemas.microsoft.com/office/drawing/2014/main" id="{BCA76E74-D665-4062-AA74-596336531FD9}"/>
               </a:ext>
             </a:extLst>
           </p:cNvPr>
@@ -9295,7 +9295,7 @@
     </p:spTree>
     <p:extLst>
       <p:ext uri="{BB962C8B-B14F-4D97-AF65-F5344CB8AC3E}">
-        <p14:creationId xmlns:p14="http://schemas.microsoft.com/office/powerpoint/2010/main" val="987644724"/>
+        <p14:creationId xmlns:p14="http://schemas.microsoft.com/office/powerpoint/2010/main" val="173980710"/>
       </p:ext>
     </p:extLst>
   </p:cSld>
@@ -9319,7 +9319,7 @@
           <p:cNvPr id="1" name="">
             <a:extLst xmlns:a="http://schemas.openxmlformats.org/drawingml/2006/main">
               <a:ext uri="{FF2B5EF4-FFF2-40B4-BE49-F238E27FC236}">
-                <a16:creationId xmlns:a16="http://schemas.microsoft.com/office/drawing/2014/main" id="{FC65928B-2F3A-4759-B464-A3F7E738EAFA}"/>
+                <a16:creationId xmlns:a16="http://schemas.microsoft.com/office/drawing/2014/main" id="{C04517E9-C9A8-4E63-98FD-68D21F3B4353}"/>
               </a:ext>
             </a:extLst>
           </p:cNvPr>
@@ -9354,7 +9354,7 @@
           <p:cNvPr id="2" name="">
             <a:extLst xmlns:a="http://schemas.openxmlformats.org/drawingml/2006/main">
               <a:ext uri="{FF2B5EF4-FFF2-40B4-BE49-F238E27FC236}">
-                <a16:creationId xmlns:a16="http://schemas.microsoft.com/office/drawing/2014/main" id="{5DBC36CD-9697-4EC2-9D3D-AF611A2FCE8F}"/>
+                <a16:creationId xmlns:a16="http://schemas.microsoft.com/office/drawing/2014/main" id="{560ECB63-B358-49AA-9AD9-459E7A73E3AD}"/>
               </a:ext>
             </a:extLst>
           </p:cNvPr>
@@ -9389,7 +9389,7 @@
           <p:cNvPr id="3" name="">
             <a:extLst xmlns:a="http://schemas.openxmlformats.org/drawingml/2006/main">
               <a:ext uri="{FF2B5EF4-FFF2-40B4-BE49-F238E27FC236}">
-                <a16:creationId xmlns:a16="http://schemas.microsoft.com/office/drawing/2014/main" id="{0556E252-0A7E-4211-B992-D0B8B4E82C74}"/>
+                <a16:creationId xmlns:a16="http://schemas.microsoft.com/office/drawing/2014/main" id="{B6493683-7182-48DA-9E5B-BF77932529EE}"/>
               </a:ext>
             </a:extLst>
           </p:cNvPr>
@@ -9453,7 +9453,7 @@
           <p:cNvPr id="4" name="">
             <a:extLst xmlns:a="http://schemas.openxmlformats.org/drawingml/2006/main">
               <a:ext uri="{FF2B5EF4-FFF2-40B4-BE49-F238E27FC236}">
-                <a16:creationId xmlns:a16="http://schemas.microsoft.com/office/drawing/2014/main" id="{7E6B89EF-D298-435F-9126-6523FACA1240}"/>
+                <a16:creationId xmlns:a16="http://schemas.microsoft.com/office/drawing/2014/main" id="{CE7F0FE4-A780-43B3-BAF9-2E9B8BA29D0F}"/>
               </a:ext>
             </a:extLst>
           </p:cNvPr>
@@ -9507,7 +9507,7 @@
                 <a:ea typeface="Aptos Display"/>
                 <a:cs typeface="Aptos Display"/>
               </a:rPr>
-              <a:t>Un dossier KYC fragile coute plus cher qu'un parcours lent.</a:t>
+              <a:t>Un dossier client fragile coute plus cher qu'un parcours lent.</a:t>
             </a:r>
           </a:p>
         </p:txBody>
@@ -9517,7 +9517,7 @@
           <p:cNvPr id="5" name="">
             <a:extLst xmlns:a="http://schemas.openxmlformats.org/drawingml/2006/main">
               <a:ext uri="{FF2B5EF4-FFF2-40B4-BE49-F238E27FC236}">
-                <a16:creationId xmlns:a16="http://schemas.microsoft.com/office/drawing/2014/main" id="{31081C26-4112-49D1-AD17-4154D945F642}"/>
+                <a16:creationId xmlns:a16="http://schemas.microsoft.com/office/drawing/2014/main" id="{F52AB698-33F6-4496-94C7-9406D9CA692D}"/>
               </a:ext>
             </a:extLst>
           </p:cNvPr>
@@ -9581,7 +9581,7 @@
           <p:cNvPr id="6" name="">
             <a:extLst xmlns:a="http://schemas.openxmlformats.org/drawingml/2006/main">
               <a:ext uri="{FF2B5EF4-FFF2-40B4-BE49-F238E27FC236}">
-                <a16:creationId xmlns:a16="http://schemas.microsoft.com/office/drawing/2014/main" id="{DD338D2F-0D76-4C7C-8CC4-33DE4E290A3A}"/>
+                <a16:creationId xmlns:a16="http://schemas.microsoft.com/office/drawing/2014/main" id="{45417A69-AF71-4758-8377-AB999EBF1B42}"/>
               </a:ext>
             </a:extLst>
           </p:cNvPr>
@@ -9614,7 +9614,7 @@
           <p:cNvPr id="7" name="">
             <a:extLst xmlns:a="http://schemas.openxmlformats.org/drawingml/2006/main">
               <a:ext uri="{FF2B5EF4-FFF2-40B4-BE49-F238E27FC236}">
-                <a16:creationId xmlns:a16="http://schemas.microsoft.com/office/drawing/2014/main" id="{2F608A4B-540F-4CE7-83FF-243038D881D2}"/>
+                <a16:creationId xmlns:a16="http://schemas.microsoft.com/office/drawing/2014/main" id="{8BE1E050-37FB-49B1-9F89-2D9F1E36506E}"/>
               </a:ext>
             </a:extLst>
           </p:cNvPr>
@@ -9649,7 +9649,7 @@
           <p:cNvPr id="8" name="">
             <a:extLst xmlns:a="http://schemas.openxmlformats.org/drawingml/2006/main">
               <a:ext uri="{FF2B5EF4-FFF2-40B4-BE49-F238E27FC236}">
-                <a16:creationId xmlns:a16="http://schemas.microsoft.com/office/drawing/2014/main" id="{EB203BF7-86B5-4F76-8C46-B1078B72AAEC}"/>
+                <a16:creationId xmlns:a16="http://schemas.microsoft.com/office/drawing/2014/main" id="{45642DC1-5767-4D76-BA73-DFBAF7466C35}"/>
               </a:ext>
             </a:extLst>
           </p:cNvPr>
@@ -9713,7 +9713,7 @@
           <p:cNvPr id="9" name="">
             <a:extLst xmlns:a="http://schemas.openxmlformats.org/drawingml/2006/main">
               <a:ext uri="{FF2B5EF4-FFF2-40B4-BE49-F238E27FC236}">
-                <a16:creationId xmlns:a16="http://schemas.microsoft.com/office/drawing/2014/main" id="{C390385D-1294-4F13-AF35-0C967CCF860E}"/>
+                <a16:creationId xmlns:a16="http://schemas.microsoft.com/office/drawing/2014/main" id="{296DCCF0-416E-43CD-AB1A-1AC77FB001AE}"/>
               </a:ext>
             </a:extLst>
           </p:cNvPr>
@@ -9777,7 +9777,7 @@
           <p:cNvPr id="10" name="">
             <a:extLst xmlns:a="http://schemas.openxmlformats.org/drawingml/2006/main">
               <a:ext uri="{FF2B5EF4-FFF2-40B4-BE49-F238E27FC236}">
-                <a16:creationId xmlns:a16="http://schemas.microsoft.com/office/drawing/2014/main" id="{58605468-004B-46DD-A8AD-252AD6903AC6}"/>
+                <a16:creationId xmlns:a16="http://schemas.microsoft.com/office/drawing/2014/main" id="{3349C096-C26D-4477-8EF6-257D878F6208}"/>
               </a:ext>
             </a:extLst>
           </p:cNvPr>
@@ -9810,7 +9810,7 @@
           <p:cNvPr id="11" name="">
             <a:extLst xmlns:a="http://schemas.openxmlformats.org/drawingml/2006/main">
               <a:ext uri="{FF2B5EF4-FFF2-40B4-BE49-F238E27FC236}">
-                <a16:creationId xmlns:a16="http://schemas.microsoft.com/office/drawing/2014/main" id="{70CD6F01-9962-44EE-B55D-8C4FDE25BF18}"/>
+                <a16:creationId xmlns:a16="http://schemas.microsoft.com/office/drawing/2014/main" id="{49086549-4405-4810-B967-7D2EFC3762BF}"/>
               </a:ext>
             </a:extLst>
           </p:cNvPr>
@@ -9845,7 +9845,7 @@
           <p:cNvPr id="12" name="">
             <a:extLst xmlns:a="http://schemas.openxmlformats.org/drawingml/2006/main">
               <a:ext uri="{FF2B5EF4-FFF2-40B4-BE49-F238E27FC236}">
-                <a16:creationId xmlns:a16="http://schemas.microsoft.com/office/drawing/2014/main" id="{BE5E58C2-2464-47B8-A16E-AFD6F01ECE7F}"/>
+                <a16:creationId xmlns:a16="http://schemas.microsoft.com/office/drawing/2014/main" id="{4709973C-3612-4C89-8FD2-6D00A21C5B65}"/>
               </a:ext>
             </a:extLst>
           </p:cNvPr>
@@ -9909,7 +9909,7 @@
           <p:cNvPr id="13" name="">
             <a:extLst xmlns:a="http://schemas.openxmlformats.org/drawingml/2006/main">
               <a:ext uri="{FF2B5EF4-FFF2-40B4-BE49-F238E27FC236}">
-                <a16:creationId xmlns:a16="http://schemas.microsoft.com/office/drawing/2014/main" id="{CAFA44A4-56CB-414E-BA49-A9E926E53A93}"/>
+                <a16:creationId xmlns:a16="http://schemas.microsoft.com/office/drawing/2014/main" id="{88E24E9F-C9A1-4A70-9753-81B826C5A52B}"/>
               </a:ext>
             </a:extLst>
           </p:cNvPr>
@@ -9973,7 +9973,7 @@
           <p:cNvPr id="14" name="">
             <a:extLst xmlns:a="http://schemas.openxmlformats.org/drawingml/2006/main">
               <a:ext uri="{FF2B5EF4-FFF2-40B4-BE49-F238E27FC236}">
-                <a16:creationId xmlns:a16="http://schemas.microsoft.com/office/drawing/2014/main" id="{35DFDAF6-B3B6-49D6-9F4D-28FA8289E8CA}"/>
+                <a16:creationId xmlns:a16="http://schemas.microsoft.com/office/drawing/2014/main" id="{DCB26D05-F1DD-4992-9482-83B8C5F2B593}"/>
               </a:ext>
             </a:extLst>
           </p:cNvPr>
@@ -10006,7 +10006,7 @@
           <p:cNvPr id="15" name="">
             <a:extLst xmlns:a="http://schemas.openxmlformats.org/drawingml/2006/main">
               <a:ext uri="{FF2B5EF4-FFF2-40B4-BE49-F238E27FC236}">
-                <a16:creationId xmlns:a16="http://schemas.microsoft.com/office/drawing/2014/main" id="{E33FBF3C-711A-41A3-9741-08D42220E5C3}"/>
+                <a16:creationId xmlns:a16="http://schemas.microsoft.com/office/drawing/2014/main" id="{8947F607-6F09-4C3C-94CF-0786007D5067}"/>
               </a:ext>
             </a:extLst>
           </p:cNvPr>
@@ -10041,7 +10041,7 @@
           <p:cNvPr id="16" name="">
             <a:extLst xmlns:a="http://schemas.openxmlformats.org/drawingml/2006/main">
               <a:ext uri="{FF2B5EF4-FFF2-40B4-BE49-F238E27FC236}">
-                <a16:creationId xmlns:a16="http://schemas.microsoft.com/office/drawing/2014/main" id="{62D0653E-CC2E-41BF-95E7-3ECCD876542C}"/>
+                <a16:creationId xmlns:a16="http://schemas.microsoft.com/office/drawing/2014/main" id="{67542F73-5EA3-4923-A223-630C36B9F3DC}"/>
               </a:ext>
             </a:extLst>
           </p:cNvPr>
@@ -10105,7 +10105,7 @@
           <p:cNvPr id="17" name="">
             <a:extLst xmlns:a="http://schemas.openxmlformats.org/drawingml/2006/main">
               <a:ext uri="{FF2B5EF4-FFF2-40B4-BE49-F238E27FC236}">
-                <a16:creationId xmlns:a16="http://schemas.microsoft.com/office/drawing/2014/main" id="{1370E788-CBCC-48CB-A6B5-212081F54828}"/>
+                <a16:creationId xmlns:a16="http://schemas.microsoft.com/office/drawing/2014/main" id="{8FCF8DCD-9B0A-4334-9CAA-B086599A346F}"/>
               </a:ext>
             </a:extLst>
           </p:cNvPr>
@@ -10169,7 +10169,7 @@
           <p:cNvPr id="18" name="">
             <a:extLst xmlns:a="http://schemas.openxmlformats.org/drawingml/2006/main">
               <a:ext uri="{FF2B5EF4-FFF2-40B4-BE49-F238E27FC236}">
-                <a16:creationId xmlns:a16="http://schemas.microsoft.com/office/drawing/2014/main" id="{3B3506BF-951E-4AAE-A0E2-E7E0C32A731E}"/>
+                <a16:creationId xmlns:a16="http://schemas.microsoft.com/office/drawing/2014/main" id="{DDAFDA26-4FFB-416B-A239-3EAF49CBDD5B}"/>
               </a:ext>
             </a:extLst>
           </p:cNvPr>
@@ -10202,7 +10202,7 @@
           <p:cNvPr id="19" name="">
             <a:extLst xmlns:a="http://schemas.openxmlformats.org/drawingml/2006/main">
               <a:ext uri="{FF2B5EF4-FFF2-40B4-BE49-F238E27FC236}">
-                <a16:creationId xmlns:a16="http://schemas.microsoft.com/office/drawing/2014/main" id="{9073ECC2-CDA0-4AFB-9B2B-7B355C1FBA90}"/>
+                <a16:creationId xmlns:a16="http://schemas.microsoft.com/office/drawing/2014/main" id="{63C42E79-2201-40D8-B7F1-47BFF0900E15}"/>
               </a:ext>
             </a:extLst>
           </p:cNvPr>
@@ -10237,7 +10237,7 @@
           <p:cNvPr id="20" name="">
             <a:extLst xmlns:a="http://schemas.openxmlformats.org/drawingml/2006/main">
               <a:ext uri="{FF2B5EF4-FFF2-40B4-BE49-F238E27FC236}">
-                <a16:creationId xmlns:a16="http://schemas.microsoft.com/office/drawing/2014/main" id="{DB8F1024-25CD-4062-9DDC-D6D1870A2FA7}"/>
+                <a16:creationId xmlns:a16="http://schemas.microsoft.com/office/drawing/2014/main" id="{5D458224-577E-4DB8-8FB0-0EB4CE373254}"/>
               </a:ext>
             </a:extLst>
           </p:cNvPr>
@@ -10301,7 +10301,7 @@
           <p:cNvPr id="21" name="">
             <a:extLst xmlns:a="http://schemas.openxmlformats.org/drawingml/2006/main">
               <a:ext uri="{FF2B5EF4-FFF2-40B4-BE49-F238E27FC236}">
-                <a16:creationId xmlns:a16="http://schemas.microsoft.com/office/drawing/2014/main" id="{DBA5BDB4-A19C-4437-B5E2-D9F939FD781B}"/>
+                <a16:creationId xmlns:a16="http://schemas.microsoft.com/office/drawing/2014/main" id="{CB2BC34F-60E6-411F-BFB4-4D3477C0BB4D}"/>
               </a:ext>
             </a:extLst>
           </p:cNvPr>
@@ -10365,7 +10365,7 @@
           <p:cNvPr id="22" name="">
             <a:extLst xmlns:a="http://schemas.openxmlformats.org/drawingml/2006/main">
               <a:ext uri="{FF2B5EF4-FFF2-40B4-BE49-F238E27FC236}">
-                <a16:creationId xmlns:a16="http://schemas.microsoft.com/office/drawing/2014/main" id="{210B324D-249E-405E-A0B3-494D5B5B2660}"/>
+                <a16:creationId xmlns:a16="http://schemas.microsoft.com/office/drawing/2014/main" id="{9F585E7A-F7D6-4B9E-A795-0C916E15E060}"/>
               </a:ext>
             </a:extLst>
           </p:cNvPr>
@@ -10398,7 +10398,7 @@
           <p:cNvPr id="23" name="">
             <a:extLst xmlns:a="http://schemas.openxmlformats.org/drawingml/2006/main">
               <a:ext uri="{FF2B5EF4-FFF2-40B4-BE49-F238E27FC236}">
-                <a16:creationId xmlns:a16="http://schemas.microsoft.com/office/drawing/2014/main" id="{266D2859-A042-4143-94C3-252AD06BD798}"/>
+                <a16:creationId xmlns:a16="http://schemas.microsoft.com/office/drawing/2014/main" id="{D5466C3F-1E92-4E2F-92B9-781B8A1C8DFB}"/>
               </a:ext>
             </a:extLst>
           </p:cNvPr>
@@ -10433,7 +10433,7 @@
           <p:cNvPr id="24" name="">
             <a:extLst xmlns:a="http://schemas.openxmlformats.org/drawingml/2006/main">
               <a:ext uri="{FF2B5EF4-FFF2-40B4-BE49-F238E27FC236}">
-                <a16:creationId xmlns:a16="http://schemas.microsoft.com/office/drawing/2014/main" id="{AD460D22-36BB-4A25-B430-E50A6372B866}"/>
+                <a16:creationId xmlns:a16="http://schemas.microsoft.com/office/drawing/2014/main" id="{CB00CB75-988D-4A7A-A879-45BAEB631E90}"/>
               </a:ext>
             </a:extLst>
           </p:cNvPr>
@@ -10497,7 +10497,7 @@
           <p:cNvPr id="25" name="">
             <a:extLst xmlns:a="http://schemas.openxmlformats.org/drawingml/2006/main">
               <a:ext uri="{FF2B5EF4-FFF2-40B4-BE49-F238E27FC236}">
-                <a16:creationId xmlns:a16="http://schemas.microsoft.com/office/drawing/2014/main" id="{1FF7E1C4-6285-45D3-AF95-AB9668DFE285}"/>
+                <a16:creationId xmlns:a16="http://schemas.microsoft.com/office/drawing/2014/main" id="{D9867071-366D-4389-B56A-8330F41F63E8}"/>
               </a:ext>
             </a:extLst>
           </p:cNvPr>
@@ -10561,7 +10561,7 @@
           <p:cNvPr id="26" name="">
             <a:extLst xmlns:a="http://schemas.openxmlformats.org/drawingml/2006/main">
               <a:ext uri="{FF2B5EF4-FFF2-40B4-BE49-F238E27FC236}">
-                <a16:creationId xmlns:a16="http://schemas.microsoft.com/office/drawing/2014/main" id="{F6FBA8B8-A5E6-48F9-B34A-BFA5016A5776}"/>
+                <a16:creationId xmlns:a16="http://schemas.microsoft.com/office/drawing/2014/main" id="{A290E970-4A5F-4083-ADF0-ED060A883046}"/>
               </a:ext>
             </a:extLst>
           </p:cNvPr>
@@ -10596,7 +10596,7 @@
           <p:cNvPr id="27" name="">
             <a:extLst xmlns:a="http://schemas.openxmlformats.org/drawingml/2006/main">
               <a:ext uri="{FF2B5EF4-FFF2-40B4-BE49-F238E27FC236}">
-                <a16:creationId xmlns:a16="http://schemas.microsoft.com/office/drawing/2014/main" id="{E740DD49-C5BC-462C-BC51-F3327097DD2C}"/>
+                <a16:creationId xmlns:a16="http://schemas.microsoft.com/office/drawing/2014/main" id="{28DB0881-3105-4933-A548-F14CD40758C0}"/>
               </a:ext>
             </a:extLst>
           </p:cNvPr>
@@ -10660,7 +10660,7 @@
           <p:cNvPr id="28" name="">
             <a:extLst xmlns:a="http://schemas.openxmlformats.org/drawingml/2006/main">
               <a:ext uri="{FF2B5EF4-FFF2-40B4-BE49-F238E27FC236}">
-                <a16:creationId xmlns:a16="http://schemas.microsoft.com/office/drawing/2014/main" id="{13A1EEB3-A69F-4C40-A6E2-64B052097179}"/>
+                <a16:creationId xmlns:a16="http://schemas.microsoft.com/office/drawing/2014/main" id="{C66A5F00-4FA3-4B04-A559-BDA514F014CE}"/>
               </a:ext>
             </a:extLst>
           </p:cNvPr>
@@ -10695,7 +10695,7 @@
           <p:cNvPr id="29" name="">
             <a:extLst xmlns:a="http://schemas.openxmlformats.org/drawingml/2006/main">
               <a:ext uri="{FF2B5EF4-FFF2-40B4-BE49-F238E27FC236}">
-                <a16:creationId xmlns:a16="http://schemas.microsoft.com/office/drawing/2014/main" id="{3379DA05-EDF7-4325-B778-67841438B259}"/>
+                <a16:creationId xmlns:a16="http://schemas.microsoft.com/office/drawing/2014/main" id="{38093B7C-4C31-40D2-A099-F5D4979E5630}"/>
               </a:ext>
             </a:extLst>
           </p:cNvPr>
@@ -10759,7 +10759,7 @@
           <p:cNvPr id="30" name="">
             <a:extLst xmlns:a="http://schemas.openxmlformats.org/drawingml/2006/main">
               <a:ext uri="{FF2B5EF4-FFF2-40B4-BE49-F238E27FC236}">
-                <a16:creationId xmlns:a16="http://schemas.microsoft.com/office/drawing/2014/main" id="{ABC2B1E2-A661-4208-819D-2B26DB523B61}"/>
+                <a16:creationId xmlns:a16="http://schemas.microsoft.com/office/drawing/2014/main" id="{87A1918B-2ED4-40BF-BFD2-C1806B8973AB}"/>
               </a:ext>
             </a:extLst>
           </p:cNvPr>
@@ -10792,7 +10792,7 @@
           <p:cNvPr id="31" name="">
             <a:extLst xmlns:a="http://schemas.openxmlformats.org/drawingml/2006/main">
               <a:ext uri="{FF2B5EF4-FFF2-40B4-BE49-F238E27FC236}">
-                <a16:creationId xmlns:a16="http://schemas.microsoft.com/office/drawing/2014/main" id="{9A747CBB-6AC7-4830-9CE2-E6777C6EA74E}"/>
+                <a16:creationId xmlns:a16="http://schemas.microsoft.com/office/drawing/2014/main" id="{C4B7EFFE-1A0D-438C-97A8-7D7FCE4EBF58}"/>
               </a:ext>
             </a:extLst>
           </p:cNvPr>
@@ -10856,7 +10856,7 @@
           <p:cNvPr id="32" name="">
             <a:extLst xmlns:a="http://schemas.openxmlformats.org/drawingml/2006/main">
               <a:ext uri="{FF2B5EF4-FFF2-40B4-BE49-F238E27FC236}">
-                <a16:creationId xmlns:a16="http://schemas.microsoft.com/office/drawing/2014/main" id="{44ED6DFF-6BBB-4C55-8989-AE2FB4922DB1}"/>
+                <a16:creationId xmlns:a16="http://schemas.microsoft.com/office/drawing/2014/main" id="{47B3C9CA-C3AB-4BBB-B7EE-28F980B74785}"/>
               </a:ext>
             </a:extLst>
           </p:cNvPr>
@@ -10920,7 +10920,7 @@
           <p:cNvPr id="33" name="">
             <a:extLst xmlns:a="http://schemas.openxmlformats.org/drawingml/2006/main">
               <a:ext uri="{FF2B5EF4-FFF2-40B4-BE49-F238E27FC236}">
-                <a16:creationId xmlns:a16="http://schemas.microsoft.com/office/drawing/2014/main" id="{53C3CC57-D04A-4A22-882A-CF608A0D3E43}"/>
+                <a16:creationId xmlns:a16="http://schemas.microsoft.com/office/drawing/2014/main" id="{ECC6C965-789F-4CFD-A754-A4B491D8C3E6}"/>
               </a:ext>
             </a:extLst>
           </p:cNvPr>
@@ -10984,7 +10984,7 @@
           <p:cNvPr id="34" name="">
             <a:extLst xmlns:a="http://schemas.openxmlformats.org/drawingml/2006/main">
               <a:ext uri="{FF2B5EF4-FFF2-40B4-BE49-F238E27FC236}">
-                <a16:creationId xmlns:a16="http://schemas.microsoft.com/office/drawing/2014/main" id="{409EFB63-70A9-4231-A894-886A2EF6D8DA}"/>
+                <a16:creationId xmlns:a16="http://schemas.microsoft.com/office/drawing/2014/main" id="{23E406EB-F323-4E3E-AD4D-770021EC651E}"/>
               </a:ext>
             </a:extLst>
           </p:cNvPr>
@@ -11019,7 +11019,7 @@
           <p:cNvPr id="35" name="">
             <a:extLst xmlns:a="http://schemas.openxmlformats.org/drawingml/2006/main">
               <a:ext uri="{FF2B5EF4-FFF2-40B4-BE49-F238E27FC236}">
-                <a16:creationId xmlns:a16="http://schemas.microsoft.com/office/drawing/2014/main" id="{328EA133-A520-4016-8C3F-75A5D7B98E82}"/>
+                <a16:creationId xmlns:a16="http://schemas.microsoft.com/office/drawing/2014/main" id="{71A3E699-B3C4-4118-9DBC-93EB499D79E6}"/>
               </a:ext>
             </a:extLst>
           </p:cNvPr>
@@ -11073,7 +11073,7 @@
                 <a:ea typeface="Aptos"/>
                 <a:cs typeface="Aptos"/>
               </a:rPr>
-              <a:t>VeriPass - rail KYC souverain</a:t>
+              <a:t>VeriPass - connaissance client souveraine</a:t>
             </a:r>
           </a:p>
         </p:txBody>
@@ -11083,7 +11083,7 @@
           <p:cNvPr id="36" name="">
             <a:extLst xmlns:a="http://schemas.openxmlformats.org/drawingml/2006/main">
               <a:ext uri="{FF2B5EF4-FFF2-40B4-BE49-F238E27FC236}">
-                <a16:creationId xmlns:a16="http://schemas.microsoft.com/office/drawing/2014/main" id="{028DA2C9-81D5-4663-9F0C-1462E12365E9}"/>
+                <a16:creationId xmlns:a16="http://schemas.microsoft.com/office/drawing/2014/main" id="{FE1DF32A-EEE1-40DC-BF0E-59A6EBC70DE7}"/>
               </a:ext>
             </a:extLst>
           </p:cNvPr>
@@ -11145,7 +11145,7 @@
     </p:spTree>
     <p:extLst>
       <p:ext uri="{BB962C8B-B14F-4D97-AF65-F5344CB8AC3E}">
-        <p14:creationId xmlns:p14="http://schemas.microsoft.com/office/powerpoint/2010/main" val="1355317992"/>
+        <p14:creationId xmlns:p14="http://schemas.microsoft.com/office/powerpoint/2010/main" val="1791107853"/>
       </p:ext>
     </p:extLst>
   </p:cSld>
@@ -11169,7 +11169,7 @@
           <p:cNvPr id="1" name="">
             <a:extLst xmlns:a="http://schemas.openxmlformats.org/drawingml/2006/main">
               <a:ext uri="{FF2B5EF4-FFF2-40B4-BE49-F238E27FC236}">
-                <a16:creationId xmlns:a16="http://schemas.microsoft.com/office/drawing/2014/main" id="{9175679B-3D88-438E-AB86-5C5113E4F7D7}"/>
+                <a16:creationId xmlns:a16="http://schemas.microsoft.com/office/drawing/2014/main" id="{C49AD4BA-CCB7-4F48-90C2-F3129F562B65}"/>
               </a:ext>
             </a:extLst>
           </p:cNvPr>
@@ -11204,7 +11204,7 @@
           <p:cNvPr id="2" name="">
             <a:extLst xmlns:a="http://schemas.openxmlformats.org/drawingml/2006/main">
               <a:ext uri="{FF2B5EF4-FFF2-40B4-BE49-F238E27FC236}">
-                <a16:creationId xmlns:a16="http://schemas.microsoft.com/office/drawing/2014/main" id="{07857914-B6A6-4AD1-B9A5-AF90EAD780E6}"/>
+                <a16:creationId xmlns:a16="http://schemas.microsoft.com/office/drawing/2014/main" id="{9ED9B966-44A9-45E3-B98B-2D695E417341}"/>
               </a:ext>
             </a:extLst>
           </p:cNvPr>
@@ -11239,7 +11239,7 @@
           <p:cNvPr id="3" name="">
             <a:extLst xmlns:a="http://schemas.openxmlformats.org/drawingml/2006/main">
               <a:ext uri="{FF2B5EF4-FFF2-40B4-BE49-F238E27FC236}">
-                <a16:creationId xmlns:a16="http://schemas.microsoft.com/office/drawing/2014/main" id="{337B9AE8-13B0-46B0-9247-AF6FB3E2E63D}"/>
+                <a16:creationId xmlns:a16="http://schemas.microsoft.com/office/drawing/2014/main" id="{DA4C9869-9AB6-4B08-815D-F70023E96206}"/>
               </a:ext>
             </a:extLst>
           </p:cNvPr>
@@ -11303,7 +11303,7 @@
           <p:cNvPr id="4" name="">
             <a:extLst xmlns:a="http://schemas.openxmlformats.org/drawingml/2006/main">
               <a:ext uri="{FF2B5EF4-FFF2-40B4-BE49-F238E27FC236}">
-                <a16:creationId xmlns:a16="http://schemas.microsoft.com/office/drawing/2014/main" id="{FC5D98B1-4960-40EB-BFCF-CFC05FBE096E}"/>
+                <a16:creationId xmlns:a16="http://schemas.microsoft.com/office/drawing/2014/main" id="{56EE6CA3-75DD-43C8-B2B5-8BDC06332233}"/>
               </a:ext>
             </a:extLst>
           </p:cNvPr>
@@ -11357,7 +11357,7 @@
                 <a:ea typeface="Aptos Display"/>
                 <a:cs typeface="Aptos Display"/>
               </a:rPr>
-              <a:t>Le stage a transforme une intuition en MVP bancaire testable.</a:t>
+              <a:t>Le stage a transforme une intuition en version bancaire testable.</a:t>
             </a:r>
           </a:p>
         </p:txBody>
@@ -11367,7 +11367,7 @@
           <p:cNvPr id="5" name="">
             <a:extLst xmlns:a="http://schemas.openxmlformats.org/drawingml/2006/main">
               <a:ext uri="{FF2B5EF4-FFF2-40B4-BE49-F238E27FC236}">
-                <a16:creationId xmlns:a16="http://schemas.microsoft.com/office/drawing/2014/main" id="{41654617-8D8B-4F9F-A315-772485BE9BC3}"/>
+                <a16:creationId xmlns:a16="http://schemas.microsoft.com/office/drawing/2014/main" id="{402A9C8F-95C6-4D46-B1CB-232E429CBD01}"/>
               </a:ext>
             </a:extLst>
           </p:cNvPr>
@@ -11431,7 +11431,7 @@
           <p:cNvPr id="6" name="">
             <a:extLst xmlns:a="http://schemas.openxmlformats.org/drawingml/2006/main">
               <a:ext uri="{FF2B5EF4-FFF2-40B4-BE49-F238E27FC236}">
-                <a16:creationId xmlns:a16="http://schemas.microsoft.com/office/drawing/2014/main" id="{21AA86AB-FFD1-4478-A167-AD4E75197775}"/>
+                <a16:creationId xmlns:a16="http://schemas.microsoft.com/office/drawing/2014/main" id="{A7D9E093-EDC3-4C59-8E6E-69FF6FA5920E}"/>
               </a:ext>
             </a:extLst>
           </p:cNvPr>
@@ -11464,7 +11464,7 @@
           <p:cNvPr id="7" name="">
             <a:extLst xmlns:a="http://schemas.openxmlformats.org/drawingml/2006/main">
               <a:ext uri="{FF2B5EF4-FFF2-40B4-BE49-F238E27FC236}">
-                <a16:creationId xmlns:a16="http://schemas.microsoft.com/office/drawing/2014/main" id="{54DF0077-380E-46A1-B55E-4B69D3133E48}"/>
+                <a16:creationId xmlns:a16="http://schemas.microsoft.com/office/drawing/2014/main" id="{A4191A54-A12B-4225-AB33-62D140D33EC4}"/>
               </a:ext>
             </a:extLst>
           </p:cNvPr>
@@ -11499,7 +11499,7 @@
           <p:cNvPr id="8" name="">
             <a:extLst xmlns:a="http://schemas.openxmlformats.org/drawingml/2006/main">
               <a:ext uri="{FF2B5EF4-FFF2-40B4-BE49-F238E27FC236}">
-                <a16:creationId xmlns:a16="http://schemas.microsoft.com/office/drawing/2014/main" id="{8FA8801B-2894-4966-AB6D-B315163C37F0}"/>
+                <a16:creationId xmlns:a16="http://schemas.microsoft.com/office/drawing/2014/main" id="{4D17A38C-69BB-40BC-9307-72D8E2210C8E}"/>
               </a:ext>
             </a:extLst>
           </p:cNvPr>
@@ -11563,7 +11563,7 @@
           <p:cNvPr id="9" name="">
             <a:extLst xmlns:a="http://schemas.openxmlformats.org/drawingml/2006/main">
               <a:ext uri="{FF2B5EF4-FFF2-40B4-BE49-F238E27FC236}">
-                <a16:creationId xmlns:a16="http://schemas.microsoft.com/office/drawing/2014/main" id="{5E393133-724F-4AFE-9391-A1ACFE13FC53}"/>
+                <a16:creationId xmlns:a16="http://schemas.microsoft.com/office/drawing/2014/main" id="{08CC93AB-5CD1-41EE-96B7-C0ACCFF37A9F}"/>
               </a:ext>
             </a:extLst>
           </p:cNvPr>
@@ -11627,7 +11627,7 @@
           <p:cNvPr id="10" name="">
             <a:extLst xmlns:a="http://schemas.openxmlformats.org/drawingml/2006/main">
               <a:ext uri="{FF2B5EF4-FFF2-40B4-BE49-F238E27FC236}">
-                <a16:creationId xmlns:a16="http://schemas.microsoft.com/office/drawing/2014/main" id="{C854D56B-6712-4B4F-8053-82A8AB8ECFC2}"/>
+                <a16:creationId xmlns:a16="http://schemas.microsoft.com/office/drawing/2014/main" id="{A9D13FD0-B19B-4943-8CCB-5DCE836C092B}"/>
               </a:ext>
             </a:extLst>
           </p:cNvPr>
@@ -11681,7 +11681,7 @@
                 <a:ea typeface="Aptos"/>
                 <a:cs typeface="Aptos"/>
               </a:rPr>
-              <a:t>OTP, CNI, OCR, liveness, consentement</a:t>
+              <a:t>code SMS, CNI, lecture des pieces, presence, consentement</a:t>
             </a:r>
           </a:p>
         </p:txBody>
@@ -11691,7 +11691,7 @@
           <p:cNvPr id="11" name="">
             <a:extLst xmlns:a="http://schemas.openxmlformats.org/drawingml/2006/main">
               <a:ext uri="{FF2B5EF4-FFF2-40B4-BE49-F238E27FC236}">
-                <a16:creationId xmlns:a16="http://schemas.microsoft.com/office/drawing/2014/main" id="{387A0C8D-3BFB-4801-B92E-350EAA8231EB}"/>
+                <a16:creationId xmlns:a16="http://schemas.microsoft.com/office/drawing/2014/main" id="{EBC6A0BE-1E0B-425E-B77F-BC4C73DE9744}"/>
               </a:ext>
             </a:extLst>
           </p:cNvPr>
@@ -11726,7 +11726,7 @@
           <p:cNvPr id="12" name="">
             <a:extLst xmlns:a="http://schemas.openxmlformats.org/drawingml/2006/main">
               <a:ext uri="{FF2B5EF4-FFF2-40B4-BE49-F238E27FC236}">
-                <a16:creationId xmlns:a16="http://schemas.microsoft.com/office/drawing/2014/main" id="{E277F90E-240A-4E5C-AA26-EBF5C028E36D}"/>
+                <a16:creationId xmlns:a16="http://schemas.microsoft.com/office/drawing/2014/main" id="{AC5FCBE2-2FFD-4604-85D1-C52C6F61B225}"/>
               </a:ext>
             </a:extLst>
           </p:cNvPr>
@@ -11759,7 +11759,7 @@
           <p:cNvPr id="13" name="">
             <a:extLst xmlns:a="http://schemas.openxmlformats.org/drawingml/2006/main">
               <a:ext uri="{FF2B5EF4-FFF2-40B4-BE49-F238E27FC236}">
-                <a16:creationId xmlns:a16="http://schemas.microsoft.com/office/drawing/2014/main" id="{CF24B91C-8FBB-4A77-83F6-EAF5FFAF4D10}"/>
+                <a16:creationId xmlns:a16="http://schemas.microsoft.com/office/drawing/2014/main" id="{60F91022-FCA9-48E7-8147-2F942C7FA4F1}"/>
               </a:ext>
             </a:extLst>
           </p:cNvPr>
@@ -11794,7 +11794,7 @@
           <p:cNvPr id="14" name="">
             <a:extLst xmlns:a="http://schemas.openxmlformats.org/drawingml/2006/main">
               <a:ext uri="{FF2B5EF4-FFF2-40B4-BE49-F238E27FC236}">
-                <a16:creationId xmlns:a16="http://schemas.microsoft.com/office/drawing/2014/main" id="{D3646598-182E-43C3-8CB9-502E6FDF890C}"/>
+                <a16:creationId xmlns:a16="http://schemas.microsoft.com/office/drawing/2014/main" id="{FA60CB89-0DC3-4C5A-AB51-A96425435AB3}"/>
               </a:ext>
             </a:extLst>
           </p:cNvPr>
@@ -11858,7 +11858,7 @@
           <p:cNvPr id="15" name="">
             <a:extLst xmlns:a="http://schemas.openxmlformats.org/drawingml/2006/main">
               <a:ext uri="{FF2B5EF4-FFF2-40B4-BE49-F238E27FC236}">
-                <a16:creationId xmlns:a16="http://schemas.microsoft.com/office/drawing/2014/main" id="{BF2C97B0-5348-4646-9547-B47B45846F01}"/>
+                <a16:creationId xmlns:a16="http://schemas.microsoft.com/office/drawing/2014/main" id="{B63CD2EA-02AF-4C85-8DB1-94C587127DFF}"/>
               </a:ext>
             </a:extLst>
           </p:cNvPr>
@@ -11922,7 +11922,7 @@
           <p:cNvPr id="16" name="">
             <a:extLst xmlns:a="http://schemas.openxmlformats.org/drawingml/2006/main">
               <a:ext uri="{FF2B5EF4-FFF2-40B4-BE49-F238E27FC236}">
-                <a16:creationId xmlns:a16="http://schemas.microsoft.com/office/drawing/2014/main" id="{5E772A5A-530C-4435-A98A-1D092AC6FDCB}"/>
+                <a16:creationId xmlns:a16="http://schemas.microsoft.com/office/drawing/2014/main" id="{5B61A25B-DC74-4BD6-8AFB-AFDF109EE492}"/>
               </a:ext>
             </a:extLst>
           </p:cNvPr>
@@ -11986,7 +11986,7 @@
           <p:cNvPr id="17" name="">
             <a:extLst xmlns:a="http://schemas.openxmlformats.org/drawingml/2006/main">
               <a:ext uri="{FF2B5EF4-FFF2-40B4-BE49-F238E27FC236}">
-                <a16:creationId xmlns:a16="http://schemas.microsoft.com/office/drawing/2014/main" id="{BF292B8D-C593-498E-985A-C6562AB4285E}"/>
+                <a16:creationId xmlns:a16="http://schemas.microsoft.com/office/drawing/2014/main" id="{C494164B-BE4B-4D4F-A19F-3DF6EDD5CF4E}"/>
               </a:ext>
             </a:extLst>
           </p:cNvPr>
@@ -12021,7 +12021,7 @@
           <p:cNvPr id="18" name="">
             <a:extLst xmlns:a="http://schemas.openxmlformats.org/drawingml/2006/main">
               <a:ext uri="{FF2B5EF4-FFF2-40B4-BE49-F238E27FC236}">
-                <a16:creationId xmlns:a16="http://schemas.microsoft.com/office/drawing/2014/main" id="{F9ED9455-0136-4321-8BDE-600C4DAA9A37}"/>
+                <a16:creationId xmlns:a16="http://schemas.microsoft.com/office/drawing/2014/main" id="{B1951066-B738-458B-BE35-F29C61D596C4}"/>
               </a:ext>
             </a:extLst>
           </p:cNvPr>
@@ -12054,7 +12054,7 @@
           <p:cNvPr id="19" name="">
             <a:extLst xmlns:a="http://schemas.openxmlformats.org/drawingml/2006/main">
               <a:ext uri="{FF2B5EF4-FFF2-40B4-BE49-F238E27FC236}">
-                <a16:creationId xmlns:a16="http://schemas.microsoft.com/office/drawing/2014/main" id="{1570681A-0A99-4AB8-854F-7DD7E6780C83}"/>
+                <a16:creationId xmlns:a16="http://schemas.microsoft.com/office/drawing/2014/main" id="{0F1564E8-273E-4F81-9AF5-CB65C312B1CF}"/>
               </a:ext>
             </a:extLst>
           </p:cNvPr>
@@ -12089,7 +12089,7 @@
           <p:cNvPr id="20" name="">
             <a:extLst xmlns:a="http://schemas.openxmlformats.org/drawingml/2006/main">
               <a:ext uri="{FF2B5EF4-FFF2-40B4-BE49-F238E27FC236}">
-                <a16:creationId xmlns:a16="http://schemas.microsoft.com/office/drawing/2014/main" id="{0731D6E2-AD42-4CE8-B6A1-342A151D69F6}"/>
+                <a16:creationId xmlns:a16="http://schemas.microsoft.com/office/drawing/2014/main" id="{8E7F0352-02B0-4A01-B945-BA98B89EE7A2}"/>
               </a:ext>
             </a:extLst>
           </p:cNvPr>
@@ -12153,7 +12153,7 @@
           <p:cNvPr id="21" name="">
             <a:extLst xmlns:a="http://schemas.openxmlformats.org/drawingml/2006/main">
               <a:ext uri="{FF2B5EF4-FFF2-40B4-BE49-F238E27FC236}">
-                <a16:creationId xmlns:a16="http://schemas.microsoft.com/office/drawing/2014/main" id="{B92B9C79-DF06-4113-8829-FEAB7BDE1ACB}"/>
+                <a16:creationId xmlns:a16="http://schemas.microsoft.com/office/drawing/2014/main" id="{4BE0AB00-627E-44B8-837F-6BF0C3B49A73}"/>
               </a:ext>
             </a:extLst>
           </p:cNvPr>
@@ -12217,7 +12217,7 @@
           <p:cNvPr id="22" name="">
             <a:extLst xmlns:a="http://schemas.openxmlformats.org/drawingml/2006/main">
               <a:ext uri="{FF2B5EF4-FFF2-40B4-BE49-F238E27FC236}">
-                <a16:creationId xmlns:a16="http://schemas.microsoft.com/office/drawing/2014/main" id="{9838CA37-AC6B-4FF8-9003-634C6E6A14D1}"/>
+                <a16:creationId xmlns:a16="http://schemas.microsoft.com/office/drawing/2014/main" id="{4A05DAB1-5F92-46AB-81FC-00FA525F4811}"/>
               </a:ext>
             </a:extLst>
           </p:cNvPr>
@@ -12271,7 +12271,7 @@
                 <a:ea typeface="Aptos"/>
                 <a:cs typeface="Aptos"/>
               </a:rPr>
-              <a:t>humaine: file agent, correction, complement</a:t>
+              <a:t>humaine: revue agent, correction, complement</a:t>
             </a:r>
           </a:p>
         </p:txBody>
@@ -12281,7 +12281,7 @@
           <p:cNvPr id="23" name="">
             <a:extLst xmlns:a="http://schemas.openxmlformats.org/drawingml/2006/main">
               <a:ext uri="{FF2B5EF4-FFF2-40B4-BE49-F238E27FC236}">
-                <a16:creationId xmlns:a16="http://schemas.microsoft.com/office/drawing/2014/main" id="{7C4D1C8D-5689-4598-AC57-2D4F4DF5B87B}"/>
+                <a16:creationId xmlns:a16="http://schemas.microsoft.com/office/drawing/2014/main" id="{E71EA7B6-574E-42C8-BCA7-F30CD4DEA609}"/>
               </a:ext>
             </a:extLst>
           </p:cNvPr>
@@ -12316,7 +12316,7 @@
           <p:cNvPr id="24" name="">
             <a:extLst xmlns:a="http://schemas.openxmlformats.org/drawingml/2006/main">
               <a:ext uri="{FF2B5EF4-FFF2-40B4-BE49-F238E27FC236}">
-                <a16:creationId xmlns:a16="http://schemas.microsoft.com/office/drawing/2014/main" id="{C29FEE48-4AC6-466F-9114-BA383814AE62}"/>
+                <a16:creationId xmlns:a16="http://schemas.microsoft.com/office/drawing/2014/main" id="{A4B08490-E756-4444-B5B4-74F4E3BBDE06}"/>
               </a:ext>
             </a:extLst>
           </p:cNvPr>
@@ -12349,7 +12349,7 @@
           <p:cNvPr id="25" name="">
             <a:extLst xmlns:a="http://schemas.openxmlformats.org/drawingml/2006/main">
               <a:ext uri="{FF2B5EF4-FFF2-40B4-BE49-F238E27FC236}">
-                <a16:creationId xmlns:a16="http://schemas.microsoft.com/office/drawing/2014/main" id="{6FCE9C6A-96DB-488D-A568-3FC08F05461B}"/>
+                <a16:creationId xmlns:a16="http://schemas.microsoft.com/office/drawing/2014/main" id="{61CAAC9C-F4A2-4F55-80DC-AFCD62C0D9BB}"/>
               </a:ext>
             </a:extLst>
           </p:cNvPr>
@@ -12384,7 +12384,7 @@
           <p:cNvPr id="26" name="">
             <a:extLst xmlns:a="http://schemas.openxmlformats.org/drawingml/2006/main">
               <a:ext uri="{FF2B5EF4-FFF2-40B4-BE49-F238E27FC236}">
-                <a16:creationId xmlns:a16="http://schemas.microsoft.com/office/drawing/2014/main" id="{ADF80971-9EFB-437D-B535-2077A2D3FCA6}"/>
+                <a16:creationId xmlns:a16="http://schemas.microsoft.com/office/drawing/2014/main" id="{24DB8589-E96E-471C-AC5A-DA2C727C9143}"/>
               </a:ext>
             </a:extLst>
           </p:cNvPr>
@@ -12448,7 +12448,7 @@
           <p:cNvPr id="27" name="">
             <a:extLst xmlns:a="http://schemas.openxmlformats.org/drawingml/2006/main">
               <a:ext uri="{FF2B5EF4-FFF2-40B4-BE49-F238E27FC236}">
-                <a16:creationId xmlns:a16="http://schemas.microsoft.com/office/drawing/2014/main" id="{5E0E53AD-CD3E-447A-B114-291DA56F2A94}"/>
+                <a16:creationId xmlns:a16="http://schemas.microsoft.com/office/drawing/2014/main" id="{3CA9B495-9FC1-47CD-9CE4-D1012FFAF39A}"/>
               </a:ext>
             </a:extLst>
           </p:cNvPr>
@@ -12512,7 +12512,7 @@
           <p:cNvPr id="28" name="">
             <a:extLst xmlns:a="http://schemas.openxmlformats.org/drawingml/2006/main">
               <a:ext uri="{FF2B5EF4-FFF2-40B4-BE49-F238E27FC236}">
-                <a16:creationId xmlns:a16="http://schemas.microsoft.com/office/drawing/2014/main" id="{B1B79925-3286-460D-9BA7-DE2AC8CD08CE}"/>
+                <a16:creationId xmlns:a16="http://schemas.microsoft.com/office/drawing/2014/main" id="{F9F685FC-D5E4-43D2-8994-C456E5EB3A39}"/>
               </a:ext>
             </a:extLst>
           </p:cNvPr>
@@ -12566,7 +12566,7 @@
                 <a:ea typeface="Aptos"/>
                 <a:cs typeface="Aptos"/>
               </a:rPr>
-              <a:t>AML, biometrie, blocage si alerte ouverte</a:t>
+              <a:t>LCB-FT, biometrie, blocage si alerte ouverte</a:t>
             </a:r>
           </a:p>
         </p:txBody>
@@ -12576,7 +12576,7 @@
           <p:cNvPr id="29" name="">
             <a:extLst xmlns:a="http://schemas.openxmlformats.org/drawingml/2006/main">
               <a:ext uri="{FF2B5EF4-FFF2-40B4-BE49-F238E27FC236}">
-                <a16:creationId xmlns:a16="http://schemas.microsoft.com/office/drawing/2014/main" id="{03383FE4-6598-4BB0-8907-DC04B237C80C}"/>
+                <a16:creationId xmlns:a16="http://schemas.microsoft.com/office/drawing/2014/main" id="{CAC4D09A-1E07-4E7A-93E6-9FB7A0BD3E04}"/>
               </a:ext>
             </a:extLst>
           </p:cNvPr>
@@ -12611,7 +12611,7 @@
           <p:cNvPr id="30" name="">
             <a:extLst xmlns:a="http://schemas.openxmlformats.org/drawingml/2006/main">
               <a:ext uri="{FF2B5EF4-FFF2-40B4-BE49-F238E27FC236}">
-                <a16:creationId xmlns:a16="http://schemas.microsoft.com/office/drawing/2014/main" id="{6CF9F2E4-1E30-40E4-A71F-DD56E0F81EA1}"/>
+                <a16:creationId xmlns:a16="http://schemas.microsoft.com/office/drawing/2014/main" id="{19DAE500-1256-4FDC-BC7C-CA2BD7E0F2FA}"/>
               </a:ext>
             </a:extLst>
           </p:cNvPr>
@@ -12644,7 +12644,7 @@
           <p:cNvPr id="31" name="">
             <a:extLst xmlns:a="http://schemas.openxmlformats.org/drawingml/2006/main">
               <a:ext uri="{FF2B5EF4-FFF2-40B4-BE49-F238E27FC236}">
-                <a16:creationId xmlns:a16="http://schemas.microsoft.com/office/drawing/2014/main" id="{4B79EFC4-6280-4682-AD25-652069C4558D}"/>
+                <a16:creationId xmlns:a16="http://schemas.microsoft.com/office/drawing/2014/main" id="{F9479B7F-CB6C-458A-B5C3-B9206DF58E43}"/>
               </a:ext>
             </a:extLst>
           </p:cNvPr>
@@ -12679,7 +12679,7 @@
           <p:cNvPr id="32" name="">
             <a:extLst xmlns:a="http://schemas.openxmlformats.org/drawingml/2006/main">
               <a:ext uri="{FF2B5EF4-FFF2-40B4-BE49-F238E27FC236}">
-                <a16:creationId xmlns:a16="http://schemas.microsoft.com/office/drawing/2014/main" id="{B232C39B-C0EF-40E3-B420-E1CF0F128B41}"/>
+                <a16:creationId xmlns:a16="http://schemas.microsoft.com/office/drawing/2014/main" id="{447EB2F6-5FC8-4A1F-9104-BA4F11E9A1A0}"/>
               </a:ext>
             </a:extLst>
           </p:cNvPr>
@@ -12743,7 +12743,7 @@
           <p:cNvPr id="33" name="">
             <a:extLst xmlns:a="http://schemas.openxmlformats.org/drawingml/2006/main">
               <a:ext uri="{FF2B5EF4-FFF2-40B4-BE49-F238E27FC236}">
-                <a16:creationId xmlns:a16="http://schemas.microsoft.com/office/drawing/2014/main" id="{9DEA3C61-FF19-4D3B-93E2-68CED8764170}"/>
+                <a16:creationId xmlns:a16="http://schemas.microsoft.com/office/drawing/2014/main" id="{3593E1CC-AE74-4B15-98EE-0A7C8D336E2C}"/>
               </a:ext>
             </a:extLst>
           </p:cNvPr>
@@ -12807,7 +12807,7 @@
           <p:cNvPr id="34" name="">
             <a:extLst xmlns:a="http://schemas.openxmlformats.org/drawingml/2006/main">
               <a:ext uri="{FF2B5EF4-FFF2-40B4-BE49-F238E27FC236}">
-                <a16:creationId xmlns:a16="http://schemas.microsoft.com/office/drawing/2014/main" id="{22E18DE6-8BE0-4FDA-A685-4C3CC3BFF4F7}"/>
+                <a16:creationId xmlns:a16="http://schemas.microsoft.com/office/drawing/2014/main" id="{2D8036E4-4A6B-4BAD-8CBD-69F3360A48BB}"/>
               </a:ext>
             </a:extLst>
           </p:cNvPr>
@@ -12861,7 +12861,7 @@
                 <a:ea typeface="Aptos"/>
                 <a:cs typeface="Aptos"/>
               </a:rPr>
-              <a:t>audit, command center, analytics, KPI pilote</a:t>
+              <a:t>audit, centre de pilotage, indicateurs</a:t>
             </a:r>
           </a:p>
         </p:txBody>
@@ -12871,7 +12871,7 @@
           <p:cNvPr id="35" name="">
             <a:extLst xmlns:a="http://schemas.openxmlformats.org/drawingml/2006/main">
               <a:ext uri="{FF2B5EF4-FFF2-40B4-BE49-F238E27FC236}">
-                <a16:creationId xmlns:a16="http://schemas.microsoft.com/office/drawing/2014/main" id="{6550A6B4-9CC2-4AFB-B3FF-12AB43876D88}"/>
+                <a16:creationId xmlns:a16="http://schemas.microsoft.com/office/drawing/2014/main" id="{0544CE3D-A4E3-4B7B-814A-02FC140CB923}"/>
               </a:ext>
             </a:extLst>
           </p:cNvPr>
@@ -12906,7 +12906,7 @@
           <p:cNvPr id="36" name="">
             <a:extLst xmlns:a="http://schemas.openxmlformats.org/drawingml/2006/main">
               <a:ext uri="{FF2B5EF4-FFF2-40B4-BE49-F238E27FC236}">
-                <a16:creationId xmlns:a16="http://schemas.microsoft.com/office/drawing/2014/main" id="{AF056C3D-E344-444B-8A16-4567CDA1D725}"/>
+                <a16:creationId xmlns:a16="http://schemas.microsoft.com/office/drawing/2014/main" id="{5D2687A6-79B2-4FCD-A0B4-3189F80955C2}"/>
               </a:ext>
             </a:extLst>
           </p:cNvPr>
@@ -12960,7 +12960,7 @@
                 <a:ea typeface="Aptos"/>
                 <a:cs typeface="Aptos"/>
               </a:rPr>
-              <a:t>A retenir: le MVP ne remplace pas le jugement de la banque; il prepare de meilleures preuves avant que ce jugement soit rendu.</a:t>
+              <a:t>A retenir: la version fonctionnelle ne remplace pas le jugement de la banque; elle prepare de meilleures preuves avant ce jugement.</a:t>
             </a:r>
           </a:p>
         </p:txBody>
@@ -12970,7 +12970,7 @@
           <p:cNvPr id="37" name="">
             <a:extLst xmlns:a="http://schemas.openxmlformats.org/drawingml/2006/main">
               <a:ext uri="{FF2B5EF4-FFF2-40B4-BE49-F238E27FC236}">
-                <a16:creationId xmlns:a16="http://schemas.microsoft.com/office/drawing/2014/main" id="{EB8A30E6-128F-423A-B4C0-DEE9DF729A63}"/>
+                <a16:creationId xmlns:a16="http://schemas.microsoft.com/office/drawing/2014/main" id="{9E905CB2-B91B-4BDD-A0D6-89B43FE5F660}"/>
               </a:ext>
             </a:extLst>
           </p:cNvPr>
@@ -13005,7 +13005,7 @@
           <p:cNvPr id="38" name="">
             <a:extLst xmlns:a="http://schemas.openxmlformats.org/drawingml/2006/main">
               <a:ext uri="{FF2B5EF4-FFF2-40B4-BE49-F238E27FC236}">
-                <a16:creationId xmlns:a16="http://schemas.microsoft.com/office/drawing/2014/main" id="{24464C30-B328-416C-84B6-4BEF7852CE71}"/>
+                <a16:creationId xmlns:a16="http://schemas.microsoft.com/office/drawing/2014/main" id="{7CF8B5D1-0881-48E4-A0EE-F114DA97E864}"/>
               </a:ext>
             </a:extLst>
           </p:cNvPr>
@@ -13059,7 +13059,7 @@
                 <a:ea typeface="Aptos"/>
                 <a:cs typeface="Aptos"/>
               </a:rPr>
-              <a:t>VeriPass - rail KYC souverain</a:t>
+              <a:t>VeriPass - connaissance client souveraine</a:t>
             </a:r>
           </a:p>
         </p:txBody>
@@ -13069,7 +13069,7 @@
           <p:cNvPr id="39" name="">
             <a:extLst xmlns:a="http://schemas.openxmlformats.org/drawingml/2006/main">
               <a:ext uri="{FF2B5EF4-FFF2-40B4-BE49-F238E27FC236}">
-                <a16:creationId xmlns:a16="http://schemas.microsoft.com/office/drawing/2014/main" id="{81F847E2-40CB-471C-97E9-25FA784FC784}"/>
+                <a16:creationId xmlns:a16="http://schemas.microsoft.com/office/drawing/2014/main" id="{54B5A9D9-EFDB-4E46-9E90-21ACB2A1BB2D}"/>
               </a:ext>
             </a:extLst>
           </p:cNvPr>
@@ -13131,7 +13131,7 @@
     </p:spTree>
     <p:extLst>
       <p:ext uri="{BB962C8B-B14F-4D97-AF65-F5344CB8AC3E}">
-        <p14:creationId xmlns:p14="http://schemas.microsoft.com/office/powerpoint/2010/main" val="1865448713"/>
+        <p14:creationId xmlns:p14="http://schemas.microsoft.com/office/powerpoint/2010/main" val="1110633540"/>
       </p:ext>
     </p:extLst>
   </p:cSld>
@@ -13155,7 +13155,7 @@
           <p:cNvPr id="1" name="">
             <a:extLst xmlns:a="http://schemas.openxmlformats.org/drawingml/2006/main">
               <a:ext uri="{FF2B5EF4-FFF2-40B4-BE49-F238E27FC236}">
-                <a16:creationId xmlns:a16="http://schemas.microsoft.com/office/drawing/2014/main" id="{25A66678-4B5F-4442-8353-DCD6C8A7A277}"/>
+                <a16:creationId xmlns:a16="http://schemas.microsoft.com/office/drawing/2014/main" id="{3655DB76-5645-4171-BFF8-805F1AD35ED1}"/>
               </a:ext>
             </a:extLst>
           </p:cNvPr>
@@ -13190,7 +13190,7 @@
           <p:cNvPr id="2" name="">
             <a:extLst xmlns:a="http://schemas.openxmlformats.org/drawingml/2006/main">
               <a:ext uri="{FF2B5EF4-FFF2-40B4-BE49-F238E27FC236}">
-                <a16:creationId xmlns:a16="http://schemas.microsoft.com/office/drawing/2014/main" id="{44D7BDA1-4606-495C-AAB9-1937B9196DF4}"/>
+                <a16:creationId xmlns:a16="http://schemas.microsoft.com/office/drawing/2014/main" id="{24A982FE-E2AC-4A61-B2AD-2410DCC6515D}"/>
               </a:ext>
             </a:extLst>
           </p:cNvPr>
@@ -13225,7 +13225,7 @@
           <p:cNvPr id="3" name="">
             <a:extLst xmlns:a="http://schemas.openxmlformats.org/drawingml/2006/main">
               <a:ext uri="{FF2B5EF4-FFF2-40B4-BE49-F238E27FC236}">
-                <a16:creationId xmlns:a16="http://schemas.microsoft.com/office/drawing/2014/main" id="{ADF85EB8-3978-4A0B-8B83-E2E8E227EF8E}"/>
+                <a16:creationId xmlns:a16="http://schemas.microsoft.com/office/drawing/2014/main" id="{4F6482B1-B101-4D93-9FA3-B636CF1C8CDA}"/>
               </a:ext>
             </a:extLst>
           </p:cNvPr>
@@ -13289,7 +13289,7 @@
           <p:cNvPr id="4" name="">
             <a:extLst xmlns:a="http://schemas.openxmlformats.org/drawingml/2006/main">
               <a:ext uri="{FF2B5EF4-FFF2-40B4-BE49-F238E27FC236}">
-                <a16:creationId xmlns:a16="http://schemas.microsoft.com/office/drawing/2014/main" id="{FEB983E0-492D-428B-B2D1-06837C8761C9}"/>
+                <a16:creationId xmlns:a16="http://schemas.microsoft.com/office/drawing/2014/main" id="{D8AF9677-CBF5-4CFC-B823-D6C7C84E8859}"/>
               </a:ext>
             </a:extLst>
           </p:cNvPr>
@@ -13353,7 +13353,7 @@
           <p:cNvPr id="5" name="">
             <a:extLst xmlns:a="http://schemas.openxmlformats.org/drawingml/2006/main">
               <a:ext uri="{FF2B5EF4-FFF2-40B4-BE49-F238E27FC236}">
-                <a16:creationId xmlns:a16="http://schemas.microsoft.com/office/drawing/2014/main" id="{9E15DFA9-200C-4182-8096-5CFF5B439D0E}"/>
+                <a16:creationId xmlns:a16="http://schemas.microsoft.com/office/drawing/2014/main" id="{71C3EB43-361F-4EF2-B5A1-423F3CEF3670}"/>
               </a:ext>
             </a:extLst>
           </p:cNvPr>
@@ -13407,7 +13407,7 @@
                 <a:ea typeface="Aptos"/>
                 <a:cs typeface="Aptos"/>
               </a:rPr>
-              <a:t>Le parcours montre une PWA accessible et un scope volontairement borne: CNI Cameroun d'abord, autres documents desactives tant qu'ils ne sont pas prouves.</a:t>
+              <a:t>Le parcours montre une application web mobile accessible et un perimetre volontairement borne: CNI Cameroun d'abord, autres documents desactives tant qu'ils ne sont pas prouves.</a:t>
             </a:r>
           </a:p>
         </p:txBody>
@@ -13417,7 +13417,7 @@
           <p:cNvPr id="6" name="">
             <a:extLst xmlns:a="http://schemas.openxmlformats.org/drawingml/2006/main">
               <a:ext uri="{FF2B5EF4-FFF2-40B4-BE49-F238E27FC236}">
-                <a16:creationId xmlns:a16="http://schemas.microsoft.com/office/drawing/2014/main" id="{7162E37C-B7B5-4C9E-8BF8-A8A3809E55D2}"/>
+                <a16:creationId xmlns:a16="http://schemas.microsoft.com/office/drawing/2014/main" id="{4DD6DBEA-1F29-48C0-A5C5-859B96E5A759}"/>
               </a:ext>
             </a:extLst>
           </p:cNvPr>
@@ -13454,7 +13454,7 @@
           <p:nvPr/>
         </p:nvPicPr>
         <p:blipFill>
-          <a:blip xmlns:r="http://schemas.openxmlformats.org/officeDocument/2006/relationships" xmlns:a="http://schemas.openxmlformats.org/drawingml/2006/main" r:embed="R4d3ceae449a040a8"/>
+          <a:blip xmlns:r="http://schemas.openxmlformats.org/officeDocument/2006/relationships" xmlns:a="http://schemas.openxmlformats.org/drawingml/2006/main" r:embed="Rff61c09eaa6c4e25"/>
           <a:stretch xmlns:a="http://schemas.openxmlformats.org/drawingml/2006/main"/>
         </p:blipFill>
         <p:spPr>
@@ -13472,7 +13472,7 @@
           <p:cNvPr id="8" name="">
             <a:extLst xmlns:a="http://schemas.openxmlformats.org/drawingml/2006/main">
               <a:ext uri="{FF2B5EF4-FFF2-40B4-BE49-F238E27FC236}">
-                <a16:creationId xmlns:a16="http://schemas.microsoft.com/office/drawing/2014/main" id="{1843E106-240B-4331-9BBA-E37E35846164}"/>
+                <a16:creationId xmlns:a16="http://schemas.microsoft.com/office/drawing/2014/main" id="{E850C79D-60F4-4A72-86E2-7E3DE56C4F62}"/>
               </a:ext>
             </a:extLst>
           </p:cNvPr>
@@ -13509,7 +13509,7 @@
           <p:nvPr/>
         </p:nvPicPr>
         <p:blipFill>
-          <a:blip xmlns:r="http://schemas.openxmlformats.org/officeDocument/2006/relationships" xmlns:a="http://schemas.openxmlformats.org/drawingml/2006/main" r:embed="R357b62b14c0a4de1"/>
+          <a:blip xmlns:r="http://schemas.openxmlformats.org/officeDocument/2006/relationships" xmlns:a="http://schemas.openxmlformats.org/drawingml/2006/main" r:embed="Rfb619f392075422f"/>
           <a:srcRect xmlns:a="http://schemas.openxmlformats.org/drawingml/2006/main" l="0" t="18167" r="0" b="18167"/>
           <a:stretch xmlns:a="http://schemas.openxmlformats.org/drawingml/2006/main">
             <a:fillRect l="0" t="0" r="0" b="0"/>
@@ -13530,7 +13530,7 @@
           <p:cNvPr id="10" name="">
             <a:extLst xmlns:a="http://schemas.openxmlformats.org/drawingml/2006/main">
               <a:ext uri="{FF2B5EF4-FFF2-40B4-BE49-F238E27FC236}">
-                <a16:creationId xmlns:a16="http://schemas.microsoft.com/office/drawing/2014/main" id="{F5B9D501-935C-4CA8-9ED3-6B612D9C69C3}"/>
+                <a16:creationId xmlns:a16="http://schemas.microsoft.com/office/drawing/2014/main" id="{AF50BFB5-2AED-472C-A21D-2427598D39BF}"/>
               </a:ext>
             </a:extLst>
           </p:cNvPr>
@@ -13567,7 +13567,7 @@
           <p:nvPr/>
         </p:nvPicPr>
         <p:blipFill>
-          <a:blip xmlns:r="http://schemas.openxmlformats.org/officeDocument/2006/relationships" xmlns:a="http://schemas.openxmlformats.org/drawingml/2006/main" r:embed="R785a68b951f44f1e"/>
+          <a:blip xmlns:r="http://schemas.openxmlformats.org/officeDocument/2006/relationships" xmlns:a="http://schemas.openxmlformats.org/drawingml/2006/main" r:embed="R3d20e6b4ad1c43f6"/>
           <a:stretch xmlns:a="http://schemas.openxmlformats.org/drawingml/2006/main"/>
         </p:blipFill>
         <p:spPr>
@@ -13585,7 +13585,7 @@
           <p:cNvPr id="12" name="">
             <a:extLst xmlns:a="http://schemas.openxmlformats.org/drawingml/2006/main">
               <a:ext uri="{FF2B5EF4-FFF2-40B4-BE49-F238E27FC236}">
-                <a16:creationId xmlns:a16="http://schemas.microsoft.com/office/drawing/2014/main" id="{EAEC18B5-4132-4500-B912-0691F9DEAB8A}"/>
+                <a16:creationId xmlns:a16="http://schemas.microsoft.com/office/drawing/2014/main" id="{19262450-86DE-465A-B800-A6400F347514}"/>
               </a:ext>
             </a:extLst>
           </p:cNvPr>
@@ -13649,7 +13649,7 @@
           <p:cNvPr id="13" name="">
             <a:extLst xmlns:a="http://schemas.openxmlformats.org/drawingml/2006/main">
               <a:ext uri="{FF2B5EF4-FFF2-40B4-BE49-F238E27FC236}">
-                <a16:creationId xmlns:a16="http://schemas.microsoft.com/office/drawing/2014/main" id="{99C93D4C-A37C-41B0-A3D9-5BB03EFE2DCC}"/>
+                <a16:creationId xmlns:a16="http://schemas.microsoft.com/office/drawing/2014/main" id="{EB1DF0BA-1B55-447A-AAE0-0A99149FC150}"/>
               </a:ext>
             </a:extLst>
           </p:cNvPr>
@@ -13713,7 +13713,7 @@
           <p:cNvPr id="14" name="">
             <a:extLst xmlns:a="http://schemas.openxmlformats.org/drawingml/2006/main">
               <a:ext uri="{FF2B5EF4-FFF2-40B4-BE49-F238E27FC236}">
-                <a16:creationId xmlns:a16="http://schemas.microsoft.com/office/drawing/2014/main" id="{2F548320-F645-458A-8E8D-9A132DE3F761}"/>
+                <a16:creationId xmlns:a16="http://schemas.microsoft.com/office/drawing/2014/main" id="{FF708FC9-C12E-4957-87AB-41B3FC70E891}"/>
               </a:ext>
             </a:extLst>
           </p:cNvPr>
@@ -13767,7 +13767,7 @@
                 <a:ea typeface="Aptos"/>
                 <a:cs typeface="Aptos"/>
               </a:rPr>
-              <a:t>Preuves internes: captures produit mobile et demo scope CNI, dossier marketing-presentation-bicec-2026-06-02/05_preuve_produit__*.</a:t>
+              <a:t>Preuves internes: captures produit mobile et demo perimetre CNI, dossier marketing-presentation-bicec-2026-06-02/05_preuve_produit__*.</a:t>
             </a:r>
           </a:p>
         </p:txBody>
@@ -13777,7 +13777,7 @@
           <p:cNvPr id="15" name="">
             <a:extLst xmlns:a="http://schemas.openxmlformats.org/drawingml/2006/main">
               <a:ext uri="{FF2B5EF4-FFF2-40B4-BE49-F238E27FC236}">
-                <a16:creationId xmlns:a16="http://schemas.microsoft.com/office/drawing/2014/main" id="{FCF5EEC1-6B11-4D2C-8059-3CE6C9CE3D18}"/>
+                <a16:creationId xmlns:a16="http://schemas.microsoft.com/office/drawing/2014/main" id="{4137063F-F2FC-4BF1-834A-28F15DF55083}"/>
               </a:ext>
             </a:extLst>
           </p:cNvPr>
@@ -13812,7 +13812,7 @@
           <p:cNvPr id="16" name="">
             <a:extLst xmlns:a="http://schemas.openxmlformats.org/drawingml/2006/main">
               <a:ext uri="{FF2B5EF4-FFF2-40B4-BE49-F238E27FC236}">
-                <a16:creationId xmlns:a16="http://schemas.microsoft.com/office/drawing/2014/main" id="{A1C1DC8A-CE5B-4577-B962-EFBC7308761A}"/>
+                <a16:creationId xmlns:a16="http://schemas.microsoft.com/office/drawing/2014/main" id="{C3EB6365-CFEB-400E-95A0-67F67C8BDAE9}"/>
               </a:ext>
             </a:extLst>
           </p:cNvPr>
@@ -13866,7 +13866,7 @@
                 <a:ea typeface="Aptos"/>
                 <a:cs typeface="Aptos"/>
               </a:rPr>
-              <a:t>VeriPass - rail KYC souverain</a:t>
+              <a:t>VeriPass - connaissance client souveraine</a:t>
             </a:r>
           </a:p>
         </p:txBody>
@@ -13876,7 +13876,7 @@
           <p:cNvPr id="17" name="">
             <a:extLst xmlns:a="http://schemas.openxmlformats.org/drawingml/2006/main">
               <a:ext uri="{FF2B5EF4-FFF2-40B4-BE49-F238E27FC236}">
-                <a16:creationId xmlns:a16="http://schemas.microsoft.com/office/drawing/2014/main" id="{DDBD58E7-35D7-4E93-A47F-5B46CA2C1B4F}"/>
+                <a16:creationId xmlns:a16="http://schemas.microsoft.com/office/drawing/2014/main" id="{B8EFFD8E-6332-40F3-88C9-4E5F6769AEDE}"/>
               </a:ext>
             </a:extLst>
           </p:cNvPr>
@@ -13938,7 +13938,7 @@
     </p:spTree>
     <p:extLst>
       <p:ext uri="{BB962C8B-B14F-4D97-AF65-F5344CB8AC3E}">
-        <p14:creationId xmlns:p14="http://schemas.microsoft.com/office/powerpoint/2010/main" val="1213352430"/>
+        <p14:creationId xmlns:p14="http://schemas.microsoft.com/office/powerpoint/2010/main" val="343165560"/>
       </p:ext>
     </p:extLst>
   </p:cSld>
@@ -13962,7 +13962,7 @@
           <p:cNvPr id="1" name="">
             <a:extLst xmlns:a="http://schemas.openxmlformats.org/drawingml/2006/main">
               <a:ext uri="{FF2B5EF4-FFF2-40B4-BE49-F238E27FC236}">
-                <a16:creationId xmlns:a16="http://schemas.microsoft.com/office/drawing/2014/main" id="{84D7A10C-C990-4FBB-8A1E-19EEC9B844B1}"/>
+                <a16:creationId xmlns:a16="http://schemas.microsoft.com/office/drawing/2014/main" id="{74242708-5992-464F-8252-1E5B1BEC488B}"/>
               </a:ext>
             </a:extLst>
           </p:cNvPr>
@@ -13997,7 +13997,7 @@
           <p:cNvPr id="2" name="">
             <a:extLst xmlns:a="http://schemas.openxmlformats.org/drawingml/2006/main">
               <a:ext uri="{FF2B5EF4-FFF2-40B4-BE49-F238E27FC236}">
-                <a16:creationId xmlns:a16="http://schemas.microsoft.com/office/drawing/2014/main" id="{971837A8-562E-4E5A-A39B-6E6ABE3F4FDA}"/>
+                <a16:creationId xmlns:a16="http://schemas.microsoft.com/office/drawing/2014/main" id="{2A760104-0BAE-4DE0-AEEB-E626321FA2A6}"/>
               </a:ext>
             </a:extLst>
           </p:cNvPr>
@@ -14032,7 +14032,7 @@
           <p:cNvPr id="3" name="">
             <a:extLst xmlns:a="http://schemas.openxmlformats.org/drawingml/2006/main">
               <a:ext uri="{FF2B5EF4-FFF2-40B4-BE49-F238E27FC236}">
-                <a16:creationId xmlns:a16="http://schemas.microsoft.com/office/drawing/2014/main" id="{C0F1637D-5114-4E8E-A59A-F76884A0AECC}"/>
+                <a16:creationId xmlns:a16="http://schemas.microsoft.com/office/drawing/2014/main" id="{114FD236-0CE9-4D09-B0E5-5492B452AD0B}"/>
               </a:ext>
             </a:extLst>
           </p:cNvPr>
@@ -14096,7 +14096,7 @@
           <p:cNvPr id="4" name="">
             <a:extLst xmlns:a="http://schemas.openxmlformats.org/drawingml/2006/main">
               <a:ext uri="{FF2B5EF4-FFF2-40B4-BE49-F238E27FC236}">
-                <a16:creationId xmlns:a16="http://schemas.microsoft.com/office/drawing/2014/main" id="{195E4AD2-5128-4FC2-B112-049F8A2D3CBE}"/>
+                <a16:creationId xmlns:a16="http://schemas.microsoft.com/office/drawing/2014/main" id="{9901EC41-ACCB-4DBB-A597-6C0437C8DCAD}"/>
               </a:ext>
             </a:extLst>
           </p:cNvPr>
@@ -14160,7 +14160,7 @@
           <p:cNvPr id="5" name="">
             <a:extLst xmlns:a="http://schemas.openxmlformats.org/drawingml/2006/main">
               <a:ext uri="{FF2B5EF4-FFF2-40B4-BE49-F238E27FC236}">
-                <a16:creationId xmlns:a16="http://schemas.microsoft.com/office/drawing/2014/main" id="{1934F7BD-5104-41C1-9EF9-C4D750CEFA0E}"/>
+                <a16:creationId xmlns:a16="http://schemas.microsoft.com/office/drawing/2014/main" id="{7C421456-BD80-444A-8A83-CAD04FF923DD}"/>
               </a:ext>
             </a:extLst>
           </p:cNvPr>
@@ -14224,7 +14224,7 @@
           <p:cNvPr id="6" name="">
             <a:extLst xmlns:a="http://schemas.openxmlformats.org/drawingml/2006/main">
               <a:ext uri="{FF2B5EF4-FFF2-40B4-BE49-F238E27FC236}">
-                <a16:creationId xmlns:a16="http://schemas.microsoft.com/office/drawing/2014/main" id="{BB634402-27B1-4ECF-97B9-1C019BE0F7F8}"/>
+                <a16:creationId xmlns:a16="http://schemas.microsoft.com/office/drawing/2014/main" id="{84BBBE97-7291-4263-AFF2-5882723F4AEA}"/>
               </a:ext>
             </a:extLst>
           </p:cNvPr>
@@ -14261,7 +14261,7 @@
           <p:nvPr/>
         </p:nvPicPr>
         <p:blipFill>
-          <a:blip xmlns:r="http://schemas.openxmlformats.org/officeDocument/2006/relationships" xmlns:a="http://schemas.openxmlformats.org/drawingml/2006/main" r:embed="Rad8c4430c9f54222"/>
+          <a:blip xmlns:r="http://schemas.openxmlformats.org/officeDocument/2006/relationships" xmlns:a="http://schemas.openxmlformats.org/drawingml/2006/main" r:embed="R64480600c23544fb"/>
           <a:stretch xmlns:a="http://schemas.openxmlformats.org/drawingml/2006/main"/>
         </p:blipFill>
         <p:spPr>
@@ -14279,7 +14279,7 @@
           <p:cNvPr id="8" name="">
             <a:extLst xmlns:a="http://schemas.openxmlformats.org/drawingml/2006/main">
               <a:ext uri="{FF2B5EF4-FFF2-40B4-BE49-F238E27FC236}">
-                <a16:creationId xmlns:a16="http://schemas.microsoft.com/office/drawing/2014/main" id="{A61765C0-3D22-4C1F-8B60-B3B3E0F4B1FB}"/>
+                <a16:creationId xmlns:a16="http://schemas.microsoft.com/office/drawing/2014/main" id="{4B35F88C-08EB-4D35-9AE2-466B51ACAD48}"/>
               </a:ext>
             </a:extLst>
           </p:cNvPr>
@@ -14316,7 +14316,7 @@
           <p:nvPr/>
         </p:nvPicPr>
         <p:blipFill>
-          <a:blip xmlns:r="http://schemas.openxmlformats.org/officeDocument/2006/relationships" xmlns:a="http://schemas.openxmlformats.org/drawingml/2006/main" r:embed="Re9d75d10943f426f"/>
+          <a:blip xmlns:r="http://schemas.openxmlformats.org/officeDocument/2006/relationships" xmlns:a="http://schemas.openxmlformats.org/drawingml/2006/main" r:embed="Rfd6c85f8c71744c7"/>
           <a:srcRect xmlns:a="http://schemas.openxmlformats.org/drawingml/2006/main" l="0" t="34981" r="0" b="34981"/>
           <a:stretch xmlns:a="http://schemas.openxmlformats.org/drawingml/2006/main">
             <a:fillRect l="0" t="0" r="0" b="0"/>
@@ -14337,7 +14337,7 @@
           <p:cNvPr id="10" name="">
             <a:extLst xmlns:a="http://schemas.openxmlformats.org/drawingml/2006/main">
               <a:ext uri="{FF2B5EF4-FFF2-40B4-BE49-F238E27FC236}">
-                <a16:creationId xmlns:a16="http://schemas.microsoft.com/office/drawing/2014/main" id="{71104766-2444-44EB-9365-8148579999A6}"/>
+                <a16:creationId xmlns:a16="http://schemas.microsoft.com/office/drawing/2014/main" id="{604CDD38-3219-44A0-B01F-E6FDABF930BF}"/>
               </a:ext>
             </a:extLst>
           </p:cNvPr>
@@ -14372,7 +14372,7 @@
           <p:cNvPr id="11" name="">
             <a:extLst xmlns:a="http://schemas.openxmlformats.org/drawingml/2006/main">
               <a:ext uri="{FF2B5EF4-FFF2-40B4-BE49-F238E27FC236}">
-                <a16:creationId xmlns:a16="http://schemas.microsoft.com/office/drawing/2014/main" id="{8AB21D42-5823-40F7-B7FF-BA2E36FA5FE2}"/>
+                <a16:creationId xmlns:a16="http://schemas.microsoft.com/office/drawing/2014/main" id="{2FB9B207-08E5-4B9F-8838-C8AD18695E3F}"/>
               </a:ext>
             </a:extLst>
           </p:cNvPr>
@@ -14436,7 +14436,7 @@
           <p:cNvPr id="12" name="">
             <a:extLst xmlns:a="http://schemas.openxmlformats.org/drawingml/2006/main">
               <a:ext uri="{FF2B5EF4-FFF2-40B4-BE49-F238E27FC236}">
-                <a16:creationId xmlns:a16="http://schemas.microsoft.com/office/drawing/2014/main" id="{D8691BE7-7785-4595-B2B3-2026C77FFF04}"/>
+                <a16:creationId xmlns:a16="http://schemas.microsoft.com/office/drawing/2014/main" id="{3218EACD-D1ED-4F65-8E22-5AACFA117741}"/>
               </a:ext>
             </a:extLst>
           </p:cNvPr>
@@ -14490,7 +14490,7 @@
                 <a:ea typeface="Aptos"/>
                 <a:cs typeface="Aptos"/>
               </a:rPr>
-              <a:t>Preuves internes: backoffice Jean, file de validation, dossier approuve, happy path API live approuve le 26/05/2026.</a:t>
+              <a:t>Preuves internes: espace agent Jean, file de validation, dossier approuve, parcours API de bout en bout approuve le 26/05/2026.</a:t>
             </a:r>
           </a:p>
         </p:txBody>
@@ -14500,7 +14500,7 @@
           <p:cNvPr id="13" name="">
             <a:extLst xmlns:a="http://schemas.openxmlformats.org/drawingml/2006/main">
               <a:ext uri="{FF2B5EF4-FFF2-40B4-BE49-F238E27FC236}">
-                <a16:creationId xmlns:a16="http://schemas.microsoft.com/office/drawing/2014/main" id="{D78A12B0-2478-4F30-AFE8-69C012CB4830}"/>
+                <a16:creationId xmlns:a16="http://schemas.microsoft.com/office/drawing/2014/main" id="{1CD410C6-A60B-432E-8CA5-870129E81394}"/>
               </a:ext>
             </a:extLst>
           </p:cNvPr>
@@ -14535,7 +14535,7 @@
           <p:cNvPr id="14" name="">
             <a:extLst xmlns:a="http://schemas.openxmlformats.org/drawingml/2006/main">
               <a:ext uri="{FF2B5EF4-FFF2-40B4-BE49-F238E27FC236}">
-                <a16:creationId xmlns:a16="http://schemas.microsoft.com/office/drawing/2014/main" id="{3BEB1BFA-A33D-4115-B852-19631E60B599}"/>
+                <a16:creationId xmlns:a16="http://schemas.microsoft.com/office/drawing/2014/main" id="{7378C396-042F-4E9F-847F-7B9EF435F3BD}"/>
               </a:ext>
             </a:extLst>
           </p:cNvPr>
@@ -14589,7 +14589,7 @@
                 <a:ea typeface="Aptos"/>
                 <a:cs typeface="Aptos"/>
               </a:rPr>
-              <a:t>VeriPass - rail KYC souverain</a:t>
+              <a:t>VeriPass - connaissance client souveraine</a:t>
             </a:r>
           </a:p>
         </p:txBody>
@@ -14599,7 +14599,7 @@
           <p:cNvPr id="15" name="">
             <a:extLst xmlns:a="http://schemas.openxmlformats.org/drawingml/2006/main">
               <a:ext uri="{FF2B5EF4-FFF2-40B4-BE49-F238E27FC236}">
-                <a16:creationId xmlns:a16="http://schemas.microsoft.com/office/drawing/2014/main" id="{89051DF5-164F-463A-940F-439A83134F3F}"/>
+                <a16:creationId xmlns:a16="http://schemas.microsoft.com/office/drawing/2014/main" id="{A48DE1CD-C626-4858-8A35-8ADEA93DDD0F}"/>
               </a:ext>
             </a:extLst>
           </p:cNvPr>
@@ -14661,7 +14661,7 @@
     </p:spTree>
     <p:extLst>
       <p:ext uri="{BB962C8B-B14F-4D97-AF65-F5344CB8AC3E}">
-        <p14:creationId xmlns:p14="http://schemas.microsoft.com/office/powerpoint/2010/main" val="1212088286"/>
+        <p14:creationId xmlns:p14="http://schemas.microsoft.com/office/powerpoint/2010/main" val="210481333"/>
       </p:ext>
     </p:extLst>
   </p:cSld>
@@ -14685,7 +14685,7 @@
           <p:cNvPr id="1" name="">
             <a:extLst xmlns:a="http://schemas.openxmlformats.org/drawingml/2006/main">
               <a:ext uri="{FF2B5EF4-FFF2-40B4-BE49-F238E27FC236}">
-                <a16:creationId xmlns:a16="http://schemas.microsoft.com/office/drawing/2014/main" id="{C85B034A-44B0-4DBA-8F21-6FE47133C72C}"/>
+                <a16:creationId xmlns:a16="http://schemas.microsoft.com/office/drawing/2014/main" id="{A7436420-FE79-4394-9B14-3A5999347708}"/>
               </a:ext>
             </a:extLst>
           </p:cNvPr>
@@ -14720,7 +14720,7 @@
           <p:cNvPr id="2" name="">
             <a:extLst xmlns:a="http://schemas.openxmlformats.org/drawingml/2006/main">
               <a:ext uri="{FF2B5EF4-FFF2-40B4-BE49-F238E27FC236}">
-                <a16:creationId xmlns:a16="http://schemas.microsoft.com/office/drawing/2014/main" id="{0871C8F2-5CC3-41B0-86FB-55B639B21E95}"/>
+                <a16:creationId xmlns:a16="http://schemas.microsoft.com/office/drawing/2014/main" id="{126FAB14-73C1-4B9C-A5C2-4FBE489F490C}"/>
               </a:ext>
             </a:extLst>
           </p:cNvPr>
@@ -14755,7 +14755,7 @@
           <p:cNvPr id="3" name="">
             <a:extLst xmlns:a="http://schemas.openxmlformats.org/drawingml/2006/main">
               <a:ext uri="{FF2B5EF4-FFF2-40B4-BE49-F238E27FC236}">
-                <a16:creationId xmlns:a16="http://schemas.microsoft.com/office/drawing/2014/main" id="{11DEEAEA-3F2C-470B-9766-79041A90A0BC}"/>
+                <a16:creationId xmlns:a16="http://schemas.microsoft.com/office/drawing/2014/main" id="{4076D98B-4DDF-40CC-90A9-D4D6FD03CAFF}"/>
               </a:ext>
             </a:extLst>
           </p:cNvPr>
@@ -14819,7 +14819,7 @@
           <p:cNvPr id="4" name="">
             <a:extLst xmlns:a="http://schemas.openxmlformats.org/drawingml/2006/main">
               <a:ext uri="{FF2B5EF4-FFF2-40B4-BE49-F238E27FC236}">
-                <a16:creationId xmlns:a16="http://schemas.microsoft.com/office/drawing/2014/main" id="{B5DFADF9-440A-42A9-A3B4-11E7667F54B3}"/>
+                <a16:creationId xmlns:a16="http://schemas.microsoft.com/office/drawing/2014/main" id="{6321E050-9B6A-4934-90F3-F7FE9BDAF0B0}"/>
               </a:ext>
             </a:extLst>
           </p:cNvPr>
@@ -14883,7 +14883,7 @@
           <p:cNvPr id="5" name="">
             <a:extLst xmlns:a="http://schemas.openxmlformats.org/drawingml/2006/main">
               <a:ext uri="{FF2B5EF4-FFF2-40B4-BE49-F238E27FC236}">
-                <a16:creationId xmlns:a16="http://schemas.microsoft.com/office/drawing/2014/main" id="{188F516E-AFAF-46F0-B27E-E79BF5084489}"/>
+                <a16:creationId xmlns:a16="http://schemas.microsoft.com/office/drawing/2014/main" id="{DEB00C65-589A-4F40-A939-AF2009052EBA}"/>
               </a:ext>
             </a:extLst>
           </p:cNvPr>
@@ -14937,7 +14937,7 @@
                 <a:ea typeface="Aptos"/>
                 <a:cs typeface="Aptos"/>
               </a:rPr>
-              <a:t>Le MVP montre un garde-fou simple a comprendre: une alerte AML ouverte bloque l'approbation. C'est le bon message pour Thomas et pour l'audit.</a:t>
+              <a:t>La version fonctionnelle montre un garde-fou simple a comprendre: une alerte LCB-FT ouverte bloque l'approbation. C'est le bon message pour Thomas et pour l'audit.</a:t>
             </a:r>
           </a:p>
         </p:txBody>
@@ -14947,7 +14947,7 @@
           <p:cNvPr id="6" name="">
             <a:extLst xmlns:a="http://schemas.openxmlformats.org/drawingml/2006/main">
               <a:ext uri="{FF2B5EF4-FFF2-40B4-BE49-F238E27FC236}">
-                <a16:creationId xmlns:a16="http://schemas.microsoft.com/office/drawing/2014/main" id="{63FC2940-53F9-4BE7-A66E-3A9E3EF596CE}"/>
+                <a16:creationId xmlns:a16="http://schemas.microsoft.com/office/drawing/2014/main" id="{775089D6-6125-48CA-BF81-02A78AB8629C}"/>
               </a:ext>
             </a:extLst>
           </p:cNvPr>
@@ -14984,7 +14984,7 @@
           <p:nvPr/>
         </p:nvPicPr>
         <p:blipFill>
-          <a:blip xmlns:r="http://schemas.openxmlformats.org/officeDocument/2006/relationships" xmlns:a="http://schemas.openxmlformats.org/drawingml/2006/main" r:embed="Rc1dc9259db5e4103"/>
+          <a:blip xmlns:r="http://schemas.openxmlformats.org/officeDocument/2006/relationships" xmlns:a="http://schemas.openxmlformats.org/drawingml/2006/main" r:embed="Re36a351add254a4c"/>
           <a:srcRect xmlns:a="http://schemas.openxmlformats.org/drawingml/2006/main" l="0" t="34206" r="0" b="34206"/>
           <a:stretch xmlns:a="http://schemas.openxmlformats.org/drawingml/2006/main">
             <a:fillRect l="0" t="0" r="0" b="0"/>
@@ -15005,7 +15005,7 @@
           <p:cNvPr id="8" name="">
             <a:extLst xmlns:a="http://schemas.openxmlformats.org/drawingml/2006/main">
               <a:ext uri="{FF2B5EF4-FFF2-40B4-BE49-F238E27FC236}">
-                <a16:creationId xmlns:a16="http://schemas.microsoft.com/office/drawing/2014/main" id="{662A1EB9-FB4D-401B-A8CE-D91A021AC5EA}"/>
+                <a16:creationId xmlns:a16="http://schemas.microsoft.com/office/drawing/2014/main" id="{957C7947-AE77-4743-A803-D79BD45744E4}"/>
               </a:ext>
             </a:extLst>
           </p:cNvPr>
@@ -15042,7 +15042,7 @@
           <p:nvPr/>
         </p:nvPicPr>
         <p:blipFill>
-          <a:blip xmlns:r="http://schemas.openxmlformats.org/officeDocument/2006/relationships" xmlns:a="http://schemas.openxmlformats.org/drawingml/2006/main" r:embed="R147f441fb43a43d2"/>
+          <a:blip xmlns:r="http://schemas.openxmlformats.org/officeDocument/2006/relationships" xmlns:a="http://schemas.openxmlformats.org/drawingml/2006/main" r:embed="Rb1ea34e8faa1435f"/>
           <a:srcRect xmlns:a="http://schemas.openxmlformats.org/drawingml/2006/main" l="0" t="34257" r="0" b="34257"/>
           <a:stretch xmlns:a="http://schemas.openxmlformats.org/drawingml/2006/main">
             <a:fillRect l="0" t="0" r="0" b="0"/>
@@ -15063,7 +15063,7 @@
           <p:cNvPr id="10" name="">
             <a:extLst xmlns:a="http://schemas.openxmlformats.org/drawingml/2006/main">
               <a:ext uri="{FF2B5EF4-FFF2-40B4-BE49-F238E27FC236}">
-                <a16:creationId xmlns:a16="http://schemas.microsoft.com/office/drawing/2014/main" id="{29061C88-00FF-4DAA-91F2-5E6CAD8A0062}"/>
+                <a16:creationId xmlns:a16="http://schemas.microsoft.com/office/drawing/2014/main" id="{36872721-8FCB-475E-A7DC-3B3979D32018}"/>
               </a:ext>
             </a:extLst>
           </p:cNvPr>
@@ -15098,7 +15098,7 @@
           <p:cNvPr id="11" name="">
             <a:extLst xmlns:a="http://schemas.openxmlformats.org/drawingml/2006/main">
               <a:ext uri="{FF2B5EF4-FFF2-40B4-BE49-F238E27FC236}">
-                <a16:creationId xmlns:a16="http://schemas.microsoft.com/office/drawing/2014/main" id="{8F80BBA8-B798-4A6F-9EEC-3216325D3DC9}"/>
+                <a16:creationId xmlns:a16="http://schemas.microsoft.com/office/drawing/2014/main" id="{22615815-14DC-4640-8D96-99EFB7B9E8AB}"/>
               </a:ext>
             </a:extLst>
           </p:cNvPr>
@@ -15162,7 +15162,7 @@
           <p:cNvPr id="12" name="">
             <a:extLst xmlns:a="http://schemas.openxmlformats.org/drawingml/2006/main">
               <a:ext uri="{FF2B5EF4-FFF2-40B4-BE49-F238E27FC236}">
-                <a16:creationId xmlns:a16="http://schemas.microsoft.com/office/drawing/2014/main" id="{A761EB04-29FC-4028-B77B-DD1440FE4E7A}"/>
+                <a16:creationId xmlns:a16="http://schemas.microsoft.com/office/drawing/2014/main" id="{56600E33-5609-4ACC-85F5-9C2D3EE42350}"/>
               </a:ext>
             </a:extLst>
           </p:cNvPr>
@@ -15216,7 +15216,7 @@
                 <a:ea typeface="Aptos"/>
                 <a:cs typeface="Aptos"/>
               </a:rPr>
-              <a:t>Preuves internes: demo conformite AML du 28/05/2026, etapes 08 a 10; FATF, Cameroon increased monitoring, 13/02/2026.</a:t>
+              <a:t>Preuves internes: demo conformite LCB-FT du 28/05/2026, etapes 08 a 10; GAFI, Cameroun sous surveillance accrue, 13/02/2026.</a:t>
             </a:r>
           </a:p>
         </p:txBody>
@@ -15226,7 +15226,7 @@
           <p:cNvPr id="13" name="">
             <a:extLst xmlns:a="http://schemas.openxmlformats.org/drawingml/2006/main">
               <a:ext uri="{FF2B5EF4-FFF2-40B4-BE49-F238E27FC236}">
-                <a16:creationId xmlns:a16="http://schemas.microsoft.com/office/drawing/2014/main" id="{C1919F94-8B64-4BBA-985F-88AF43AFE0C4}"/>
+                <a16:creationId xmlns:a16="http://schemas.microsoft.com/office/drawing/2014/main" id="{BC07CC9A-21B3-40B1-9A83-2185964260CC}"/>
               </a:ext>
             </a:extLst>
           </p:cNvPr>
@@ -15261,7 +15261,7 @@
           <p:cNvPr id="14" name="">
             <a:extLst xmlns:a="http://schemas.openxmlformats.org/drawingml/2006/main">
               <a:ext uri="{FF2B5EF4-FFF2-40B4-BE49-F238E27FC236}">
-                <a16:creationId xmlns:a16="http://schemas.microsoft.com/office/drawing/2014/main" id="{BC7C618F-BE3C-4C23-ADDA-6779C8168CEB}"/>
+                <a16:creationId xmlns:a16="http://schemas.microsoft.com/office/drawing/2014/main" id="{894C3669-64D4-4162-9C34-ECD20678605D}"/>
               </a:ext>
             </a:extLst>
           </p:cNvPr>
@@ -15315,7 +15315,7 @@
                 <a:ea typeface="Aptos"/>
                 <a:cs typeface="Aptos"/>
               </a:rPr>
-              <a:t>VeriPass - rail KYC souverain</a:t>
+              <a:t>VeriPass - connaissance client souveraine</a:t>
             </a:r>
           </a:p>
         </p:txBody>
@@ -15325,7 +15325,7 @@
           <p:cNvPr id="15" name="">
             <a:extLst xmlns:a="http://schemas.openxmlformats.org/drawingml/2006/main">
               <a:ext uri="{FF2B5EF4-FFF2-40B4-BE49-F238E27FC236}">
-                <a16:creationId xmlns:a16="http://schemas.microsoft.com/office/drawing/2014/main" id="{A536EDAB-ABC6-4B6C-B0DB-10514CBA2741}"/>
+                <a16:creationId xmlns:a16="http://schemas.microsoft.com/office/drawing/2014/main" id="{BD718ABD-1E4D-436E-BF88-F02B47AA50CB}"/>
               </a:ext>
             </a:extLst>
           </p:cNvPr>
@@ -15387,7 +15387,7 @@
     </p:spTree>
     <p:extLst>
       <p:ext uri="{BB962C8B-B14F-4D97-AF65-F5344CB8AC3E}">
-        <p14:creationId xmlns:p14="http://schemas.microsoft.com/office/powerpoint/2010/main" val="2039799282"/>
+        <p14:creationId xmlns:p14="http://schemas.microsoft.com/office/powerpoint/2010/main" val="945872960"/>
       </p:ext>
     </p:extLst>
   </p:cSld>
@@ -15411,7 +15411,7 @@
           <p:cNvPr id="1" name="">
             <a:extLst xmlns:a="http://schemas.openxmlformats.org/drawingml/2006/main">
               <a:ext uri="{FF2B5EF4-FFF2-40B4-BE49-F238E27FC236}">
-                <a16:creationId xmlns:a16="http://schemas.microsoft.com/office/drawing/2014/main" id="{7272EA20-3A7E-42A1-835E-0756C130C71C}"/>
+                <a16:creationId xmlns:a16="http://schemas.microsoft.com/office/drawing/2014/main" id="{97A961B7-4A90-4987-A38D-4558412B1250}"/>
               </a:ext>
             </a:extLst>
           </p:cNvPr>
@@ -15446,7 +15446,7 @@
           <p:cNvPr id="2" name="">
             <a:extLst xmlns:a="http://schemas.openxmlformats.org/drawingml/2006/main">
               <a:ext uri="{FF2B5EF4-FFF2-40B4-BE49-F238E27FC236}">
-                <a16:creationId xmlns:a16="http://schemas.microsoft.com/office/drawing/2014/main" id="{BB850A8D-8AFC-4E41-8A1F-6C6070000BDB}"/>
+                <a16:creationId xmlns:a16="http://schemas.microsoft.com/office/drawing/2014/main" id="{AB5E16D9-D37A-46F5-9EB5-5A346280FEF9}"/>
               </a:ext>
             </a:extLst>
           </p:cNvPr>
@@ -15481,7 +15481,7 @@
           <p:cNvPr id="3" name="">
             <a:extLst xmlns:a="http://schemas.openxmlformats.org/drawingml/2006/main">
               <a:ext uri="{FF2B5EF4-FFF2-40B4-BE49-F238E27FC236}">
-                <a16:creationId xmlns:a16="http://schemas.microsoft.com/office/drawing/2014/main" id="{8856726E-ACE2-4F6F-AB15-CC7CFEF22DF2}"/>
+                <a16:creationId xmlns:a16="http://schemas.microsoft.com/office/drawing/2014/main" id="{589A0DDA-F898-4606-95F0-F69BC7FEA9E2}"/>
               </a:ext>
             </a:extLst>
           </p:cNvPr>
@@ -15545,7 +15545,7 @@
           <p:cNvPr id="4" name="">
             <a:extLst xmlns:a="http://schemas.openxmlformats.org/drawingml/2006/main">
               <a:ext uri="{FF2B5EF4-FFF2-40B4-BE49-F238E27FC236}">
-                <a16:creationId xmlns:a16="http://schemas.microsoft.com/office/drawing/2014/main" id="{BF868532-C7F6-40EB-AB89-1986F2260FB1}"/>
+                <a16:creationId xmlns:a16="http://schemas.microsoft.com/office/drawing/2014/main" id="{3C5E6EDC-044C-43CA-BD95-5E5078C8D66C}"/>
               </a:ext>
             </a:extLst>
           </p:cNvPr>
@@ -15609,7 +15609,7 @@
           <p:cNvPr id="5" name="">
             <a:extLst xmlns:a="http://schemas.openxmlformats.org/drawingml/2006/main">
               <a:ext uri="{FF2B5EF4-FFF2-40B4-BE49-F238E27FC236}">
-                <a16:creationId xmlns:a16="http://schemas.microsoft.com/office/drawing/2014/main" id="{07C9D477-B446-4B13-B30F-71A6C8BD5AC8}"/>
+                <a16:creationId xmlns:a16="http://schemas.microsoft.com/office/drawing/2014/main" id="{E349828F-A257-4C7E-B2BD-26DB330BEF9D}"/>
               </a:ext>
             </a:extLst>
           </p:cNvPr>
@@ -15663,7 +15663,7 @@
                 <a:ea typeface="Aptos"/>
                 <a:cs typeface="Aptos"/>
               </a:rPr>
-              <a:t>Sylvie voit la charge. Thomas voit les alertes. L'audit peut reconstituer les decisions. C'est la difference entre une application et un rail bancaire.</a:t>
+              <a:t>Sylvie voit la charge. Thomas voit les alertes. L'audit peut reconstituer les decisions. C'est la difference entre une application et un dispositif bancaire.</a:t>
             </a:r>
           </a:p>
         </p:txBody>
@@ -15673,7 +15673,7 @@
           <p:cNvPr id="6" name="">
             <a:extLst xmlns:a="http://schemas.openxmlformats.org/drawingml/2006/main">
               <a:ext uri="{FF2B5EF4-FFF2-40B4-BE49-F238E27FC236}">
-                <a16:creationId xmlns:a16="http://schemas.microsoft.com/office/drawing/2014/main" id="{67FC54F6-58D4-41A5-B92C-73252033F281}"/>
+                <a16:creationId xmlns:a16="http://schemas.microsoft.com/office/drawing/2014/main" id="{3A0A11CE-4CB8-4419-BEF2-6BA0E0DD90EB}"/>
               </a:ext>
             </a:extLst>
           </p:cNvPr>
@@ -15710,7 +15710,7 @@
           <p:nvPr/>
         </p:nvPicPr>
         <p:blipFill>
-          <a:blip xmlns:r="http://schemas.openxmlformats.org/officeDocument/2006/relationships" xmlns:a="http://schemas.openxmlformats.org/drawingml/2006/main" r:embed="R70df48d0e65647f7"/>
+          <a:blip xmlns:r="http://schemas.openxmlformats.org/officeDocument/2006/relationships" xmlns:a="http://schemas.openxmlformats.org/drawingml/2006/main" r:embed="R209f6acd64794910"/>
           <a:stretch xmlns:a="http://schemas.openxmlformats.org/drawingml/2006/main"/>
         </p:blipFill>
         <p:spPr>
@@ -15728,7 +15728,7 @@
           <p:cNvPr id="8" name="">
             <a:extLst xmlns:a="http://schemas.openxmlformats.org/drawingml/2006/main">
               <a:ext uri="{FF2B5EF4-FFF2-40B4-BE49-F238E27FC236}">
-                <a16:creationId xmlns:a16="http://schemas.microsoft.com/office/drawing/2014/main" id="{AAB7E421-1529-42A7-A117-2AEAFDEDBD1F}"/>
+                <a16:creationId xmlns:a16="http://schemas.microsoft.com/office/drawing/2014/main" id="{B2C3A29E-E190-4511-9C38-87A271D951CD}"/>
               </a:ext>
             </a:extLst>
           </p:cNvPr>
@@ -15765,7 +15765,7 @@
           <p:nvPr/>
         </p:nvPicPr>
         <p:blipFill>
-          <a:blip xmlns:r="http://schemas.openxmlformats.org/officeDocument/2006/relationships" xmlns:a="http://schemas.openxmlformats.org/drawingml/2006/main" r:embed="R1db16a90469e4544"/>
+          <a:blip xmlns:r="http://schemas.openxmlformats.org/officeDocument/2006/relationships" xmlns:a="http://schemas.openxmlformats.org/drawingml/2006/main" r:embed="R82318584227d444d"/>
           <a:srcRect xmlns:a="http://schemas.openxmlformats.org/drawingml/2006/main" l="0" t="3042" r="0" b="3042"/>
           <a:stretch xmlns:a="http://schemas.openxmlformats.org/drawingml/2006/main">
             <a:fillRect l="0" t="0" r="0" b="0"/>
@@ -15786,7 +15786,7 @@
           <p:cNvPr id="10" name="">
             <a:extLst xmlns:a="http://schemas.openxmlformats.org/drawingml/2006/main">
               <a:ext uri="{FF2B5EF4-FFF2-40B4-BE49-F238E27FC236}">
-                <a16:creationId xmlns:a16="http://schemas.microsoft.com/office/drawing/2014/main" id="{05D4D386-9066-4AFD-AD16-88EA3901E838}"/>
+                <a16:creationId xmlns:a16="http://schemas.microsoft.com/office/drawing/2014/main" id="{F3C4BC9B-0224-4AC4-9C14-4E5334D5B0D9}"/>
               </a:ext>
             </a:extLst>
           </p:cNvPr>
@@ -15821,7 +15821,7 @@
           <p:cNvPr id="11" name="">
             <a:extLst xmlns:a="http://schemas.openxmlformats.org/drawingml/2006/main">
               <a:ext uri="{FF2B5EF4-FFF2-40B4-BE49-F238E27FC236}">
-                <a16:creationId xmlns:a16="http://schemas.microsoft.com/office/drawing/2014/main" id="{C7C30AA1-4C91-4518-9304-E18674553502}"/>
+                <a16:creationId xmlns:a16="http://schemas.microsoft.com/office/drawing/2014/main" id="{186D3943-3014-4013-A0DD-495CA17B1818}"/>
               </a:ext>
             </a:extLst>
           </p:cNvPr>
@@ -15885,7 +15885,7 @@
           <p:cNvPr id="12" name="">
             <a:extLst xmlns:a="http://schemas.openxmlformats.org/drawingml/2006/main">
               <a:ext uri="{FF2B5EF4-FFF2-40B4-BE49-F238E27FC236}">
-                <a16:creationId xmlns:a16="http://schemas.microsoft.com/office/drawing/2014/main" id="{6F978379-A519-49A1-B167-6D2645484738}"/>
+                <a16:creationId xmlns:a16="http://schemas.microsoft.com/office/drawing/2014/main" id="{6D1B44C6-D80E-4C4E-A440-331C902C91B2}"/>
               </a:ext>
             </a:extLst>
           </p:cNvPr>
@@ -15920,7 +15920,7 @@
           <p:cNvPr id="13" name="">
             <a:extLst xmlns:a="http://schemas.openxmlformats.org/drawingml/2006/main">
               <a:ext uri="{FF2B5EF4-FFF2-40B4-BE49-F238E27FC236}">
-                <a16:creationId xmlns:a16="http://schemas.microsoft.com/office/drawing/2014/main" id="{9B81B3BC-7CC9-4A10-85AF-59A509ADBF6C}"/>
+                <a16:creationId xmlns:a16="http://schemas.microsoft.com/office/drawing/2014/main" id="{BF72460F-171B-44ED-86FA-5841D5C2A255}"/>
               </a:ext>
             </a:extLst>
           </p:cNvPr>
@@ -15984,7 +15984,7 @@
           <p:cNvPr id="14" name="">
             <a:extLst xmlns:a="http://schemas.openxmlformats.org/drawingml/2006/main">
               <a:ext uri="{FF2B5EF4-FFF2-40B4-BE49-F238E27FC236}">
-                <a16:creationId xmlns:a16="http://schemas.microsoft.com/office/drawing/2014/main" id="{BD2189DD-02C2-438E-B1DC-2A2FE343F586}"/>
+                <a16:creationId xmlns:a16="http://schemas.microsoft.com/office/drawing/2014/main" id="{0B43C2BB-B6FD-412A-8638-466A8C940C28}"/>
               </a:ext>
             </a:extLst>
           </p:cNvPr>
@@ -16019,7 +16019,7 @@
           <p:cNvPr id="15" name="">
             <a:extLst xmlns:a="http://schemas.openxmlformats.org/drawingml/2006/main">
               <a:ext uri="{FF2B5EF4-FFF2-40B4-BE49-F238E27FC236}">
-                <a16:creationId xmlns:a16="http://schemas.microsoft.com/office/drawing/2014/main" id="{8445422C-DBB5-4F9B-B22F-21E0630C4FE3}"/>
+                <a16:creationId xmlns:a16="http://schemas.microsoft.com/office/drawing/2014/main" id="{5A26901F-3958-4F94-A8CF-FD4808333F04}"/>
               </a:ext>
             </a:extLst>
           </p:cNvPr>
@@ -16083,7 +16083,7 @@
           <p:cNvPr id="16" name="">
             <a:extLst xmlns:a="http://schemas.openxmlformats.org/drawingml/2006/main">
               <a:ext uri="{FF2B5EF4-FFF2-40B4-BE49-F238E27FC236}">
-                <a16:creationId xmlns:a16="http://schemas.microsoft.com/office/drawing/2014/main" id="{8E2F855A-0DC7-4AE4-8B90-CE3DAC4D9E51}"/>
+                <a16:creationId xmlns:a16="http://schemas.microsoft.com/office/drawing/2014/main" id="{3B569D2F-8831-4CA4-8268-4422E634F1CF}"/>
               </a:ext>
             </a:extLst>
           </p:cNvPr>
@@ -16137,7 +16137,7 @@
                 <a:ea typeface="Aptos"/>
                 <a:cs typeface="Aptos"/>
               </a:rPr>
-              <a:t>Preuves internes: captures command center, analytics, audit COBAC et rapport demo.</a:t>
+              <a:t>Preuves internes: captures centre de pilotage, indicateurs, audit COBAC et rapport demo.</a:t>
             </a:r>
           </a:p>
         </p:txBody>
@@ -16147,7 +16147,7 @@
           <p:cNvPr id="17" name="">
             <a:extLst xmlns:a="http://schemas.openxmlformats.org/drawingml/2006/main">
               <a:ext uri="{FF2B5EF4-FFF2-40B4-BE49-F238E27FC236}">
-                <a16:creationId xmlns:a16="http://schemas.microsoft.com/office/drawing/2014/main" id="{8A5CB3EE-C625-4B43-A480-D86C9BA9E521}"/>
+                <a16:creationId xmlns:a16="http://schemas.microsoft.com/office/drawing/2014/main" id="{F37F4387-EEEF-4627-9C9D-46BDB9A2F0C4}"/>
               </a:ext>
             </a:extLst>
           </p:cNvPr>
@@ -16182,7 +16182,7 @@
           <p:cNvPr id="18" name="">
             <a:extLst xmlns:a="http://schemas.openxmlformats.org/drawingml/2006/main">
               <a:ext uri="{FF2B5EF4-FFF2-40B4-BE49-F238E27FC236}">
-                <a16:creationId xmlns:a16="http://schemas.microsoft.com/office/drawing/2014/main" id="{9A29C23D-58C8-4E90-8287-A615173CBCC6}"/>
+                <a16:creationId xmlns:a16="http://schemas.microsoft.com/office/drawing/2014/main" id="{4A64C253-9719-4B59-AA9B-FF0E1A5C3DBF}"/>
               </a:ext>
             </a:extLst>
           </p:cNvPr>
@@ -16236,7 +16236,7 @@
                 <a:ea typeface="Aptos"/>
                 <a:cs typeface="Aptos"/>
               </a:rPr>
-              <a:t>VeriPass - rail KYC souverain</a:t>
+              <a:t>VeriPass - connaissance client souveraine</a:t>
             </a:r>
           </a:p>
         </p:txBody>
@@ -16246,7 +16246,7 @@
           <p:cNvPr id="19" name="">
             <a:extLst xmlns:a="http://schemas.openxmlformats.org/drawingml/2006/main">
               <a:ext uri="{FF2B5EF4-FFF2-40B4-BE49-F238E27FC236}">
-                <a16:creationId xmlns:a16="http://schemas.microsoft.com/office/drawing/2014/main" id="{82E00D33-DB5E-46BC-A25B-B06F3A27450C}"/>
+                <a16:creationId xmlns:a16="http://schemas.microsoft.com/office/drawing/2014/main" id="{989A9DA8-3227-44BF-842B-B827C9F6A527}"/>
               </a:ext>
             </a:extLst>
           </p:cNvPr>
@@ -16308,7 +16308,7 @@
     </p:spTree>
     <p:extLst>
       <p:ext uri="{BB962C8B-B14F-4D97-AF65-F5344CB8AC3E}">
-        <p14:creationId xmlns:p14="http://schemas.microsoft.com/office/powerpoint/2010/main" val="1692322730"/>
+        <p14:creationId xmlns:p14="http://schemas.microsoft.com/office/powerpoint/2010/main" val="992042527"/>
       </p:ext>
     </p:extLst>
   </p:cSld>
@@ -16332,7 +16332,7 @@
           <p:cNvPr id="1" name="">
             <a:extLst xmlns:a="http://schemas.openxmlformats.org/drawingml/2006/main">
               <a:ext uri="{FF2B5EF4-FFF2-40B4-BE49-F238E27FC236}">
-                <a16:creationId xmlns:a16="http://schemas.microsoft.com/office/drawing/2014/main" id="{CD98D22A-066C-4C6F-AD9B-D83CD4D6D52B}"/>
+                <a16:creationId xmlns:a16="http://schemas.microsoft.com/office/drawing/2014/main" id="{8BFC2FC8-5FA2-47C6-9F28-DDDCFDE15515}"/>
               </a:ext>
             </a:extLst>
           </p:cNvPr>
@@ -16367,7 +16367,7 @@
           <p:cNvPr id="2" name="">
             <a:extLst xmlns:a="http://schemas.openxmlformats.org/drawingml/2006/main">
               <a:ext uri="{FF2B5EF4-FFF2-40B4-BE49-F238E27FC236}">
-                <a16:creationId xmlns:a16="http://schemas.microsoft.com/office/drawing/2014/main" id="{7469BA46-EE20-4758-98B7-5ED9A7126F13}"/>
+                <a16:creationId xmlns:a16="http://schemas.microsoft.com/office/drawing/2014/main" id="{734D393A-6E01-46E0-B97C-EF750AA54DF6}"/>
               </a:ext>
             </a:extLst>
           </p:cNvPr>
@@ -16402,7 +16402,7 @@
           <p:cNvPr id="3" name="">
             <a:extLst xmlns:a="http://schemas.openxmlformats.org/drawingml/2006/main">
               <a:ext uri="{FF2B5EF4-FFF2-40B4-BE49-F238E27FC236}">
-                <a16:creationId xmlns:a16="http://schemas.microsoft.com/office/drawing/2014/main" id="{61844934-B116-45E9-BD27-AB019BE9B59C}"/>
+                <a16:creationId xmlns:a16="http://schemas.microsoft.com/office/drawing/2014/main" id="{6099322A-D543-4516-8DC0-C76D8FE10665}"/>
               </a:ext>
             </a:extLst>
           </p:cNvPr>
@@ -16466,7 +16466,7 @@
           <p:cNvPr id="4" name="">
             <a:extLst xmlns:a="http://schemas.openxmlformats.org/drawingml/2006/main">
               <a:ext uri="{FF2B5EF4-FFF2-40B4-BE49-F238E27FC236}">
-                <a16:creationId xmlns:a16="http://schemas.microsoft.com/office/drawing/2014/main" id="{40C19B79-4F62-47CC-9BF1-6DA28C613BB4}"/>
+                <a16:creationId xmlns:a16="http://schemas.microsoft.com/office/drawing/2014/main" id="{74FF8C88-26DF-48D0-B664-8DC824CAD7F4}"/>
               </a:ext>
             </a:extLst>
           </p:cNvPr>
@@ -16530,7 +16530,7 @@
           <p:cNvPr id="5" name="">
             <a:extLst xmlns:a="http://schemas.openxmlformats.org/drawingml/2006/main">
               <a:ext uri="{FF2B5EF4-FFF2-40B4-BE49-F238E27FC236}">
-                <a16:creationId xmlns:a16="http://schemas.microsoft.com/office/drawing/2014/main" id="{896C1709-242B-454C-AE62-C378037C5E55}"/>
+                <a16:creationId xmlns:a16="http://schemas.microsoft.com/office/drawing/2014/main" id="{2EB9693D-01E7-47A2-8598-3DB4A4E1A83E}"/>
               </a:ext>
             </a:extLst>
           </p:cNvPr>
@@ -16584,7 +16584,7 @@
                 <a:ea typeface="Aptos"/>
                 <a:cs typeface="Aptos"/>
               </a:rPr>
-              <a:t>Tant que ta machine reste connectee, les responsables peuvent tester la PWA et le back-office. C'est suffisant pour une beta encadree, pas pour un deploiement cible.</a:t>
+              <a:t>Tant que ta machine reste connectee, les responsables peuvent tester l'application mobile et l'espace agents. C'est suffisant pour une phase d'essai encadree, pas pour un deploiement cible.</a:t>
             </a:r>
           </a:p>
         </p:txBody>
@@ -16594,7 +16594,7 @@
           <p:cNvPr id="6" name="">
             <a:extLst xmlns:a="http://schemas.openxmlformats.org/drawingml/2006/main">
               <a:ext uri="{FF2B5EF4-FFF2-40B4-BE49-F238E27FC236}">
-                <a16:creationId xmlns:a16="http://schemas.microsoft.com/office/drawing/2014/main" id="{183CA13B-408A-485E-B397-F433BD2CF428}"/>
+                <a16:creationId xmlns:a16="http://schemas.microsoft.com/office/drawing/2014/main" id="{D9291776-CC2B-4719-84EE-EC0A8B5C8EDE}"/>
               </a:ext>
             </a:extLst>
           </p:cNvPr>
@@ -16627,7 +16627,7 @@
           <p:cNvPr id="7" name="">
             <a:extLst xmlns:a="http://schemas.openxmlformats.org/drawingml/2006/main">
               <a:ext uri="{FF2B5EF4-FFF2-40B4-BE49-F238E27FC236}">
-                <a16:creationId xmlns:a16="http://schemas.microsoft.com/office/drawing/2014/main" id="{BFEB0044-30E5-4F94-851A-A56E615675DE}"/>
+                <a16:creationId xmlns:a16="http://schemas.microsoft.com/office/drawing/2014/main" id="{C163C545-549A-4955-95D5-D03DE19066C2}"/>
               </a:ext>
             </a:extLst>
           </p:cNvPr>
@@ -16662,7 +16662,7 @@
           <p:cNvPr id="8" name="">
             <a:extLst xmlns:a="http://schemas.openxmlformats.org/drawingml/2006/main">
               <a:ext uri="{FF2B5EF4-FFF2-40B4-BE49-F238E27FC236}">
-                <a16:creationId xmlns:a16="http://schemas.microsoft.com/office/drawing/2014/main" id="{370024D5-F794-42A1-A515-2F7D5BC013A5}"/>
+                <a16:creationId xmlns:a16="http://schemas.microsoft.com/office/drawing/2014/main" id="{ABF2F483-CDA1-4DE5-958E-588E69CD8F36}"/>
               </a:ext>
             </a:extLst>
           </p:cNvPr>
@@ -16726,7 +16726,7 @@
           <p:cNvPr id="9" name="">
             <a:extLst xmlns:a="http://schemas.openxmlformats.org/drawingml/2006/main">
               <a:ext uri="{FF2B5EF4-FFF2-40B4-BE49-F238E27FC236}">
-                <a16:creationId xmlns:a16="http://schemas.microsoft.com/office/drawing/2014/main" id="{C09D4090-605A-47FD-A2F1-8F5A46BF4FDF}"/>
+                <a16:creationId xmlns:a16="http://schemas.microsoft.com/office/drawing/2014/main" id="{C02ACC8D-29C6-4377-BA0F-92C1AC858D6B}"/>
               </a:ext>
             </a:extLst>
           </p:cNvPr>
@@ -16790,7 +16790,7 @@
           <p:cNvPr id="10" name="">
             <a:extLst xmlns:a="http://schemas.openxmlformats.org/drawingml/2006/main">
               <a:ext uri="{FF2B5EF4-FFF2-40B4-BE49-F238E27FC236}">
-                <a16:creationId xmlns:a16="http://schemas.microsoft.com/office/drawing/2014/main" id="{E4482AA1-60BF-4A5C-A6F0-146CF5F83612}"/>
+                <a16:creationId xmlns:a16="http://schemas.microsoft.com/office/drawing/2014/main" id="{091F79AE-751C-486A-A5C3-1650F346D740}"/>
               </a:ext>
             </a:extLst>
           </p:cNvPr>
@@ -16825,7 +16825,7 @@
           <p:cNvPr id="11" name="">
             <a:extLst xmlns:a="http://schemas.openxmlformats.org/drawingml/2006/main">
               <a:ext uri="{FF2B5EF4-FFF2-40B4-BE49-F238E27FC236}">
-                <a16:creationId xmlns:a16="http://schemas.microsoft.com/office/drawing/2014/main" id="{42CA0D0E-6E4A-41EE-9C58-A669157016B4}"/>
+                <a16:creationId xmlns:a16="http://schemas.microsoft.com/office/drawing/2014/main" id="{AA593D2B-8DB5-4BD1-8DF7-01EA293CB04A}"/>
               </a:ext>
             </a:extLst>
           </p:cNvPr>
@@ -16858,7 +16858,7 @@
           <p:cNvPr id="12" name="">
             <a:extLst xmlns:a="http://schemas.openxmlformats.org/drawingml/2006/main">
               <a:ext uri="{FF2B5EF4-FFF2-40B4-BE49-F238E27FC236}">
-                <a16:creationId xmlns:a16="http://schemas.microsoft.com/office/drawing/2014/main" id="{C70A5AF9-39B8-4A0B-B87C-CFD4F0CA83F1}"/>
+                <a16:creationId xmlns:a16="http://schemas.microsoft.com/office/drawing/2014/main" id="{5012E919-7A8D-4541-A392-5C60BA536B51}"/>
               </a:ext>
             </a:extLst>
           </p:cNvPr>
@@ -16893,7 +16893,7 @@
           <p:cNvPr id="13" name="">
             <a:extLst xmlns:a="http://schemas.openxmlformats.org/drawingml/2006/main">
               <a:ext uri="{FF2B5EF4-FFF2-40B4-BE49-F238E27FC236}">
-                <a16:creationId xmlns:a16="http://schemas.microsoft.com/office/drawing/2014/main" id="{EDFB3EC2-CC58-4427-B5D4-99E5B1A40CC9}"/>
+                <a16:creationId xmlns:a16="http://schemas.microsoft.com/office/drawing/2014/main" id="{360966AB-B041-47A8-A817-540B85149D51}"/>
               </a:ext>
             </a:extLst>
           </p:cNvPr>
@@ -16957,7 +16957,7 @@
           <p:cNvPr id="14" name="">
             <a:extLst xmlns:a="http://schemas.openxmlformats.org/drawingml/2006/main">
               <a:ext uri="{FF2B5EF4-FFF2-40B4-BE49-F238E27FC236}">
-                <a16:creationId xmlns:a16="http://schemas.microsoft.com/office/drawing/2014/main" id="{DE759B19-A73C-4868-A948-E6B6E9720DD2}"/>
+                <a16:creationId xmlns:a16="http://schemas.microsoft.com/office/drawing/2014/main" id="{E06139F4-96F2-47D4-B9A9-C312E742FE80}"/>
               </a:ext>
             </a:extLst>
           </p:cNvPr>
@@ -17021,7 +17021,7 @@
           <p:cNvPr id="15" name="">
             <a:extLst xmlns:a="http://schemas.openxmlformats.org/drawingml/2006/main">
               <a:ext uri="{FF2B5EF4-FFF2-40B4-BE49-F238E27FC236}">
-                <a16:creationId xmlns:a16="http://schemas.microsoft.com/office/drawing/2014/main" id="{525E46D0-7B37-4A42-90ED-91390666F113}"/>
+                <a16:creationId xmlns:a16="http://schemas.microsoft.com/office/drawing/2014/main" id="{13DE8A85-32A1-4E8F-94B9-22DDC1C1C4F6}"/>
               </a:ext>
             </a:extLst>
           </p:cNvPr>
@@ -17056,7 +17056,7 @@
           <p:cNvPr id="16" name="">
             <a:extLst xmlns:a="http://schemas.openxmlformats.org/drawingml/2006/main">
               <a:ext uri="{FF2B5EF4-FFF2-40B4-BE49-F238E27FC236}">
-                <a16:creationId xmlns:a16="http://schemas.microsoft.com/office/drawing/2014/main" id="{4A1DAB82-2DBE-4A38-924A-2A52B2DA6FFC}"/>
+                <a16:creationId xmlns:a16="http://schemas.microsoft.com/office/drawing/2014/main" id="{328E464B-676F-46A2-AA06-A75FCB6477F3}"/>
               </a:ext>
             </a:extLst>
           </p:cNvPr>
@@ -17089,7 +17089,7 @@
           <p:cNvPr id="17" name="">
             <a:extLst xmlns:a="http://schemas.openxmlformats.org/drawingml/2006/main">
               <a:ext uri="{FF2B5EF4-FFF2-40B4-BE49-F238E27FC236}">
-                <a16:creationId xmlns:a16="http://schemas.microsoft.com/office/drawing/2014/main" id="{7AC877EA-E761-496E-82A3-4217D4846618}"/>
+                <a16:creationId xmlns:a16="http://schemas.microsoft.com/office/drawing/2014/main" id="{D614DADC-07D9-4A2A-B39E-66C47697D93E}"/>
               </a:ext>
             </a:extLst>
           </p:cNvPr>
@@ -17124,7 +17124,7 @@
           <p:cNvPr id="18" name="">
             <a:extLst xmlns:a="http://schemas.openxmlformats.org/drawingml/2006/main">
               <a:ext uri="{FF2B5EF4-FFF2-40B4-BE49-F238E27FC236}">
-                <a16:creationId xmlns:a16="http://schemas.microsoft.com/office/drawing/2014/main" id="{82D1A97A-1315-40F5-B376-ABE964059405}"/>
+                <a16:creationId xmlns:a16="http://schemas.microsoft.com/office/drawing/2014/main" id="{B5975822-0052-4B3A-A100-15FAC164BB1D}"/>
               </a:ext>
             </a:extLst>
           </p:cNvPr>
@@ -17178,7 +17178,7 @@
                 <a:ea typeface="Aptos Display"/>
                 <a:cs typeface="Aptos Display"/>
               </a:rPr>
-              <a:t>MVP VeriPass</a:t>
+              <a:t>Version VeriPass</a:t>
             </a:r>
           </a:p>
         </p:txBody>
@@ -17188,7 +17188,7 @@
           <p:cNvPr id="19" name="">
             <a:extLst xmlns:a="http://schemas.openxmlformats.org/drawingml/2006/main">
               <a:ext uri="{FF2B5EF4-FFF2-40B4-BE49-F238E27FC236}">
-                <a16:creationId xmlns:a16="http://schemas.microsoft.com/office/drawing/2014/main" id="{6F1478FF-721E-427B-8E88-D0D2F60A31A3}"/>
+                <a16:creationId xmlns:a16="http://schemas.microsoft.com/office/drawing/2014/main" id="{AC7AD742-684D-448F-A217-629D9A485107}"/>
               </a:ext>
             </a:extLst>
           </p:cNvPr>
@@ -17242,7 +17242,7 @@
                 <a:ea typeface="Aptos"/>
                 <a:cs typeface="Aptos"/>
               </a:rPr>
-              <a:t>mobile + back-office</a:t>
+              <a:t>mobile + espace agents</a:t>
             </a:r>
           </a:p>
         </p:txBody>
@@ -17252,7 +17252,7 @@
           <p:cNvPr id="20" name="">
             <a:extLst xmlns:a="http://schemas.openxmlformats.org/drawingml/2006/main">
               <a:ext uri="{FF2B5EF4-FFF2-40B4-BE49-F238E27FC236}">
-                <a16:creationId xmlns:a16="http://schemas.microsoft.com/office/drawing/2014/main" id="{3EDE739F-E88A-4C9C-96F0-57E239BEC189}"/>
+                <a16:creationId xmlns:a16="http://schemas.microsoft.com/office/drawing/2014/main" id="{2DBF7B2D-ABBD-4C0E-A729-3C617E904CB4}"/>
               </a:ext>
             </a:extLst>
           </p:cNvPr>
@@ -17287,7 +17287,7 @@
           <p:cNvPr id="21" name="">
             <a:extLst xmlns:a="http://schemas.openxmlformats.org/drawingml/2006/main">
               <a:ext uri="{FF2B5EF4-FFF2-40B4-BE49-F238E27FC236}">
-                <a16:creationId xmlns:a16="http://schemas.microsoft.com/office/drawing/2014/main" id="{40070CE4-E943-4344-9F78-49D0EDBFA2FE}"/>
+                <a16:creationId xmlns:a16="http://schemas.microsoft.com/office/drawing/2014/main" id="{733BBB20-85BD-40B8-AF64-15E9DA52F9CA}"/>
               </a:ext>
             </a:extLst>
           </p:cNvPr>
@@ -17320,7 +17320,7 @@
           <p:cNvPr id="22" name="">
             <a:extLst xmlns:a="http://schemas.openxmlformats.org/drawingml/2006/main">
               <a:ext uri="{FF2B5EF4-FFF2-40B4-BE49-F238E27FC236}">
-                <a16:creationId xmlns:a16="http://schemas.microsoft.com/office/drawing/2014/main" id="{3ED1DC39-3962-4AF9-8023-72B9ED79676E}"/>
+                <a16:creationId xmlns:a16="http://schemas.microsoft.com/office/drawing/2014/main" id="{2D92260D-CA46-43AC-AC4D-34166AFD99D5}"/>
               </a:ext>
             </a:extLst>
           </p:cNvPr>
@@ -17355,7 +17355,7 @@
           <p:cNvPr id="23" name="">
             <a:extLst xmlns:a="http://schemas.openxmlformats.org/drawingml/2006/main">
               <a:ext uri="{FF2B5EF4-FFF2-40B4-BE49-F238E27FC236}">
-                <a16:creationId xmlns:a16="http://schemas.microsoft.com/office/drawing/2014/main" id="{489C0F63-5D55-4954-B59D-9E74762DBF6F}"/>
+                <a16:creationId xmlns:a16="http://schemas.microsoft.com/office/drawing/2014/main" id="{8FB7654B-9A3E-4E58-9D66-24A1C71E4B01}"/>
               </a:ext>
             </a:extLst>
           </p:cNvPr>
@@ -17419,7 +17419,7 @@
           <p:cNvPr id="24" name="">
             <a:extLst xmlns:a="http://schemas.openxmlformats.org/drawingml/2006/main">
               <a:ext uri="{FF2B5EF4-FFF2-40B4-BE49-F238E27FC236}">
-                <a16:creationId xmlns:a16="http://schemas.microsoft.com/office/drawing/2014/main" id="{1B23426C-551E-4FF9-AA6B-D886835AB090}"/>
+                <a16:creationId xmlns:a16="http://schemas.microsoft.com/office/drawing/2014/main" id="{8A969CDF-EEB0-42D9-BC1B-9FBC507412E4}"/>
               </a:ext>
             </a:extLst>
           </p:cNvPr>
@@ -17473,7 +17473,7 @@
                 <a:ea typeface="Aptos"/>
                 <a:cs typeface="Aptos"/>
               </a:rPr>
-              <a:t>risques, parcours, KPI</a:t>
+              <a:t>risques, parcours, indicateurs</a:t>
             </a:r>
           </a:p>
         </p:txBody>
@@ -17483,7 +17483,7 @@
           <p:cNvPr id="25" name="">
             <a:extLst xmlns:a="http://schemas.openxmlformats.org/drawingml/2006/main">
               <a:ext uri="{FF2B5EF4-FFF2-40B4-BE49-F238E27FC236}">
-                <a16:creationId xmlns:a16="http://schemas.microsoft.com/office/drawing/2014/main" id="{94B0F128-DD26-462B-9529-EF969DEDFD3D}"/>
+                <a16:creationId xmlns:a16="http://schemas.microsoft.com/office/drawing/2014/main" id="{2E8E2749-B837-4110-9BA9-DABDC60F5C8B}"/>
               </a:ext>
             </a:extLst>
           </p:cNvPr>
@@ -17518,7 +17518,7 @@
           <p:cNvPr id="26" name="">
             <a:extLst xmlns:a="http://schemas.openxmlformats.org/drawingml/2006/main">
               <a:ext uri="{FF2B5EF4-FFF2-40B4-BE49-F238E27FC236}">
-                <a16:creationId xmlns:a16="http://schemas.microsoft.com/office/drawing/2014/main" id="{9787BC25-C3C9-46F4-B868-D01738822CCD}"/>
+                <a16:creationId xmlns:a16="http://schemas.microsoft.com/office/drawing/2014/main" id="{5340B70B-EF45-432F-B427-E1ED3D4A0291}"/>
               </a:ext>
             </a:extLst>
           </p:cNvPr>
@@ -17582,7 +17582,7 @@
           <p:cNvPr id="27" name="">
             <a:extLst xmlns:a="http://schemas.openxmlformats.org/drawingml/2006/main">
               <a:ext uri="{FF2B5EF4-FFF2-40B4-BE49-F238E27FC236}">
-                <a16:creationId xmlns:a16="http://schemas.microsoft.com/office/drawing/2014/main" id="{46D7E04A-25FC-42A1-B287-2B9CA788377C}"/>
+                <a16:creationId xmlns:a16="http://schemas.microsoft.com/office/drawing/2014/main" id="{5E6C120E-4243-47D3-A612-E894E72BDB3C}"/>
               </a:ext>
             </a:extLst>
           </p:cNvPr>
@@ -17617,7 +17617,7 @@
           <p:cNvPr id="28" name="">
             <a:extLst xmlns:a="http://schemas.openxmlformats.org/drawingml/2006/main">
               <a:ext uri="{FF2B5EF4-FFF2-40B4-BE49-F238E27FC236}">
-                <a16:creationId xmlns:a16="http://schemas.microsoft.com/office/drawing/2014/main" id="{3B86A67F-1C2E-4423-A6F9-1122DAFBDA3C}"/>
+                <a16:creationId xmlns:a16="http://schemas.microsoft.com/office/drawing/2014/main" id="{B5A0E910-78AA-4EB2-B4EA-A910F0AB3866}"/>
               </a:ext>
             </a:extLst>
           </p:cNvPr>
@@ -17671,7 +17671,7 @@
                 <a:ea typeface="Aptos"/>
                 <a:cs typeface="Aptos"/>
               </a:rPr>
-              <a:t>VeriPass - rail KYC souverain</a:t>
+              <a:t>VeriPass - connaissance client souveraine</a:t>
             </a:r>
           </a:p>
         </p:txBody>
@@ -17681,7 +17681,7 @@
           <p:cNvPr id="29" name="">
             <a:extLst xmlns:a="http://schemas.openxmlformats.org/drawingml/2006/main">
               <a:ext uri="{FF2B5EF4-FFF2-40B4-BE49-F238E27FC236}">
-                <a16:creationId xmlns:a16="http://schemas.microsoft.com/office/drawing/2014/main" id="{0FB2E6BB-9F1D-401F-9D6A-B3BF31D40098}"/>
+                <a16:creationId xmlns:a16="http://schemas.microsoft.com/office/drawing/2014/main" id="{499E730E-EB13-4CA3-B31F-489A1FBF4540}"/>
               </a:ext>
             </a:extLst>
           </p:cNvPr>
@@ -17743,7 +17743,7 @@
     </p:spTree>
     <p:extLst>
       <p:ext uri="{BB962C8B-B14F-4D97-AF65-F5344CB8AC3E}">
-        <p14:creationId xmlns:p14="http://schemas.microsoft.com/office/powerpoint/2010/main" val="610493042"/>
+        <p14:creationId xmlns:p14="http://schemas.microsoft.com/office/powerpoint/2010/main" val="1034922621"/>
       </p:ext>
     </p:extLst>
   </p:cSld>

</xml_diff>